<commit_message>
Redesign presentation deck: slide numbers, business question slide, numbered hypotheses, takeaway-first layout, zip bubble charts on recommendation slides, consistent chart colors, accessibility fix, larger fonts, Final Recommendations recap
</commit_message>
<xml_diff>
--- a/presentation.pptx
+++ b/presentation.pptx
@@ -15,9 +15,11 @@
     <p:sldId id="263" r:id="rId9"/>
     <p:sldId id="264" r:id="rId10"/>
     <p:sldId id="265" r:id="rId11"/>
+    <p:sldId id="266" r:id="rId12"/>
+    <p:sldId id="267" r:id="rId13"/>
   </p:sldIdLst>
   <p:notesMasterIdLst>
-    <p:notesMasterId r:id="rId12"/>
+    <p:notesMasterId r:id="rId14"/>
   </p:notesMasterIdLst>
   <p:sldSz cx="12192000" cy="6858000"/>
   <p:notesSz cx="6858000" cy="12192000"/>
@@ -683,7 +685,7 @@
           </c:tx>
           <c:spPr>
             <a:solidFill>
-              <a:srgbClr val="1E2761"/>
+              <a:srgbClr val="2C5F2D"/>
             </a:solidFill>
             <a:effectLst/>
           </c:spPr>
@@ -859,7 +861,7 @@
           <a:lstStyle/>
           <a:p>
             <a:pPr>
-              <a:defRPr sz="1100" b="0" i="0" u="none" strike="noStrike">
+              <a:defRPr sz="1300" b="0" i="0" u="none" strike="noStrike">
                 <a:solidFill>
                   <a:srgbClr val="262626"/>
                 </a:solidFill>
@@ -911,7 +913,7 @@
           <a:lstStyle/>
           <a:p>
             <a:pPr>
-              <a:defRPr sz="1000" b="0" i="0" u="none" strike="noStrike">
+              <a:defRPr sz="1200" b="0" i="0" u="none" strike="noStrike">
                 <a:solidFill>
                   <a:srgbClr val="6B6B6B"/>
                 </a:solidFill>
@@ -1434,7 +1436,7 @@
           <a:p>
             <a:r>
               <a:rPr lang="en-US" dirty="0"/>
-              <a:t>The country home purchase comes down to a simple trade-off: August for the lowest median price, or May for about 18% more listings at only a modest premium. That's the full picture — happy to open it up for questions.</a:t>
+              <a:t>For the country home, zip codes 98010 and 98014 stand out: genuinely large-lot areas more than 30 kilometers from downtown, where 68 to 85 percent of homes qualify as large-lot versus a 25 percent cutoff countywide, with affordable medians of $360,000 and $415,000. Non-renovated listings are both the norm and the better deal here.</a:t>
             </a:r>
             <a:endParaRPr lang="en-US" dirty="0"/>
           </a:p>
@@ -1458,6 +1460,182 @@
             <a:fld id="{F7021451-1387-4CA6-816F-3879F97B5CBC}" type="slidenum">
               <a:rPr lang="en-US"/>
               <a:t>10</a:t>
+            </a:fld>
+            <a:endParaRPr lang="en-US"/>
+          </a:p>
+        </p:txBody>
+      </p:sp>
+    </p:spTree>
+    <p:extLst>
+      <p:ext uri="{BB962C8B-B14F-4D97-AF65-F5344CB8AC3E}">
+        <p14:creationId xmlns:p14="http://schemas.microsoft.com/office/powerpoint/2010/main" val="1024086991"/>
+      </p:ext>
+    </p:extLst>
+  </p:cSld>
+  <p:clrMapOvr>
+    <a:masterClrMapping/>
+  </p:clrMapOvr>
+</p:notes>
+</file>
+
+<file path=ppt/notesSlides/notesSlide11.xml><?xml version="1.0" encoding="utf-8"?>
+<p:notes xmlns:a="http://schemas.openxmlformats.org/drawingml/2006/main" xmlns:r="http://schemas.openxmlformats.org/officeDocument/2006/relationships" xmlns:p="http://schemas.openxmlformats.org/presentationml/2006/main">
+  <p:cSld>
+    <p:spTree>
+      <p:nvGrpSpPr>
+        <p:cNvPr id="1" name=""/>
+        <p:cNvGrpSpPr/>
+        <p:nvPr/>
+      </p:nvGrpSpPr>
+      <p:grpSpPr>
+        <a:xfrm>
+          <a:off x="0" y="0"/>
+          <a:ext cx="0" cy="0"/>
+          <a:chOff x="0" y="0"/>
+          <a:chExt cx="0" cy="0"/>
+        </a:xfrm>
+      </p:grpSpPr>
+      <p:sp>
+        <p:nvSpPr>
+          <p:cNvPr id="2" name="Slide Image Placeholder 1"/>
+          <p:cNvSpPr>
+            <a:spLocks noGrp="1" noRot="1" noChangeAspect="1"/>
+          </p:cNvSpPr>
+          <p:nvPr>
+            <p:ph type="sldImg"/>
+          </p:nvPr>
+        </p:nvSpPr>
+        <p:spPr/>
+      </p:sp>
+      <p:sp>
+        <p:nvSpPr>
+          <p:cNvPr id="3" name="Notes Placeholder 2"/>
+          <p:cNvSpPr>
+            <a:spLocks noGrp="1"/>
+          </p:cNvSpPr>
+          <p:nvPr>
+            <p:ph type="body" idx="1"/>
+          </p:nvPr>
+        </p:nvSpPr>
+        <p:spPr/>
+        <p:txBody>
+          <a:bodyPr/>
+          <a:lstStyle/>
+          <a:p>
+            <a:r>
+              <a:rPr lang="en-US" dirty="0"/>
+              <a:t>To recap: city home in zip 98118 filtered to 1-3 bedrooms, country home in zip 98010 or 98014 leaning non-renovated, and if timing matters for the country search, August for the lowest price or May for more inventory at a small premium.</a:t>
+            </a:r>
+            <a:endParaRPr lang="en-US" dirty="0"/>
+          </a:p>
+        </p:txBody>
+      </p:sp>
+      <p:sp>
+        <p:nvSpPr>
+          <p:cNvPr id="4" name="Slide Number Placeholder 3"/>
+          <p:cNvSpPr>
+            <a:spLocks noGrp="1"/>
+          </p:cNvSpPr>
+          <p:nvPr>
+            <p:ph type="sldNum" sz="quarter" idx="10"/>
+          </p:nvPr>
+        </p:nvSpPr>
+        <p:spPr/>
+        <p:txBody>
+          <a:bodyPr/>
+          <a:lstStyle/>
+          <a:p>
+            <a:fld id="{F7021451-1387-4CA6-816F-3879F97B5CBC}" type="slidenum">
+              <a:rPr lang="en-US"/>
+              <a:t>11</a:t>
+            </a:fld>
+            <a:endParaRPr lang="en-US"/>
+          </a:p>
+        </p:txBody>
+      </p:sp>
+    </p:spTree>
+    <p:extLst>
+      <p:ext uri="{BB962C8B-B14F-4D97-AF65-F5344CB8AC3E}">
+        <p14:creationId xmlns:p14="http://schemas.microsoft.com/office/powerpoint/2010/main" val="1024086991"/>
+      </p:ext>
+    </p:extLst>
+  </p:cSld>
+  <p:clrMapOvr>
+    <a:masterClrMapping/>
+  </p:clrMapOvr>
+</p:notes>
+</file>
+
+<file path=ppt/notesSlides/notesSlide12.xml><?xml version="1.0" encoding="utf-8"?>
+<p:notes xmlns:a="http://schemas.openxmlformats.org/drawingml/2006/main" xmlns:r="http://schemas.openxmlformats.org/officeDocument/2006/relationships" xmlns:p="http://schemas.openxmlformats.org/presentationml/2006/main">
+  <p:cSld>
+    <p:spTree>
+      <p:nvGrpSpPr>
+        <p:cNvPr id="1" name=""/>
+        <p:cNvGrpSpPr/>
+        <p:nvPr/>
+      </p:nvGrpSpPr>
+      <p:grpSpPr>
+        <a:xfrm>
+          <a:off x="0" y="0"/>
+          <a:ext cx="0" cy="0"/>
+          <a:chOff x="0" y="0"/>
+          <a:chExt cx="0" cy="0"/>
+        </a:xfrm>
+      </p:grpSpPr>
+      <p:sp>
+        <p:nvSpPr>
+          <p:cNvPr id="2" name="Slide Image Placeholder 1"/>
+          <p:cNvSpPr>
+            <a:spLocks noGrp="1" noRot="1" noChangeAspect="1"/>
+          </p:cNvSpPr>
+          <p:nvPr>
+            <p:ph type="sldImg"/>
+          </p:nvPr>
+        </p:nvSpPr>
+        <p:spPr/>
+      </p:sp>
+      <p:sp>
+        <p:nvSpPr>
+          <p:cNvPr id="3" name="Notes Placeholder 2"/>
+          <p:cNvSpPr>
+            <a:spLocks noGrp="1"/>
+          </p:cNvSpPr>
+          <p:nvPr>
+            <p:ph type="body" idx="1"/>
+          </p:nvPr>
+        </p:nvSpPr>
+        <p:spPr/>
+        <p:txBody>
+          <a:bodyPr/>
+          <a:lstStyle/>
+          <a:p>
+            <a:r>
+              <a:rPr lang="en-US" dirty="0"/>
+              <a:t>That's the full picture — happy to open it up for questions.</a:t>
+            </a:r>
+            <a:endParaRPr lang="en-US" dirty="0"/>
+          </a:p>
+        </p:txBody>
+      </p:sp>
+      <p:sp>
+        <p:nvSpPr>
+          <p:cNvPr id="4" name="Slide Number Placeholder 3"/>
+          <p:cNvSpPr>
+            <a:spLocks noGrp="1"/>
+          </p:cNvSpPr>
+          <p:nvPr>
+            <p:ph type="sldNum" sz="quarter" idx="10"/>
+          </p:nvPr>
+        </p:nvSpPr>
+        <p:spPr/>
+        <p:txBody>
+          <a:bodyPr/>
+          <a:lstStyle/>
+          <a:p>
+            <a:fld id="{F7021451-1387-4CA6-816F-3879F97B5CBC}" type="slidenum">
+              <a:rPr lang="en-US"/>
+              <a:t>12</a:t>
             </a:fld>
             <a:endParaRPr lang="en-US"/>
           </a:p>
@@ -1610,7 +1788,7 @@
           <a:p>
             <a:r>
               <a:rPr lang="en-US" dirty="0"/>
-              <a:t>We're working with a full year of King County home sales, just over 21,500 transactions, joined to the county's property detail records so we know size, condition, location, and renovation history for every sale.</a:t>
+              <a:t>This is the business question behind the whole analysis: what actually drives home prices in King County. We break it into three specific, testable hypotheses next, then answer each one for William's two searches specifically.</a:t>
             </a:r>
             <a:endParaRPr lang="en-US" dirty="0"/>
           </a:p>
@@ -1698,7 +1876,7 @@
           <a:p>
             <a:r>
               <a:rPr lang="en-US" dirty="0"/>
-              <a:t>Three research questions guided the analysis: does where a home sits drive its price, does renovation status change what buyers pay, and is there a seasonal pattern that points to a better or worse time to buy.</a:t>
+              <a:t>We're working with a full year of King County home sales, just over 21,500 transactions, joined to the county's property detail records so we know size, condition, location, and renovation history for every sale.</a:t>
             </a:r>
             <a:endParaRPr lang="en-US" dirty="0"/>
           </a:p>
@@ -1786,7 +1964,7 @@
           <a:p>
             <a:r>
               <a:rPr lang="en-US" dirty="0"/>
-              <a:t>Homes in the closest quarter of the market to downtown Seattle sell for a median $345 per square foot, versus $220 for the rest of the county — a 57 percent premium. Large-lot homes don't sell for less in total, but they are cheaper per square foot, since more of the price is land rather than house.</a:t>
+              <a:t>Three research questions guided the analysis: does where a home sits drive its price, does renovation status change what buyers pay, and is there a seasonal pattern that points to a better or worse time to buy.</a:t>
             </a:r>
             <a:endParaRPr lang="en-US" dirty="0"/>
           </a:p>
@@ -1874,7 +2052,7 @@
           <a:p>
             <a:r>
               <a:rPr lang="en-US" dirty="0"/>
-              <a:t>Among large-lot properties, renovated homes have a median price of $712,500 versus $530,000 for non-renovated ones, a 34 percent premium. Ninety-seven percent of homes countywide have no renovation on record, so non-renovated is both the typical listing and the cheaper one — good news given the client's preference.</a:t>
+              <a:t>Homes in the closest quarter of the market to downtown Seattle sell for a median $345 per square foot, versus $220 for the rest of the county — a 57 percent premium. Large-lot homes don't sell for less in total, but they are cheaper per square foot, since more of the price is land rather than house.</a:t>
             </a:r>
             <a:endParaRPr lang="en-US" dirty="0"/>
           </a:p>
@@ -1962,7 +2140,7 @@
           <a:p>
             <a:r>
               <a:rPr lang="en-US" dirty="0"/>
-              <a:t>For country homes specifically, median price is lowest in August and highest in April, while sales volume is lowest in January and peaks in May. City homes actually follow a different pattern — their median price is lowest in November and highest in March — so the two searches shouldn't be timed the same way. Since timing matters most for the country home, August is the window we recommend targeting.</a:t>
+              <a:t>Among large-lot properties, renovated homes have a median price of $712,500 versus $530,000 for non-renovated ones, a 34 percent premium. Ninety-seven percent of homes countywide have no renovation on record, so non-renovated is both the typical listing and the cheaper one — good news given the client's preference.</a:t>
             </a:r>
             <a:endParaRPr lang="en-US" dirty="0"/>
           </a:p>
@@ -2050,7 +2228,7 @@
           <a:p>
             <a:r>
               <a:rPr lang="en-US" dirty="0"/>
-              <a:t>For the city home, zip code 98118 is the closest high-turnover zip to downtown at 7.9 kilometers, with the most sales activity among affordable central zips — 507 sales in the window — and the lowest median price of that group at $367,500. 98103, 98115, and 98117 are close backups. Worth noting too: since this is a household of 2, sticking to 1 to 3 bedroom listings covers 59 percent of the market and avoids paying a roughly 41 percent premium for bedrooms that won't get used.</a:t>
+              <a:t>For country homes specifically, median price is lowest in August and highest in April, while sales volume is lowest in January and peaks in May. City homes actually follow a different pattern — their median price is lowest in November and highest in March — so the two searches shouldn't be timed the same way. Since timing matters most for the country home, August is the window we recommend targeting.</a:t>
             </a:r>
             <a:endParaRPr lang="en-US" dirty="0"/>
           </a:p>
@@ -2138,7 +2316,7 @@
           <a:p>
             <a:r>
               <a:rPr lang="en-US" dirty="0"/>
-              <a:t>For the country home, zip codes 98010 and 98014 stand out: genuinely large-lot areas more than 30 kilometers from downtown, where 68 to 85 percent of homes qualify as large-lot versus a 25 percent cutoff countywide, with affordable medians of $360,000 and $415,000. Non-renovated listings are both the norm and the better deal here.</a:t>
+              <a:t>For the city home, zip code 98118 is the closest high-turnover zip to downtown at 7.9 kilometers, with the most sales activity among affordable central zips — 507 sales in the window — and the lowest median price of that group at $367,500. 98103, 98115, and 98117 are close backups. Worth noting too: since this is a household of 2, sticking to 1 to 3 bedroom listings covers 59 percent of the market and avoids paying a roughly 41 percent premium for bedrooms that won't get used.</a:t>
             </a:r>
             <a:endParaRPr lang="en-US" dirty="0"/>
           </a:p>
@@ -2695,6 +2873,45 @@
           </a:prstGeom>
         </p:spPr>
       </p:pic>
+      <p:sp>
+        <p:nvSpPr>
+          <p:cNvPr id="7" name="Text 4"/>
+          <p:cNvSpPr/>
+          <p:nvPr/>
+        </p:nvSpPr>
+        <p:spPr>
+          <a:xfrm>
+            <a:off x="11292840" y="6510528"/>
+            <a:ext cx="777240" cy="274320"/>
+          </a:xfrm>
+          <a:prstGeom prst="rect">
+            <a:avLst/>
+          </a:prstGeom>
+          <a:noFill/>
+          <a:ln/>
+        </p:spPr>
+        <p:txBody>
+          <a:bodyPr wrap="square" lIns="0" tIns="0" rIns="0" bIns="0" rtlCol="0" anchor="ctr"/>
+          <a:lstStyle/>
+          <a:p>
+            <a:pPr algn="r" indent="0" marL="0">
+              <a:buNone/>
+            </a:pPr>
+            <a:r>
+              <a:rPr lang="en-US" sz="1000" dirty="0">
+                <a:solidFill>
+                  <a:srgbClr val="CADCFC"/>
+                </a:solidFill>
+                <a:latin typeface="Calibri" pitchFamily="34" charset="0"/>
+                <a:ea typeface="Calibri" pitchFamily="34" charset="-122"/>
+                <a:cs typeface="Calibri" pitchFamily="34" charset="-120"/>
+              </a:rPr>
+              <a:t>1 / 12</a:t>
+            </a:r>
+            <a:endParaRPr lang="en-US" sz="1000" dirty="0"/>
+          </a:p>
+        </p:txBody>
+      </p:sp>
     </p:spTree>
   </p:cSld>
   <p:clrMapOvr>
@@ -2706,6 +2923,646 @@
 <file path=ppt/slides/slide10.xml><?xml version="1.0" encoding="utf-8"?>
 <p:sld xmlns:a="http://schemas.openxmlformats.org/drawingml/2006/main" xmlns:r="http://schemas.openxmlformats.org/officeDocument/2006/relationships" xmlns:p="http://schemas.openxmlformats.org/presentationml/2006/main">
   <p:cSld name="Slide 10">
+    <p:bg>
+      <p:bgPr>
+        <a:solidFill>
+          <a:srgbClr val="2C5F2D"/>
+        </a:solidFill>
+      </p:bgPr>
+    </p:bg>
+    <p:spTree>
+      <p:nvGrpSpPr>
+        <p:cNvPr id="1" name=""/>
+        <p:cNvGrpSpPr/>
+        <p:nvPr/>
+      </p:nvGrpSpPr>
+      <p:grpSpPr>
+        <a:xfrm>
+          <a:off x="0" y="0"/>
+          <a:ext cx="0" cy="0"/>
+          <a:chOff x="0" y="0"/>
+          <a:chExt cx="0" cy="0"/>
+        </a:xfrm>
+      </p:grpSpPr>
+      <p:sp>
+        <p:nvSpPr>
+          <p:cNvPr id="2" name="Shape 0"/>
+          <p:cNvSpPr/>
+          <p:nvPr/>
+        </p:nvSpPr>
+        <p:spPr>
+          <a:xfrm>
+            <a:off x="731520" y="457200"/>
+            <a:ext cx="914400" cy="914400"/>
+          </a:xfrm>
+          <a:prstGeom prst="ellipse">
+            <a:avLst/>
+          </a:prstGeom>
+          <a:solidFill>
+            <a:srgbClr val="1E4620"/>
+          </a:solidFill>
+          <a:ln/>
+        </p:spPr>
+      </p:sp>
+      <p:pic>
+        <p:nvPicPr>
+          <p:cNvPr id="3" name="Image 0" descr="preencoded.png">    </p:cNvPr>
+          <p:cNvPicPr>
+            <a:picLocks noChangeAspect="1"/>
+          </p:cNvPicPr>
+          <p:nvPr/>
+        </p:nvPicPr>
+        <p:blipFill>
+          <a:blip r:embed="rId1"/>
+          <a:stretch>
+            <a:fillRect/>
+          </a:stretch>
+        </p:blipFill>
+        <p:spPr>
+          <a:xfrm>
+            <a:off x="969264" y="694944"/>
+            <a:ext cx="438912" cy="438912"/>
+          </a:xfrm>
+          <a:prstGeom prst="rect">
+            <a:avLst/>
+          </a:prstGeom>
+        </p:spPr>
+      </p:pic>
+      <p:sp>
+        <p:nvSpPr>
+          <p:cNvPr id="4" name="Text 1"/>
+          <p:cNvSpPr/>
+          <p:nvPr/>
+        </p:nvSpPr>
+        <p:spPr>
+          <a:xfrm>
+            <a:off x="1828800" y="438912"/>
+            <a:ext cx="9509760" cy="777240"/>
+          </a:xfrm>
+          <a:prstGeom prst="rect">
+            <a:avLst/>
+          </a:prstGeom>
+          <a:noFill/>
+          <a:ln/>
+        </p:spPr>
+        <p:txBody>
+          <a:bodyPr wrap="square" lIns="0" tIns="0" rIns="0" bIns="0" rtlCol="0" anchor="ctr"/>
+          <a:lstStyle/>
+          <a:p>
+            <a:pPr indent="0" marL="0">
+              <a:buNone/>
+            </a:pPr>
+            <a:r>
+              <a:rPr lang="en-US" sz="2600" b="1" dirty="0">
+                <a:solidFill>
+                  <a:srgbClr val="FFFFFF"/>
+                </a:solidFill>
+                <a:latin typeface="Cambria" pitchFamily="34" charset="0"/>
+                <a:ea typeface="Cambria" pitchFamily="34" charset="-122"/>
+                <a:cs typeface="Cambria" pitchFamily="34" charset="-120"/>
+              </a:rPr>
+              <a:t>For the Country Home  →  Zip 98010 or 98014</a:t>
+            </a:r>
+            <a:endParaRPr lang="en-US" sz="2600" dirty="0"/>
+          </a:p>
+        </p:txBody>
+      </p:sp>
+      <p:sp>
+        <p:nvSpPr>
+          <p:cNvPr id="5" name="Text 2"/>
+          <p:cNvSpPr/>
+          <p:nvPr/>
+        </p:nvSpPr>
+        <p:spPr>
+          <a:xfrm>
+            <a:off x="640080" y="1280160"/>
+            <a:ext cx="10881360" cy="548640"/>
+          </a:xfrm>
+          <a:prstGeom prst="rect">
+            <a:avLst/>
+          </a:prstGeom>
+          <a:noFill/>
+          <a:ln/>
+        </p:spPr>
+        <p:txBody>
+          <a:bodyPr wrap="square" lIns="0" tIns="0" rIns="0" bIns="0" rtlCol="0" anchor="ctr"/>
+          <a:lstStyle/>
+          <a:p>
+            <a:pPr indent="0" marL="0">
+              <a:lnSpc>
+                <a:spcPct val="105000"/>
+              </a:lnSpc>
+              <a:buNone/>
+            </a:pPr>
+            <a:r>
+              <a:rPr lang="en-US" sz="1600" b="1" dirty="0">
+                <a:solidFill>
+                  <a:srgbClr val="FFFFFF"/>
+                </a:solidFill>
+                <a:latin typeface="Calibri" pitchFamily="34" charset="0"/>
+                <a:ea typeface="Calibri" pitchFamily="34" charset="-122"/>
+                <a:cs typeface="Calibri" pitchFamily="34" charset="-120"/>
+              </a:rPr>
+              <a:t>BOTTOM LINE:  </a:t>
+            </a:r>
+            <a:pPr indent="0" marL="0">
+              <a:lnSpc>
+                <a:spcPct val="105000"/>
+              </a:lnSpc>
+              <a:buNone/>
+            </a:pPr>
+            <a:r>
+              <a:rPr lang="en-US" sz="1600" dirty="0">
+                <a:solidFill>
+                  <a:srgbClr val="FFFFFF"/>
+                </a:solidFill>
+                <a:latin typeface="Calibri" pitchFamily="34" charset="0"/>
+                <a:ea typeface="Calibri" pitchFamily="34" charset="-122"/>
+                <a:cs typeface="Calibri" pitchFamily="34" charset="-120"/>
+              </a:rPr>
+              <a:t>98010 and 98014 are genuinely rural, affordable, and still liquid enough to search — the strongest match for William's timing and non-renovated preference.</a:t>
+            </a:r>
+            <a:endParaRPr lang="en-US" sz="1600" dirty="0"/>
+          </a:p>
+        </p:txBody>
+      </p:sp>
+      <p:sp>
+        <p:nvSpPr>
+          <p:cNvPr id="6" name="Shape 3"/>
+          <p:cNvSpPr/>
+          <p:nvPr/>
+        </p:nvSpPr>
+        <p:spPr>
+          <a:xfrm>
+            <a:off x="640080" y="1965960"/>
+            <a:ext cx="5806440" cy="4160520"/>
+          </a:xfrm>
+          <a:prstGeom prst="roundRect">
+            <a:avLst>
+              <a:gd name="adj" fmla="val 2198"/>
+            </a:avLst>
+          </a:prstGeom>
+          <a:solidFill>
+            <a:srgbClr val="FFFFFF"/>
+          </a:solidFill>
+          <a:ln/>
+        </p:spPr>
+      </p:sp>
+      <p:pic>
+        <p:nvPicPr>
+          <p:cNvPr id="7" name="Image 1" descr="chart_slide9_zip_bubble.png">    </p:cNvPr>
+          <p:cNvPicPr>
+            <a:picLocks noChangeAspect="1"/>
+          </p:cNvPicPr>
+          <p:nvPr/>
+        </p:nvPicPr>
+        <p:blipFill>
+          <a:blip r:embed="rId2"/>
+          <a:stretch>
+            <a:fillRect/>
+          </a:stretch>
+        </p:blipFill>
+        <p:spPr>
+          <a:xfrm>
+            <a:off x="777240" y="2103120"/>
+            <a:ext cx="5532120" cy="3685032"/>
+          </a:xfrm>
+          <a:prstGeom prst="rect">
+            <a:avLst/>
+          </a:prstGeom>
+        </p:spPr>
+      </p:pic>
+      <p:sp>
+        <p:nvSpPr>
+          <p:cNvPr id="8" name="Text 4"/>
+          <p:cNvSpPr/>
+          <p:nvPr/>
+        </p:nvSpPr>
+        <p:spPr>
+          <a:xfrm>
+            <a:off x="777240" y="5760720"/>
+            <a:ext cx="5532120" cy="320040"/>
+          </a:xfrm>
+          <a:prstGeom prst="rect">
+            <a:avLst/>
+          </a:prstGeom>
+          <a:noFill/>
+          <a:ln/>
+        </p:spPr>
+        <p:txBody>
+          <a:bodyPr wrap="square" lIns="0" tIns="0" rIns="0" bIns="0" rtlCol="0" anchor="ctr"/>
+          <a:lstStyle/>
+          <a:p>
+            <a:pPr indent="0" marL="0">
+              <a:buNone/>
+            </a:pPr>
+            <a:r>
+              <a:rPr lang="en-US" sz="1100" i="1" dirty="0">
+                <a:solidFill>
+                  <a:srgbClr val="244F26"/>
+                </a:solidFill>
+                <a:latin typeface="Calibri" pitchFamily="34" charset="0"/>
+                <a:ea typeface="Calibri" pitchFamily="34" charset="-122"/>
+                <a:cs typeface="Calibri" pitchFamily="34" charset="-120"/>
+              </a:rPr>
+              <a:t>Distance vs. large-lot share, sized by sales, colored by price — 98010 &amp; 98014 circled.</a:t>
+            </a:r>
+            <a:endParaRPr lang="en-US" sz="1100" dirty="0"/>
+          </a:p>
+        </p:txBody>
+      </p:sp>
+      <p:sp>
+        <p:nvSpPr>
+          <p:cNvPr id="9" name="Shape 5"/>
+          <p:cNvSpPr/>
+          <p:nvPr/>
+        </p:nvSpPr>
+        <p:spPr>
+          <a:xfrm>
+            <a:off x="6656832" y="2011680"/>
+            <a:ext cx="4892040" cy="1261872"/>
+          </a:xfrm>
+          <a:prstGeom prst="roundRect">
+            <a:avLst>
+              <a:gd name="adj" fmla="val 7246"/>
+            </a:avLst>
+          </a:prstGeom>
+          <a:solidFill>
+            <a:srgbClr val="244F26"/>
+          </a:solidFill>
+          <a:ln/>
+        </p:spPr>
+      </p:sp>
+      <p:sp>
+        <p:nvSpPr>
+          <p:cNvPr id="10" name="Text 6"/>
+          <p:cNvSpPr/>
+          <p:nvPr/>
+        </p:nvSpPr>
+        <p:spPr>
+          <a:xfrm>
+            <a:off x="6858000" y="2121408"/>
+            <a:ext cx="4480560" cy="457200"/>
+          </a:xfrm>
+          <a:prstGeom prst="rect">
+            <a:avLst/>
+          </a:prstGeom>
+          <a:noFill/>
+          <a:ln/>
+        </p:spPr>
+        <p:txBody>
+          <a:bodyPr wrap="square" lIns="0" tIns="0" rIns="0" bIns="0" rtlCol="0" anchor="ctr"/>
+          <a:lstStyle/>
+          <a:p>
+            <a:pPr indent="0" marL="0">
+              <a:buNone/>
+            </a:pPr>
+            <a:r>
+              <a:rPr lang="en-US" sz="2000" b="1" dirty="0">
+                <a:solidFill>
+                  <a:srgbClr val="FFFFFF"/>
+                </a:solidFill>
+                <a:latin typeface="Cambria" pitchFamily="34" charset="0"/>
+                <a:ea typeface="Cambria" pitchFamily="34" charset="-122"/>
+                <a:cs typeface="Cambria" pitchFamily="34" charset="-120"/>
+              </a:rPr>
+              <a:t>30+ km</a:t>
+            </a:r>
+            <a:endParaRPr lang="en-US" sz="2000" dirty="0"/>
+          </a:p>
+        </p:txBody>
+      </p:sp>
+      <p:sp>
+        <p:nvSpPr>
+          <p:cNvPr id="11" name="Text 7"/>
+          <p:cNvSpPr/>
+          <p:nvPr/>
+        </p:nvSpPr>
+        <p:spPr>
+          <a:xfrm>
+            <a:off x="6858000" y="2578608"/>
+            <a:ext cx="4480560" cy="640080"/>
+          </a:xfrm>
+          <a:prstGeom prst="rect">
+            <a:avLst/>
+          </a:prstGeom>
+          <a:noFill/>
+          <a:ln/>
+        </p:spPr>
+        <p:txBody>
+          <a:bodyPr wrap="square" lIns="0" tIns="0" rIns="0" bIns="0" rtlCol="0" anchor="ctr"/>
+          <a:lstStyle/>
+          <a:p>
+            <a:pPr indent="0" marL="0">
+              <a:buNone/>
+            </a:pPr>
+            <a:r>
+              <a:rPr lang="en-US" sz="1200" dirty="0">
+                <a:solidFill>
+                  <a:srgbClr val="FFFFFF"/>
+                </a:solidFill>
+                <a:latin typeface="Calibri" pitchFamily="34" charset="0"/>
+                <a:ea typeface="Calibri" pitchFamily="34" charset="-122"/>
+                <a:cs typeface="Calibri" pitchFamily="34" charset="-120"/>
+              </a:rPr>
+              <a:t>from downtown — genuinely rural, not just “outside city limits”</a:t>
+            </a:r>
+            <a:endParaRPr lang="en-US" sz="1200" dirty="0"/>
+          </a:p>
+        </p:txBody>
+      </p:sp>
+      <p:sp>
+        <p:nvSpPr>
+          <p:cNvPr id="12" name="Shape 8"/>
+          <p:cNvSpPr/>
+          <p:nvPr/>
+        </p:nvSpPr>
+        <p:spPr>
+          <a:xfrm>
+            <a:off x="6656832" y="3419856"/>
+            <a:ext cx="4892040" cy="1261872"/>
+          </a:xfrm>
+          <a:prstGeom prst="roundRect">
+            <a:avLst>
+              <a:gd name="adj" fmla="val 7246"/>
+            </a:avLst>
+          </a:prstGeom>
+          <a:solidFill>
+            <a:srgbClr val="244F26"/>
+          </a:solidFill>
+          <a:ln/>
+        </p:spPr>
+      </p:sp>
+      <p:sp>
+        <p:nvSpPr>
+          <p:cNvPr id="13" name="Text 9"/>
+          <p:cNvSpPr/>
+          <p:nvPr/>
+        </p:nvSpPr>
+        <p:spPr>
+          <a:xfrm>
+            <a:off x="6858000" y="3529584"/>
+            <a:ext cx="4480560" cy="457200"/>
+          </a:xfrm>
+          <a:prstGeom prst="rect">
+            <a:avLst/>
+          </a:prstGeom>
+          <a:noFill/>
+          <a:ln/>
+        </p:spPr>
+        <p:txBody>
+          <a:bodyPr wrap="square" lIns="0" tIns="0" rIns="0" bIns="0" rtlCol="0" anchor="ctr"/>
+          <a:lstStyle/>
+          <a:p>
+            <a:pPr indent="0" marL="0">
+              <a:buNone/>
+            </a:pPr>
+            <a:r>
+              <a:rPr lang="en-US" sz="2000" b="1" dirty="0">
+                <a:solidFill>
+                  <a:srgbClr val="FFFFFF"/>
+                </a:solidFill>
+                <a:latin typeface="Cambria" pitchFamily="34" charset="0"/>
+                <a:ea typeface="Cambria" pitchFamily="34" charset="-122"/>
+                <a:cs typeface="Cambria" pitchFamily="34" charset="-120"/>
+              </a:rPr>
+              <a:t>68–85%</a:t>
+            </a:r>
+            <a:endParaRPr lang="en-US" sz="2000" dirty="0"/>
+          </a:p>
+        </p:txBody>
+      </p:sp>
+      <p:sp>
+        <p:nvSpPr>
+          <p:cNvPr id="14" name="Text 10"/>
+          <p:cNvSpPr/>
+          <p:nvPr/>
+        </p:nvSpPr>
+        <p:spPr>
+          <a:xfrm>
+            <a:off x="6858000" y="3986784"/>
+            <a:ext cx="4480560" cy="640080"/>
+          </a:xfrm>
+          <a:prstGeom prst="rect">
+            <a:avLst/>
+          </a:prstGeom>
+          <a:noFill/>
+          <a:ln/>
+        </p:spPr>
+        <p:txBody>
+          <a:bodyPr wrap="square" lIns="0" tIns="0" rIns="0" bIns="0" rtlCol="0" anchor="ctr"/>
+          <a:lstStyle/>
+          <a:p>
+            <a:pPr indent="0" marL="0">
+              <a:buNone/>
+            </a:pPr>
+            <a:r>
+              <a:rPr lang="en-US" sz="1200" dirty="0">
+                <a:solidFill>
+                  <a:srgbClr val="FFFFFF"/>
+                </a:solidFill>
+                <a:latin typeface="Calibri" pitchFamily="34" charset="0"/>
+                <a:ea typeface="Calibri" pitchFamily="34" charset="-122"/>
+                <a:cs typeface="Calibri" pitchFamily="34" charset="-120"/>
+              </a:rPr>
+              <a:t>of homes in these zips are large-lot — real country character</a:t>
+            </a:r>
+            <a:endParaRPr lang="en-US" sz="1200" dirty="0"/>
+          </a:p>
+        </p:txBody>
+      </p:sp>
+      <p:sp>
+        <p:nvSpPr>
+          <p:cNvPr id="15" name="Shape 11"/>
+          <p:cNvSpPr/>
+          <p:nvPr/>
+        </p:nvSpPr>
+        <p:spPr>
+          <a:xfrm>
+            <a:off x="6656832" y="4828032"/>
+            <a:ext cx="4892040" cy="1261872"/>
+          </a:xfrm>
+          <a:prstGeom prst="roundRect">
+            <a:avLst>
+              <a:gd name="adj" fmla="val 7246"/>
+            </a:avLst>
+          </a:prstGeom>
+          <a:solidFill>
+            <a:srgbClr val="244F26"/>
+          </a:solidFill>
+          <a:ln/>
+        </p:spPr>
+      </p:sp>
+      <p:sp>
+        <p:nvSpPr>
+          <p:cNvPr id="16" name="Text 12"/>
+          <p:cNvSpPr/>
+          <p:nvPr/>
+        </p:nvSpPr>
+        <p:spPr>
+          <a:xfrm>
+            <a:off x="6858000" y="4937760"/>
+            <a:ext cx="4480560" cy="457200"/>
+          </a:xfrm>
+          <a:prstGeom prst="rect">
+            <a:avLst/>
+          </a:prstGeom>
+          <a:noFill/>
+          <a:ln/>
+        </p:spPr>
+        <p:txBody>
+          <a:bodyPr wrap="square" lIns="0" tIns="0" rIns="0" bIns="0" rtlCol="0" anchor="ctr"/>
+          <a:lstStyle/>
+          <a:p>
+            <a:pPr indent="0" marL="0">
+              <a:buNone/>
+            </a:pPr>
+            <a:r>
+              <a:rPr lang="en-US" sz="2000" b="1" dirty="0">
+                <a:solidFill>
+                  <a:srgbClr val="FFFFFF"/>
+                </a:solidFill>
+                <a:latin typeface="Cambria" pitchFamily="34" charset="0"/>
+                <a:ea typeface="Cambria" pitchFamily="34" charset="-122"/>
+                <a:cs typeface="Cambria" pitchFamily="34" charset="-120"/>
+              </a:rPr>
+              <a:t>$360K–$415K</a:t>
+            </a:r>
+            <a:endParaRPr lang="en-US" sz="2000" dirty="0"/>
+          </a:p>
+        </p:txBody>
+      </p:sp>
+      <p:sp>
+        <p:nvSpPr>
+          <p:cNvPr id="17" name="Text 13"/>
+          <p:cNvSpPr/>
+          <p:nvPr/>
+        </p:nvSpPr>
+        <p:spPr>
+          <a:xfrm>
+            <a:off x="6858000" y="5394960"/>
+            <a:ext cx="4480560" cy="640080"/>
+          </a:xfrm>
+          <a:prstGeom prst="rect">
+            <a:avLst/>
+          </a:prstGeom>
+          <a:noFill/>
+          <a:ln/>
+        </p:spPr>
+        <p:txBody>
+          <a:bodyPr wrap="square" lIns="0" tIns="0" rIns="0" bIns="0" rtlCol="0" anchor="ctr"/>
+          <a:lstStyle/>
+          <a:p>
+            <a:pPr indent="0" marL="0">
+              <a:buNone/>
+            </a:pPr>
+            <a:r>
+              <a:rPr lang="en-US" sz="1200" dirty="0">
+                <a:solidFill>
+                  <a:srgbClr val="FFFFFF"/>
+                </a:solidFill>
+                <a:latin typeface="Calibri" pitchFamily="34" charset="0"/>
+                <a:ea typeface="Calibri" pitchFamily="34" charset="-122"/>
+                <a:cs typeface="Calibri" pitchFamily="34" charset="-120"/>
+              </a:rPr>
+              <a:t>median price — well below the county median</a:t>
+            </a:r>
+            <a:endParaRPr lang="en-US" sz="1200" dirty="0"/>
+          </a:p>
+        </p:txBody>
+      </p:sp>
+      <p:sp>
+        <p:nvSpPr>
+          <p:cNvPr id="18" name="Text 14"/>
+          <p:cNvSpPr/>
+          <p:nvPr/>
+        </p:nvSpPr>
+        <p:spPr>
+          <a:xfrm>
+            <a:off x="6656832" y="6281928"/>
+            <a:ext cx="4892040" cy="685800"/>
+          </a:xfrm>
+          <a:prstGeom prst="rect">
+            <a:avLst/>
+          </a:prstGeom>
+          <a:noFill/>
+          <a:ln/>
+        </p:spPr>
+        <p:txBody>
+          <a:bodyPr wrap="square" lIns="0" tIns="0" rIns="0" bIns="0" rtlCol="0" anchor="ctr"/>
+          <a:lstStyle/>
+          <a:p>
+            <a:pPr indent="0" marL="0">
+              <a:lnSpc>
+                <a:spcPct val="110000"/>
+              </a:lnSpc>
+              <a:buNone/>
+            </a:pPr>
+            <a:r>
+              <a:rPr lang="en-US" sz="1150" i="1" dirty="0">
+                <a:solidFill>
+                  <a:srgbClr val="DCEAD2"/>
+                </a:solidFill>
+                <a:latin typeface="Calibri" pitchFamily="34" charset="0"/>
+                <a:ea typeface="Calibri" pitchFamily="34" charset="-122"/>
+                <a:cs typeface="Calibri" pitchFamily="34" charset="-120"/>
+              </a:rPr>
+              <a:t>Lean into non-renovated listings here — they’re the majority of homes and meaningfully cheaper.</a:t>
+            </a:r>
+            <a:endParaRPr lang="en-US" sz="1150" dirty="0"/>
+          </a:p>
+        </p:txBody>
+      </p:sp>
+      <p:sp>
+        <p:nvSpPr>
+          <p:cNvPr id="20" name="Text 15"/>
+          <p:cNvSpPr/>
+          <p:nvPr/>
+        </p:nvSpPr>
+        <p:spPr>
+          <a:xfrm>
+            <a:off x="11292840" y="6510528"/>
+            <a:ext cx="777240" cy="274320"/>
+          </a:xfrm>
+          <a:prstGeom prst="rect">
+            <a:avLst/>
+          </a:prstGeom>
+          <a:noFill/>
+          <a:ln/>
+        </p:spPr>
+        <p:txBody>
+          <a:bodyPr wrap="square" lIns="0" tIns="0" rIns="0" bIns="0" rtlCol="0" anchor="ctr"/>
+          <a:lstStyle/>
+          <a:p>
+            <a:pPr algn="r" indent="0" marL="0">
+              <a:buNone/>
+            </a:pPr>
+            <a:r>
+              <a:rPr lang="en-US" sz="1000" dirty="0">
+                <a:solidFill>
+                  <a:srgbClr val="DCEAD2"/>
+                </a:solidFill>
+                <a:latin typeface="Calibri" pitchFamily="34" charset="0"/>
+                <a:ea typeface="Calibri" pitchFamily="34" charset="-122"/>
+                <a:cs typeface="Calibri" pitchFamily="34" charset="-120"/>
+              </a:rPr>
+              <a:t>10 / 12</a:t>
+            </a:r>
+            <a:endParaRPr lang="en-US" sz="1000" dirty="0"/>
+          </a:p>
+        </p:txBody>
+      </p:sp>
+    </p:spTree>
+  </p:cSld>
+  <p:clrMapOvr>
+    <a:masterClrMapping/>
+  </p:clrMapOvr>
+</p:sld>
+</file>
+
+<file path=ppt/slides/slide11.xml><?xml version="1.0" encoding="utf-8"?>
+<p:sld xmlns:a="http://schemas.openxmlformats.org/drawingml/2006/main" xmlns:r="http://schemas.openxmlformats.org/officeDocument/2006/relationships" xmlns:p="http://schemas.openxmlformats.org/presentationml/2006/main">
+  <p:cSld name="Slide 11">
     <p:bg>
       <p:bgPr>
         <a:solidFill>
@@ -2735,7 +3592,7 @@
         </p:nvSpPr>
         <p:spPr>
           <a:xfrm>
-            <a:off x="731520" y="548640"/>
+            <a:off x="731520" y="502920"/>
             <a:ext cx="10698480" cy="777240"/>
           </a:xfrm>
           <a:prstGeom prst="rect">
@@ -2752,7 +3609,7 @@
               <a:buNone/>
             </a:pPr>
             <a:r>
-              <a:rPr lang="en-US" sz="3200" b="1" dirty="0">
+              <a:rPr lang="en-US" sz="3400" b="1" dirty="0">
                 <a:solidFill>
                   <a:srgbClr val="FFFFFF"/>
                 </a:solidFill>
@@ -2760,9 +3617,9 @@
                 <a:ea typeface="Cambria" pitchFamily="34" charset="-122"/>
                 <a:cs typeface="Cambria" pitchFamily="34" charset="-120"/>
               </a:rPr>
-              <a:t>Timing the Country Home</a:t>
-            </a:r>
-            <a:endParaRPr lang="en-US" sz="3200" dirty="0"/>
+              <a:t>Final Recommendations</a:t>
+            </a:r>
+            <a:endParaRPr lang="en-US" sz="3400" dirty="0"/>
           </a:p>
         </p:txBody>
       </p:sp>
@@ -2774,260 +3631,21 @@
         </p:nvSpPr>
         <p:spPr>
           <a:xfrm>
-            <a:off x="731520" y="1645920"/>
-            <a:ext cx="5120640" cy="2377440"/>
-          </a:xfrm>
-          <a:prstGeom prst="roundRect">
-            <a:avLst>
-              <a:gd name="adj" fmla="val 4615"/>
-            </a:avLst>
+            <a:off x="822960" y="1828800"/>
+            <a:ext cx="914400" cy="914400"/>
+          </a:xfrm>
+          <a:prstGeom prst="ellipse">
+            <a:avLst/>
           </a:prstGeom>
           <a:solidFill>
-            <a:srgbClr val="27346E"/>
-          </a:solidFill>
-          <a:ln/>
-        </p:spPr>
-      </p:sp>
-      <p:sp>
-        <p:nvSpPr>
-          <p:cNvPr id="4" name="Text 2"/>
-          <p:cNvSpPr/>
-          <p:nvPr/>
-        </p:nvSpPr>
-        <p:spPr>
-          <a:xfrm>
-            <a:off x="1005840" y="1920240"/>
-            <a:ext cx="4572000" cy="502920"/>
-          </a:xfrm>
-          <a:prstGeom prst="rect">
-            <a:avLst/>
-          </a:prstGeom>
-          <a:noFill/>
-          <a:ln/>
-        </p:spPr>
-        <p:txBody>
-          <a:bodyPr wrap="square" lIns="0" tIns="0" rIns="0" bIns="0" rtlCol="0" anchor="ctr"/>
-          <a:lstStyle/>
-          <a:p>
-            <a:pPr indent="0" marL="0">
-              <a:buNone/>
-            </a:pPr>
-            <a:r>
-              <a:rPr lang="en-US" sz="1800" b="1" dirty="0">
-                <a:solidFill>
-                  <a:srgbClr val="FFFFFF"/>
-                </a:solidFill>
-                <a:latin typeface="Calibri" pitchFamily="34" charset="0"/>
-                <a:ea typeface="Calibri" pitchFamily="34" charset="-122"/>
-                <a:cs typeface="Calibri" pitchFamily="34" charset="-120"/>
-              </a:rPr>
-              <a:t>Buy in August</a:t>
-            </a:r>
-            <a:endParaRPr lang="en-US" sz="1800" dirty="0"/>
-          </a:p>
-        </p:txBody>
-      </p:sp>
-      <p:sp>
-        <p:nvSpPr>
-          <p:cNvPr id="5" name="Text 3"/>
-          <p:cNvSpPr/>
-          <p:nvPr/>
-        </p:nvSpPr>
-        <p:spPr>
-          <a:xfrm>
-            <a:off x="1005840" y="2468880"/>
-            <a:ext cx="4572000" cy="1371600"/>
-          </a:xfrm>
-          <a:prstGeom prst="rect">
-            <a:avLst/>
-          </a:prstGeom>
-          <a:noFill/>
-          <a:ln/>
-        </p:spPr>
-        <p:txBody>
-          <a:bodyPr wrap="square" lIns="0" tIns="0" rIns="0" bIns="0" rtlCol="0" anchor="ctr"/>
-          <a:lstStyle/>
-          <a:p>
-            <a:pPr indent="0" marL="0">
-              <a:buNone/>
-            </a:pPr>
-            <a:r>
-              <a:rPr lang="en-US" sz="1400" dirty="0">
-                <a:solidFill>
-                  <a:srgbClr val="CADCFC"/>
-                </a:solidFill>
-                <a:latin typeface="Calibri" pitchFamily="34" charset="0"/>
-                <a:ea typeface="Calibri" pitchFamily="34" charset="-122"/>
-                <a:cs typeface="Calibri" pitchFamily="34" charset="-120"/>
-              </a:rPr>
-              <a:t>Lowest median price of the year for country homes — $493,725. Best if savings matter most.</a:t>
-            </a:r>
-            <a:endParaRPr lang="en-US" sz="1400" dirty="0"/>
-          </a:p>
-        </p:txBody>
-      </p:sp>
-      <p:sp>
-        <p:nvSpPr>
-          <p:cNvPr id="6" name="Shape 4"/>
-          <p:cNvSpPr/>
-          <p:nvPr/>
-        </p:nvSpPr>
-        <p:spPr>
-          <a:xfrm>
-            <a:off x="6309360" y="1645920"/>
-            <a:ext cx="5120640" cy="2377440"/>
-          </a:xfrm>
-          <a:prstGeom prst="roundRect">
-            <a:avLst>
-              <a:gd name="adj" fmla="val 4615"/>
-            </a:avLst>
-          </a:prstGeom>
-          <a:solidFill>
-            <a:srgbClr val="27346E"/>
-          </a:solidFill>
-          <a:ln/>
-        </p:spPr>
-      </p:sp>
-      <p:sp>
-        <p:nvSpPr>
-          <p:cNvPr id="7" name="Text 5"/>
-          <p:cNvSpPr/>
-          <p:nvPr/>
-        </p:nvSpPr>
-        <p:spPr>
-          <a:xfrm>
-            <a:off x="6583680" y="1920240"/>
-            <a:ext cx="4572000" cy="502920"/>
-          </a:xfrm>
-          <a:prstGeom prst="rect">
-            <a:avLst/>
-          </a:prstGeom>
-          <a:noFill/>
-          <a:ln/>
-        </p:spPr>
-        <p:txBody>
-          <a:bodyPr wrap="square" lIns="0" tIns="0" rIns="0" bIns="0" rtlCol="0" anchor="ctr"/>
-          <a:lstStyle/>
-          <a:p>
-            <a:pPr indent="0" marL="0">
-              <a:buNone/>
-            </a:pPr>
-            <a:r>
-              <a:rPr lang="en-US" sz="1800" b="1" dirty="0">
-                <a:solidFill>
-                  <a:srgbClr val="FFFFFF"/>
-                </a:solidFill>
-                <a:latin typeface="Calibri" pitchFamily="34" charset="0"/>
-                <a:ea typeface="Calibri" pitchFamily="34" charset="-122"/>
-                <a:cs typeface="Calibri" pitchFamily="34" charset="-120"/>
-              </a:rPr>
-              <a:t>Buy in May</a:t>
-            </a:r>
-            <a:endParaRPr lang="en-US" sz="1800" dirty="0"/>
-          </a:p>
-        </p:txBody>
-      </p:sp>
-      <p:sp>
-        <p:nvSpPr>
-          <p:cNvPr id="8" name="Text 6"/>
-          <p:cNvSpPr/>
-          <p:nvPr/>
-        </p:nvSpPr>
-        <p:spPr>
-          <a:xfrm>
-            <a:off x="6583680" y="2468880"/>
-            <a:ext cx="4572000" cy="1371600"/>
-          </a:xfrm>
-          <a:prstGeom prst="rect">
-            <a:avLst/>
-          </a:prstGeom>
-          <a:noFill/>
-          <a:ln/>
-        </p:spPr>
-        <p:txBody>
-          <a:bodyPr wrap="square" lIns="0" tIns="0" rIns="0" bIns="0" rtlCol="0" anchor="ctr"/>
-          <a:lstStyle/>
-          <a:p>
-            <a:pPr indent="0" marL="0">
-              <a:buNone/>
-            </a:pPr>
-            <a:r>
-              <a:rPr lang="en-US" sz="1400" dirty="0">
-                <a:solidFill>
-                  <a:srgbClr val="CADCFC"/>
-                </a:solidFill>
-                <a:latin typeface="Calibri" pitchFamily="34" charset="0"/>
-                <a:ea typeface="Calibri" pitchFamily="34" charset="-122"/>
-                <a:cs typeface="Calibri" pitchFamily="34" charset="-120"/>
-              </a:rPr>
-              <a:t>About 18% more country-home listings than August, at only a ~9% price premium.</a:t>
-            </a:r>
-            <a:endParaRPr lang="en-US" sz="1400" dirty="0"/>
-          </a:p>
-        </p:txBody>
-      </p:sp>
-      <p:sp>
-        <p:nvSpPr>
-          <p:cNvPr id="9" name="Text 7"/>
-          <p:cNvSpPr/>
-          <p:nvPr/>
-        </p:nvSpPr>
-        <p:spPr>
-          <a:xfrm>
-            <a:off x="731520" y="4663440"/>
-            <a:ext cx="10698480" cy="822960"/>
-          </a:xfrm>
-          <a:prstGeom prst="rect">
-            <a:avLst/>
-          </a:prstGeom>
-          <a:noFill/>
-          <a:ln/>
-        </p:spPr>
-        <p:txBody>
-          <a:bodyPr wrap="square" lIns="0" tIns="0" rIns="0" bIns="0" rtlCol="0" anchor="ctr"/>
-          <a:lstStyle/>
-          <a:p>
-            <a:pPr indent="0" marL="0">
-              <a:buNone/>
-            </a:pPr>
-            <a:r>
-              <a:rPr lang="en-US" sz="3400" b="1" dirty="0">
-                <a:solidFill>
-                  <a:srgbClr val="FFFFFF"/>
-                </a:solidFill>
-                <a:latin typeface="Cambria" pitchFamily="34" charset="0"/>
-                <a:ea typeface="Cambria" pitchFamily="34" charset="-122"/>
-                <a:cs typeface="Cambria" pitchFamily="34" charset="-120"/>
-              </a:rPr>
-              <a:t>Thank You</a:t>
-            </a:r>
-            <a:endParaRPr lang="en-US" sz="3400" dirty="0"/>
-          </a:p>
-        </p:txBody>
-      </p:sp>
-      <p:sp>
-        <p:nvSpPr>
-          <p:cNvPr id="10" name="Shape 8"/>
-          <p:cNvSpPr/>
-          <p:nvPr/>
-        </p:nvSpPr>
-        <p:spPr>
-          <a:xfrm>
-            <a:off x="9052560" y="4526280"/>
-            <a:ext cx="914400" cy="914400"/>
-          </a:xfrm>
-          <a:prstGeom prst="ellipse">
-            <a:avLst/>
-          </a:prstGeom>
-          <a:solidFill>
-            <a:srgbClr val="27346E"/>
+            <a:srgbClr val="1C7293"/>
           </a:solidFill>
           <a:ln/>
         </p:spPr>
       </p:sp>
       <p:pic>
         <p:nvPicPr>
-          <p:cNvPr id="11" name="Image 0" descr="preencoded.png">    </p:cNvPr>
+          <p:cNvPr id="4" name="Image 0" descr="preencoded.png">    </p:cNvPr>
           <p:cNvPicPr>
             <a:picLocks noChangeAspect="1"/>
           </p:cNvPicPr>
@@ -3041,7 +3659,7 @@
         </p:blipFill>
         <p:spPr>
           <a:xfrm>
-            <a:off x="9290304" y="4764024"/>
+            <a:off x="1060704" y="2066544"/>
             <a:ext cx="438912" cy="438912"/>
           </a:xfrm>
           <a:prstGeom prst="rect">
@@ -3051,14 +3669,14 @@
       </p:pic>
       <p:sp>
         <p:nvSpPr>
-          <p:cNvPr id="12" name="Text 9"/>
-          <p:cNvSpPr/>
-          <p:nvPr/>
-        </p:nvSpPr>
-        <p:spPr>
-          <a:xfrm>
-            <a:off x="731520" y="5440680"/>
-            <a:ext cx="7772400" cy="548640"/>
+          <p:cNvPr id="5" name="Text 2"/>
+          <p:cNvSpPr/>
+          <p:nvPr/>
+        </p:nvSpPr>
+        <p:spPr>
+          <a:xfrm>
+            <a:off x="2011680" y="1783080"/>
+            <a:ext cx="2926080" cy="914400"/>
           </a:xfrm>
           <a:prstGeom prst="rect">
             <a:avLst/>
@@ -3074,7 +3692,49 @@
               <a:buNone/>
             </a:pPr>
             <a:r>
-              <a:rPr lang="en-US" sz="1600" dirty="0">
+              <a:rPr lang="en-US" sz="2000" b="1" dirty="0">
+                <a:solidFill>
+                  <a:srgbClr val="FFFFFF"/>
+                </a:solidFill>
+                <a:latin typeface="Cambria" pitchFamily="34" charset="0"/>
+                <a:ea typeface="Cambria" pitchFamily="34" charset="-122"/>
+                <a:cs typeface="Cambria" pitchFamily="34" charset="-120"/>
+              </a:rPr>
+              <a:t>City home</a:t>
+            </a:r>
+            <a:endParaRPr lang="en-US" sz="2000" dirty="0"/>
+          </a:p>
+        </p:txBody>
+      </p:sp>
+      <p:sp>
+        <p:nvSpPr>
+          <p:cNvPr id="6" name="Text 3"/>
+          <p:cNvSpPr/>
+          <p:nvPr/>
+        </p:nvSpPr>
+        <p:spPr>
+          <a:xfrm>
+            <a:off x="4846320" y="1783080"/>
+            <a:ext cx="6675120" cy="1005840"/>
+          </a:xfrm>
+          <a:prstGeom prst="rect">
+            <a:avLst/>
+          </a:prstGeom>
+          <a:noFill/>
+          <a:ln/>
+        </p:spPr>
+        <p:txBody>
+          <a:bodyPr wrap="square" lIns="0" tIns="0" rIns="0" bIns="0" rtlCol="0" anchor="ctr"/>
+          <a:lstStyle/>
+          <a:p>
+            <a:pPr indent="0" marL="0">
+              <a:lnSpc>
+                <a:spcPct val="115000"/>
+              </a:lnSpc>
+              <a:buNone/>
+            </a:pPr>
+            <a:r>
+              <a:rPr lang="en-US" sz="1500" dirty="0">
                 <a:solidFill>
                   <a:srgbClr val="CADCFC"/>
                 </a:solidFill>
@@ -3082,9 +3742,491 @@
                 <a:ea typeface="Calibri" pitchFamily="34" charset="-122"/>
                 <a:cs typeface="Calibri" pitchFamily="34" charset="-120"/>
               </a:rPr>
+              <a:t>Target zip 98118 — closest high-turnover, affordable zip to downtown. Filter to 1–3 bedrooms.</a:t>
+            </a:r>
+            <a:endParaRPr lang="en-US" sz="1500" dirty="0"/>
+          </a:p>
+        </p:txBody>
+      </p:sp>
+      <p:sp>
+        <p:nvSpPr>
+          <p:cNvPr id="7" name="Shape 4"/>
+          <p:cNvSpPr/>
+          <p:nvPr/>
+        </p:nvSpPr>
+        <p:spPr>
+          <a:xfrm>
+            <a:off x="822960" y="3246120"/>
+            <a:ext cx="914400" cy="914400"/>
+          </a:xfrm>
+          <a:prstGeom prst="ellipse">
+            <a:avLst/>
+          </a:prstGeom>
+          <a:solidFill>
+            <a:srgbClr val="2C5F2D"/>
+          </a:solidFill>
+          <a:ln/>
+        </p:spPr>
+      </p:sp>
+      <p:pic>
+        <p:nvPicPr>
+          <p:cNvPr id="8" name="Image 1" descr="preencoded.png">    </p:cNvPr>
+          <p:cNvPicPr>
+            <a:picLocks noChangeAspect="1"/>
+          </p:cNvPicPr>
+          <p:nvPr/>
+        </p:nvPicPr>
+        <p:blipFill>
+          <a:blip r:embed="rId2"/>
+          <a:stretch>
+            <a:fillRect/>
+          </a:stretch>
+        </p:blipFill>
+        <p:spPr>
+          <a:xfrm>
+            <a:off x="1060704" y="3483864"/>
+            <a:ext cx="438912" cy="438912"/>
+          </a:xfrm>
+          <a:prstGeom prst="rect">
+            <a:avLst/>
+          </a:prstGeom>
+        </p:spPr>
+      </p:pic>
+      <p:sp>
+        <p:nvSpPr>
+          <p:cNvPr id="9" name="Text 5"/>
+          <p:cNvSpPr/>
+          <p:nvPr/>
+        </p:nvSpPr>
+        <p:spPr>
+          <a:xfrm>
+            <a:off x="2011680" y="3200400"/>
+            <a:ext cx="2926080" cy="914400"/>
+          </a:xfrm>
+          <a:prstGeom prst="rect">
+            <a:avLst/>
+          </a:prstGeom>
+          <a:noFill/>
+          <a:ln/>
+        </p:spPr>
+        <p:txBody>
+          <a:bodyPr wrap="square" lIns="0" tIns="0" rIns="0" bIns="0" rtlCol="0" anchor="ctr"/>
+          <a:lstStyle/>
+          <a:p>
+            <a:pPr indent="0" marL="0">
+              <a:buNone/>
+            </a:pPr>
+            <a:r>
+              <a:rPr lang="en-US" sz="2000" b="1" dirty="0">
+                <a:solidFill>
+                  <a:srgbClr val="FFFFFF"/>
+                </a:solidFill>
+                <a:latin typeface="Cambria" pitchFamily="34" charset="0"/>
+                <a:ea typeface="Cambria" pitchFamily="34" charset="-122"/>
+                <a:cs typeface="Cambria" pitchFamily="34" charset="-120"/>
+              </a:rPr>
+              <a:t>Country home</a:t>
+            </a:r>
+            <a:endParaRPr lang="en-US" sz="2000" dirty="0"/>
+          </a:p>
+        </p:txBody>
+      </p:sp>
+      <p:sp>
+        <p:nvSpPr>
+          <p:cNvPr id="10" name="Text 6"/>
+          <p:cNvSpPr/>
+          <p:nvPr/>
+        </p:nvSpPr>
+        <p:spPr>
+          <a:xfrm>
+            <a:off x="4846320" y="3200400"/>
+            <a:ext cx="6675120" cy="1005840"/>
+          </a:xfrm>
+          <a:prstGeom prst="rect">
+            <a:avLst/>
+          </a:prstGeom>
+          <a:noFill/>
+          <a:ln/>
+        </p:spPr>
+        <p:txBody>
+          <a:bodyPr wrap="square" lIns="0" tIns="0" rIns="0" bIns="0" rtlCol="0" anchor="ctr"/>
+          <a:lstStyle/>
+          <a:p>
+            <a:pPr indent="0" marL="0">
+              <a:lnSpc>
+                <a:spcPct val="115000"/>
+              </a:lnSpc>
+              <a:buNone/>
+            </a:pPr>
+            <a:r>
+              <a:rPr lang="en-US" sz="1500" dirty="0">
+                <a:solidFill>
+                  <a:srgbClr val="CADCFC"/>
+                </a:solidFill>
+                <a:latin typeface="Calibri" pitchFamily="34" charset="0"/>
+                <a:ea typeface="Calibri" pitchFamily="34" charset="-122"/>
+                <a:cs typeface="Calibri" pitchFamily="34" charset="-120"/>
+              </a:rPr>
+              <a:t>Target zip 98010 or 98014 — genuinely rural and affordable. Lean into non-renovated listings.</a:t>
+            </a:r>
+            <a:endParaRPr lang="en-US" sz="1500" dirty="0"/>
+          </a:p>
+        </p:txBody>
+      </p:sp>
+      <p:sp>
+        <p:nvSpPr>
+          <p:cNvPr id="11" name="Shape 7"/>
+          <p:cNvSpPr/>
+          <p:nvPr/>
+        </p:nvSpPr>
+        <p:spPr>
+          <a:xfrm>
+            <a:off x="822960" y="4663440"/>
+            <a:ext cx="914400" cy="914400"/>
+          </a:xfrm>
+          <a:prstGeom prst="ellipse">
+            <a:avLst/>
+          </a:prstGeom>
+          <a:solidFill>
+            <a:srgbClr val="5B4B8A"/>
+          </a:solidFill>
+          <a:ln/>
+        </p:spPr>
+      </p:sp>
+      <p:pic>
+        <p:nvPicPr>
+          <p:cNvPr id="12" name="Image 2" descr="preencoded.png">    </p:cNvPr>
+          <p:cNvPicPr>
+            <a:picLocks noChangeAspect="1"/>
+          </p:cNvPicPr>
+          <p:nvPr/>
+        </p:nvPicPr>
+        <p:blipFill>
+          <a:blip r:embed="rId3"/>
+          <a:stretch>
+            <a:fillRect/>
+          </a:stretch>
+        </p:blipFill>
+        <p:spPr>
+          <a:xfrm>
+            <a:off x="1060704" y="4901184"/>
+            <a:ext cx="438912" cy="438912"/>
+          </a:xfrm>
+          <a:prstGeom prst="rect">
+            <a:avLst/>
+          </a:prstGeom>
+        </p:spPr>
+      </p:pic>
+      <p:sp>
+        <p:nvSpPr>
+          <p:cNvPr id="13" name="Text 8"/>
+          <p:cNvSpPr/>
+          <p:nvPr/>
+        </p:nvSpPr>
+        <p:spPr>
+          <a:xfrm>
+            <a:off x="2011680" y="4617720"/>
+            <a:ext cx="2926080" cy="914400"/>
+          </a:xfrm>
+          <a:prstGeom prst="rect">
+            <a:avLst/>
+          </a:prstGeom>
+          <a:noFill/>
+          <a:ln/>
+        </p:spPr>
+        <p:txBody>
+          <a:bodyPr wrap="square" lIns="0" tIns="0" rIns="0" bIns="0" rtlCol="0" anchor="ctr"/>
+          <a:lstStyle/>
+          <a:p>
+            <a:pPr indent="0" marL="0">
+              <a:buNone/>
+            </a:pPr>
+            <a:r>
+              <a:rPr lang="en-US" sz="2000" b="1" dirty="0">
+                <a:solidFill>
+                  <a:srgbClr val="FFFFFF"/>
+                </a:solidFill>
+                <a:latin typeface="Cambria" pitchFamily="34" charset="0"/>
+                <a:ea typeface="Cambria" pitchFamily="34" charset="-122"/>
+                <a:cs typeface="Cambria" pitchFamily="34" charset="-120"/>
+              </a:rPr>
+              <a:t>Timing</a:t>
+            </a:r>
+            <a:endParaRPr lang="en-US" sz="2000" dirty="0"/>
+          </a:p>
+        </p:txBody>
+      </p:sp>
+      <p:sp>
+        <p:nvSpPr>
+          <p:cNvPr id="14" name="Text 9"/>
+          <p:cNvSpPr/>
+          <p:nvPr/>
+        </p:nvSpPr>
+        <p:spPr>
+          <a:xfrm>
+            <a:off x="4846320" y="4617720"/>
+            <a:ext cx="6675120" cy="1005840"/>
+          </a:xfrm>
+          <a:prstGeom prst="rect">
+            <a:avLst/>
+          </a:prstGeom>
+          <a:noFill/>
+          <a:ln/>
+        </p:spPr>
+        <p:txBody>
+          <a:bodyPr wrap="square" lIns="0" tIns="0" rIns="0" bIns="0" rtlCol="0" anchor="ctr"/>
+          <a:lstStyle/>
+          <a:p>
+            <a:pPr indent="0" marL="0">
+              <a:lnSpc>
+                <a:spcPct val="115000"/>
+              </a:lnSpc>
+              <a:buNone/>
+            </a:pPr>
+            <a:r>
+              <a:rPr lang="en-US" sz="1500" dirty="0">
+                <a:solidFill>
+                  <a:srgbClr val="CADCFC"/>
+                </a:solidFill>
+                <a:latin typeface="Calibri" pitchFamily="34" charset="0"/>
+                <a:ea typeface="Calibri" pitchFamily="34" charset="-122"/>
+                <a:cs typeface="Calibri" pitchFamily="34" charset="-120"/>
+              </a:rPr>
+              <a:t>Close in August for the lowest country-home price ($493,725), or May for ~18% more inventory at only a ~9% premium.</a:t>
+            </a:r>
+            <a:endParaRPr lang="en-US" sz="1500" dirty="0"/>
+          </a:p>
+        </p:txBody>
+      </p:sp>
+      <p:sp>
+        <p:nvSpPr>
+          <p:cNvPr id="16" name="Text 10"/>
+          <p:cNvSpPr/>
+          <p:nvPr/>
+        </p:nvSpPr>
+        <p:spPr>
+          <a:xfrm>
+            <a:off x="11292840" y="6510528"/>
+            <a:ext cx="777240" cy="274320"/>
+          </a:xfrm>
+          <a:prstGeom prst="rect">
+            <a:avLst/>
+          </a:prstGeom>
+          <a:noFill/>
+          <a:ln/>
+        </p:spPr>
+        <p:txBody>
+          <a:bodyPr wrap="square" lIns="0" tIns="0" rIns="0" bIns="0" rtlCol="0" anchor="ctr"/>
+          <a:lstStyle/>
+          <a:p>
+            <a:pPr algn="r" indent="0" marL="0">
+              <a:buNone/>
+            </a:pPr>
+            <a:r>
+              <a:rPr lang="en-US" sz="1000" dirty="0">
+                <a:solidFill>
+                  <a:srgbClr val="CADCFC"/>
+                </a:solidFill>
+                <a:latin typeface="Calibri" pitchFamily="34" charset="0"/>
+                <a:ea typeface="Calibri" pitchFamily="34" charset="-122"/>
+                <a:cs typeface="Calibri" pitchFamily="34" charset="-120"/>
+              </a:rPr>
+              <a:t>11 / 12</a:t>
+            </a:r>
+            <a:endParaRPr lang="en-US" sz="1000" dirty="0"/>
+          </a:p>
+        </p:txBody>
+      </p:sp>
+    </p:spTree>
+  </p:cSld>
+  <p:clrMapOvr>
+    <a:masterClrMapping/>
+  </p:clrMapOvr>
+</p:sld>
+</file>
+
+<file path=ppt/slides/slide12.xml><?xml version="1.0" encoding="utf-8"?>
+<p:sld xmlns:a="http://schemas.openxmlformats.org/drawingml/2006/main" xmlns:r="http://schemas.openxmlformats.org/officeDocument/2006/relationships" xmlns:p="http://schemas.openxmlformats.org/presentationml/2006/main">
+  <p:cSld name="Slide 12">
+    <p:bg>
+      <p:bgPr>
+        <a:solidFill>
+          <a:srgbClr val="1E2761"/>
+        </a:solidFill>
+      </p:bgPr>
+    </p:bg>
+    <p:spTree>
+      <p:nvGrpSpPr>
+        <p:cNvPr id="1" name=""/>
+        <p:cNvGrpSpPr/>
+        <p:nvPr/>
+      </p:nvGrpSpPr>
+      <p:grpSpPr>
+        <a:xfrm>
+          <a:off x="0" y="0"/>
+          <a:ext cx="0" cy="0"/>
+          <a:chOff x="0" y="0"/>
+          <a:chExt cx="0" cy="0"/>
+        </a:xfrm>
+      </p:grpSpPr>
+      <p:sp>
+        <p:nvSpPr>
+          <p:cNvPr id="2" name="Shape 0"/>
+          <p:cNvSpPr/>
+          <p:nvPr/>
+        </p:nvSpPr>
+        <p:spPr>
+          <a:xfrm>
+            <a:off x="5184648" y="2103120"/>
+            <a:ext cx="1828800" cy="1828800"/>
+          </a:xfrm>
+          <a:prstGeom prst="ellipse">
+            <a:avLst/>
+          </a:prstGeom>
+          <a:solidFill>
+            <a:srgbClr val="27346E"/>
+          </a:solidFill>
+          <a:ln/>
+        </p:spPr>
+      </p:sp>
+      <p:pic>
+        <p:nvPicPr>
+          <p:cNvPr id="3" name="Image 0" descr="preencoded.png">    </p:cNvPr>
+          <p:cNvPicPr>
+            <a:picLocks noChangeAspect="1"/>
+          </p:cNvPicPr>
+          <p:nvPr/>
+        </p:nvPicPr>
+        <p:blipFill>
+          <a:blip r:embed="rId1"/>
+          <a:stretch>
+            <a:fillRect/>
+          </a:stretch>
+        </p:blipFill>
+        <p:spPr>
+          <a:xfrm>
+            <a:off x="5660136" y="2578608"/>
+            <a:ext cx="877824" cy="877824"/>
+          </a:xfrm>
+          <a:prstGeom prst="rect">
+            <a:avLst/>
+          </a:prstGeom>
+        </p:spPr>
+      </p:pic>
+      <p:sp>
+        <p:nvSpPr>
+          <p:cNvPr id="4" name="Text 1"/>
+          <p:cNvSpPr/>
+          <p:nvPr/>
+        </p:nvSpPr>
+        <p:spPr>
+          <a:xfrm>
+            <a:off x="731520" y="4206240"/>
+            <a:ext cx="10698480" cy="822960"/>
+          </a:xfrm>
+          <a:prstGeom prst="rect">
+            <a:avLst/>
+          </a:prstGeom>
+          <a:noFill/>
+          <a:ln/>
+        </p:spPr>
+        <p:txBody>
+          <a:bodyPr wrap="square" lIns="0" tIns="0" rIns="0" bIns="0" rtlCol="0" anchor="ctr"/>
+          <a:lstStyle/>
+          <a:p>
+            <a:pPr algn="ctr" indent="0" marL="0">
+              <a:buNone/>
+            </a:pPr>
+            <a:r>
+              <a:rPr lang="en-US" sz="4000" b="1" dirty="0">
+                <a:solidFill>
+                  <a:srgbClr val="FFFFFF"/>
+                </a:solidFill>
+                <a:latin typeface="Cambria" pitchFamily="34" charset="0"/>
+                <a:ea typeface="Cambria" pitchFamily="34" charset="-122"/>
+                <a:cs typeface="Cambria" pitchFamily="34" charset="-120"/>
+              </a:rPr>
+              <a:t>Thank You</a:t>
+            </a:r>
+            <a:endParaRPr lang="en-US" sz="4000" dirty="0"/>
+          </a:p>
+        </p:txBody>
+      </p:sp>
+      <p:sp>
+        <p:nvSpPr>
+          <p:cNvPr id="5" name="Text 2"/>
+          <p:cNvSpPr/>
+          <p:nvPr/>
+        </p:nvSpPr>
+        <p:spPr>
+          <a:xfrm>
+            <a:off x="731520" y="5029200"/>
+            <a:ext cx="10698480" cy="548640"/>
+          </a:xfrm>
+          <a:prstGeom prst="rect">
+            <a:avLst/>
+          </a:prstGeom>
+          <a:noFill/>
+          <a:ln/>
+        </p:spPr>
+        <p:txBody>
+          <a:bodyPr wrap="square" lIns="0" tIns="0" rIns="0" bIns="0" rtlCol="0" anchor="ctr"/>
+          <a:lstStyle/>
+          <a:p>
+            <a:pPr algn="ctr" indent="0" marL="0">
+              <a:buNone/>
+            </a:pPr>
+            <a:r>
+              <a:rPr lang="en-US" sz="1800" dirty="0">
+                <a:solidFill>
+                  <a:srgbClr val="CADCFC"/>
+                </a:solidFill>
+                <a:latin typeface="Calibri" pitchFamily="34" charset="0"/>
+                <a:ea typeface="Calibri" pitchFamily="34" charset="-122"/>
+                <a:cs typeface="Calibri" pitchFamily="34" charset="-120"/>
+              </a:rPr>
               <a:t>Questions &amp; discussion</a:t>
             </a:r>
-            <a:endParaRPr lang="en-US" sz="1600" dirty="0"/>
+            <a:endParaRPr lang="en-US" sz="1800" dirty="0"/>
+          </a:p>
+        </p:txBody>
+      </p:sp>
+      <p:sp>
+        <p:nvSpPr>
+          <p:cNvPr id="7" name="Text 3"/>
+          <p:cNvSpPr/>
+          <p:nvPr/>
+        </p:nvSpPr>
+        <p:spPr>
+          <a:xfrm>
+            <a:off x="11292840" y="6510528"/>
+            <a:ext cx="777240" cy="274320"/>
+          </a:xfrm>
+          <a:prstGeom prst="rect">
+            <a:avLst/>
+          </a:prstGeom>
+          <a:noFill/>
+          <a:ln/>
+        </p:spPr>
+        <p:txBody>
+          <a:bodyPr wrap="square" lIns="0" tIns="0" rIns="0" bIns="0" rtlCol="0" anchor="ctr"/>
+          <a:lstStyle/>
+          <a:p>
+            <a:pPr algn="r" indent="0" marL="0">
+              <a:buNone/>
+            </a:pPr>
+            <a:r>
+              <a:rPr lang="en-US" sz="1000" dirty="0">
+                <a:solidFill>
+                  <a:srgbClr val="CADCFC"/>
+                </a:solidFill>
+                <a:latin typeface="Calibri" pitchFamily="34" charset="0"/>
+                <a:ea typeface="Calibri" pitchFamily="34" charset="-122"/>
+                <a:cs typeface="Calibri" pitchFamily="34" charset="-120"/>
+              </a:rPr>
+              <a:t>12 / 12</a:t>
+            </a:r>
+            <a:endParaRPr lang="en-US" sz="1000" dirty="0"/>
           </a:p>
         </p:txBody>
       </p:sp>
@@ -3550,6 +4692,45 @@
           </a:p>
         </p:txBody>
       </p:sp>
+      <p:sp>
+        <p:nvSpPr>
+          <p:cNvPr id="15" name="Text 10"/>
+          <p:cNvSpPr/>
+          <p:nvPr/>
+        </p:nvSpPr>
+        <p:spPr>
+          <a:xfrm>
+            <a:off x="11292840" y="6510528"/>
+            <a:ext cx="777240" cy="274320"/>
+          </a:xfrm>
+          <a:prstGeom prst="rect">
+            <a:avLst/>
+          </a:prstGeom>
+          <a:noFill/>
+          <a:ln/>
+        </p:spPr>
+        <p:txBody>
+          <a:bodyPr wrap="square" lIns="0" tIns="0" rIns="0" bIns="0" rtlCol="0" anchor="ctr"/>
+          <a:lstStyle/>
+          <a:p>
+            <a:pPr algn="r" indent="0" marL="0">
+              <a:buNone/>
+            </a:pPr>
+            <a:r>
+              <a:rPr lang="en-US" sz="1000" dirty="0">
+                <a:solidFill>
+                  <a:srgbClr val="6B6B6B"/>
+                </a:solidFill>
+                <a:latin typeface="Calibri" pitchFamily="34" charset="0"/>
+                <a:ea typeface="Calibri" pitchFamily="34" charset="-122"/>
+                <a:cs typeface="Calibri" pitchFamily="34" charset="-120"/>
+              </a:rPr>
+              <a:t>2 / 12</a:t>
+            </a:r>
+            <a:endParaRPr lang="en-US" sz="1000" dirty="0"/>
+          </a:p>
+        </p:txBody>
+      </p:sp>
     </p:spTree>
   </p:cSld>
   <p:clrMapOvr>
@@ -3561,6 +4742,241 @@
 <file path=ppt/slides/slide3.xml><?xml version="1.0" encoding="utf-8"?>
 <p:sld xmlns:a="http://schemas.openxmlformats.org/drawingml/2006/main" xmlns:r="http://schemas.openxmlformats.org/officeDocument/2006/relationships" xmlns:p="http://schemas.openxmlformats.org/presentationml/2006/main">
   <p:cSld name="Slide 3">
+    <p:bg>
+      <p:bgPr>
+        <a:solidFill>
+          <a:srgbClr val="1E2761"/>
+        </a:solidFill>
+      </p:bgPr>
+    </p:bg>
+    <p:spTree>
+      <p:nvGrpSpPr>
+        <p:cNvPr id="1" name=""/>
+        <p:cNvGrpSpPr/>
+        <p:nvPr/>
+      </p:nvGrpSpPr>
+      <p:grpSpPr>
+        <a:xfrm>
+          <a:off x="0" y="0"/>
+          <a:ext cx="0" cy="0"/>
+          <a:chOff x="0" y="0"/>
+          <a:chExt cx="0" cy="0"/>
+        </a:xfrm>
+      </p:grpSpPr>
+      <p:sp>
+        <p:nvSpPr>
+          <p:cNvPr id="2" name="Text 0"/>
+          <p:cNvSpPr/>
+          <p:nvPr/>
+        </p:nvSpPr>
+        <p:spPr>
+          <a:xfrm>
+            <a:off x="822960" y="1828800"/>
+            <a:ext cx="10515600" cy="457200"/>
+          </a:xfrm>
+          <a:prstGeom prst="rect">
+            <a:avLst/>
+          </a:prstGeom>
+          <a:noFill/>
+          <a:ln/>
+        </p:spPr>
+        <p:txBody>
+          <a:bodyPr wrap="square" lIns="0" tIns="0" rIns="0" bIns="0" rtlCol="0" anchor="ctr"/>
+          <a:lstStyle/>
+          <a:p>
+            <a:pPr indent="0" marL="0">
+              <a:buNone/>
+            </a:pPr>
+            <a:r>
+              <a:rPr lang="en-US" sz="1500" b="1" spc="200" kern="0" dirty="0">
+                <a:solidFill>
+                  <a:srgbClr val="8FA3E0"/>
+                </a:solidFill>
+                <a:latin typeface="Calibri" pitchFamily="34" charset="0"/>
+                <a:ea typeface="Calibri" pitchFamily="34" charset="-122"/>
+                <a:cs typeface="Calibri" pitchFamily="34" charset="-120"/>
+              </a:rPr>
+              <a:t>BUSINESS QUESTION</a:t>
+            </a:r>
+            <a:endParaRPr lang="en-US" sz="1500" dirty="0"/>
+          </a:p>
+        </p:txBody>
+      </p:sp>
+      <p:sp>
+        <p:nvSpPr>
+          <p:cNvPr id="3" name="Text 1"/>
+          <p:cNvSpPr/>
+          <p:nvPr/>
+        </p:nvSpPr>
+        <p:spPr>
+          <a:xfrm>
+            <a:off x="822960" y="2331720"/>
+            <a:ext cx="10515600" cy="1828800"/>
+          </a:xfrm>
+          <a:prstGeom prst="rect">
+            <a:avLst/>
+          </a:prstGeom>
+          <a:noFill/>
+          <a:ln/>
+        </p:spPr>
+        <p:txBody>
+          <a:bodyPr wrap="square" lIns="0" tIns="0" rIns="0" bIns="0" rtlCol="0" anchor="ctr"/>
+          <a:lstStyle/>
+          <a:p>
+            <a:pPr indent="0" marL="0">
+              <a:lnSpc>
+                <a:spcPct val="110000"/>
+              </a:lnSpc>
+              <a:buNone/>
+            </a:pPr>
+            <a:r>
+              <a:rPr lang="en-US" sz="4000" b="1" dirty="0">
+                <a:solidFill>
+                  <a:srgbClr val="FFFFFF"/>
+                </a:solidFill>
+                <a:latin typeface="Cambria" pitchFamily="34" charset="0"/>
+                <a:ea typeface="Cambria" pitchFamily="34" charset="-122"/>
+                <a:cs typeface="Cambria" pitchFamily="34" charset="-120"/>
+              </a:rPr>
+              <a:t>What factors influence the price of homes in King County?</a:t>
+            </a:r>
+            <a:endParaRPr lang="en-US" sz="4000" dirty="0"/>
+          </a:p>
+        </p:txBody>
+      </p:sp>
+      <p:sp>
+        <p:nvSpPr>
+          <p:cNvPr id="4" name="Text 2"/>
+          <p:cNvSpPr/>
+          <p:nvPr/>
+        </p:nvSpPr>
+        <p:spPr>
+          <a:xfrm>
+            <a:off x="822960" y="4480560"/>
+            <a:ext cx="9418320" cy="914400"/>
+          </a:xfrm>
+          <a:prstGeom prst="rect">
+            <a:avLst/>
+          </a:prstGeom>
+          <a:noFill/>
+          <a:ln/>
+        </p:spPr>
+        <p:txBody>
+          <a:bodyPr wrap="square" lIns="0" tIns="0" rIns="0" bIns="0" rtlCol="0" anchor="ctr"/>
+          <a:lstStyle/>
+          <a:p>
+            <a:pPr indent="0" marL="0">
+              <a:buNone/>
+            </a:pPr>
+            <a:r>
+              <a:rPr lang="en-US" sz="1600" i="1" dirty="0">
+                <a:solidFill>
+                  <a:srgbClr val="CADCFC"/>
+                </a:solidFill>
+                <a:latin typeface="Calibri" pitchFamily="34" charset="0"/>
+                <a:ea typeface="Calibri" pitchFamily="34" charset="-122"/>
+                <a:cs typeface="Calibri" pitchFamily="34" charset="-120"/>
+              </a:rPr>
+              <a:t>Every finding and recommendation in this deck traces back to this one question — answered specifically for William's two searches, not the market in general.</a:t>
+            </a:r>
+            <a:endParaRPr lang="en-US" sz="1600" dirty="0"/>
+          </a:p>
+        </p:txBody>
+      </p:sp>
+      <p:sp>
+        <p:nvSpPr>
+          <p:cNvPr id="5" name="Shape 3"/>
+          <p:cNvSpPr/>
+          <p:nvPr/>
+        </p:nvSpPr>
+        <p:spPr>
+          <a:xfrm>
+            <a:off x="10058400" y="5394960"/>
+            <a:ext cx="1188720" cy="1188720"/>
+          </a:xfrm>
+          <a:prstGeom prst="ellipse">
+            <a:avLst/>
+          </a:prstGeom>
+          <a:solidFill>
+            <a:srgbClr val="27346E"/>
+          </a:solidFill>
+          <a:ln/>
+        </p:spPr>
+      </p:sp>
+      <p:pic>
+        <p:nvPicPr>
+          <p:cNvPr id="6" name="Image 0" descr="preencoded.png">    </p:cNvPr>
+          <p:cNvPicPr>
+            <a:picLocks noChangeAspect="1"/>
+          </p:cNvPicPr>
+          <p:nvPr/>
+        </p:nvPicPr>
+        <p:blipFill>
+          <a:blip r:embed="rId1"/>
+          <a:stretch>
+            <a:fillRect/>
+          </a:stretch>
+        </p:blipFill>
+        <p:spPr>
+          <a:xfrm>
+            <a:off x="10367467" y="5704027"/>
+            <a:ext cx="570586" cy="570586"/>
+          </a:xfrm>
+          <a:prstGeom prst="rect">
+            <a:avLst/>
+          </a:prstGeom>
+        </p:spPr>
+      </p:pic>
+      <p:sp>
+        <p:nvSpPr>
+          <p:cNvPr id="8" name="Text 4"/>
+          <p:cNvSpPr/>
+          <p:nvPr/>
+        </p:nvSpPr>
+        <p:spPr>
+          <a:xfrm>
+            <a:off x="11292840" y="6510528"/>
+            <a:ext cx="777240" cy="274320"/>
+          </a:xfrm>
+          <a:prstGeom prst="rect">
+            <a:avLst/>
+          </a:prstGeom>
+          <a:noFill/>
+          <a:ln/>
+        </p:spPr>
+        <p:txBody>
+          <a:bodyPr wrap="square" lIns="0" tIns="0" rIns="0" bIns="0" rtlCol="0" anchor="ctr"/>
+          <a:lstStyle/>
+          <a:p>
+            <a:pPr algn="r" indent="0" marL="0">
+              <a:buNone/>
+            </a:pPr>
+            <a:r>
+              <a:rPr lang="en-US" sz="1000" dirty="0">
+                <a:solidFill>
+                  <a:srgbClr val="CADCFC"/>
+                </a:solidFill>
+                <a:latin typeface="Calibri" pitchFamily="34" charset="0"/>
+                <a:ea typeface="Calibri" pitchFamily="34" charset="-122"/>
+                <a:cs typeface="Calibri" pitchFamily="34" charset="-120"/>
+              </a:rPr>
+              <a:t>3 / 12</a:t>
+            </a:r>
+            <a:endParaRPr lang="en-US" sz="1000" dirty="0"/>
+          </a:p>
+        </p:txBody>
+      </p:sp>
+    </p:spTree>
+  </p:cSld>
+  <p:clrMapOvr>
+    <a:masterClrMapping/>
+  </p:clrMapOvr>
+</p:sld>
+</file>
+
+<file path=ppt/slides/slide4.xml><?xml version="1.0" encoding="utf-8"?>
+<p:sld xmlns:a="http://schemas.openxmlformats.org/drawingml/2006/main" xmlns:r="http://schemas.openxmlformats.org/officeDocument/2006/relationships" xmlns:p="http://schemas.openxmlformats.org/presentationml/2006/main">
+  <p:cSld name="Slide 4">
     <p:bg>
       <p:bgPr>
         <a:solidFill>
@@ -3938,6 +5354,45 @@
           </a:p>
         </p:txBody>
       </p:sp>
+      <p:sp>
+        <p:nvSpPr>
+          <p:cNvPr id="13" name="Text 9"/>
+          <p:cNvSpPr/>
+          <p:nvPr/>
+        </p:nvSpPr>
+        <p:spPr>
+          <a:xfrm>
+            <a:off x="11292840" y="6510528"/>
+            <a:ext cx="777240" cy="274320"/>
+          </a:xfrm>
+          <a:prstGeom prst="rect">
+            <a:avLst/>
+          </a:prstGeom>
+          <a:noFill/>
+          <a:ln/>
+        </p:spPr>
+        <p:txBody>
+          <a:bodyPr wrap="square" lIns="0" tIns="0" rIns="0" bIns="0" rtlCol="0" anchor="ctr"/>
+          <a:lstStyle/>
+          <a:p>
+            <a:pPr algn="r" indent="0" marL="0">
+              <a:buNone/>
+            </a:pPr>
+            <a:r>
+              <a:rPr lang="en-US" sz="1000" dirty="0">
+                <a:solidFill>
+                  <a:srgbClr val="6B6B6B"/>
+                </a:solidFill>
+                <a:latin typeface="Calibri" pitchFamily="34" charset="0"/>
+                <a:ea typeface="Calibri" pitchFamily="34" charset="-122"/>
+                <a:cs typeface="Calibri" pitchFamily="34" charset="-120"/>
+              </a:rPr>
+              <a:t>4 / 12</a:t>
+            </a:r>
+            <a:endParaRPr lang="en-US" sz="1000" dirty="0"/>
+          </a:p>
+        </p:txBody>
+      </p:sp>
     </p:spTree>
   </p:cSld>
   <p:clrMapOvr>
@@ -3946,9 +5401,9 @@
 </p:sld>
 </file>
 
-<file path=ppt/slides/slide4.xml><?xml version="1.0" encoding="utf-8"?>
+<file path=ppt/slides/slide5.xml><?xml version="1.0" encoding="utf-8"?>
 <p:sld xmlns:a="http://schemas.openxmlformats.org/drawingml/2006/main" xmlns:r="http://schemas.openxmlformats.org/officeDocument/2006/relationships" xmlns:p="http://schemas.openxmlformats.org/presentationml/2006/main">
-  <p:cSld name="Slide 4">
+  <p:cSld name="Slide 5">
     <p:bg>
       <p:bgPr>
         <a:solidFill>
@@ -4003,7 +5458,7 @@
                 <a:ea typeface="Cambria" pitchFamily="34" charset="-122"/>
                 <a:cs typeface="Cambria" pitchFamily="34" charset="-120"/>
               </a:rPr>
-              <a:t>Three Questions We Set Out to Answer</a:t>
+              <a:t>Three Hypotheses We Tested</a:t>
             </a:r>
             <a:endParaRPr lang="en-US" sz="3200" dirty="0"/>
           </a:p>
@@ -4078,6 +5533,20 @@
               <a:buNone/>
             </a:pPr>
             <a:r>
+              <a:rPr lang="en-US" sz="2400" b="1" dirty="0">
+                <a:solidFill>
+                  <a:srgbClr val="8FA3E0"/>
+                </a:solidFill>
+                <a:latin typeface="Calibri" pitchFamily="34" charset="0"/>
+                <a:ea typeface="Calibri" pitchFamily="34" charset="-122"/>
+                <a:cs typeface="Calibri" pitchFamily="34" charset="-120"/>
+              </a:rPr>
+              <a:t>Hypothesis 1  —  </a:t>
+            </a:r>
+            <a:pPr indent="0" marL="0">
+              <a:buNone/>
+            </a:pPr>
+            <a:r>
               <a:rPr lang="en-US" sz="2400" dirty="0">
                 <a:solidFill>
                   <a:srgbClr val="FFFFFF"/>
@@ -4161,6 +5630,20 @@
               <a:buNone/>
             </a:pPr>
             <a:r>
+              <a:rPr lang="en-US" sz="2400" b="1" dirty="0">
+                <a:solidFill>
+                  <a:srgbClr val="8FA3E0"/>
+                </a:solidFill>
+                <a:latin typeface="Calibri" pitchFamily="34" charset="0"/>
+                <a:ea typeface="Calibri" pitchFamily="34" charset="-122"/>
+                <a:cs typeface="Calibri" pitchFamily="34" charset="-120"/>
+              </a:rPr>
+              <a:t>Hypothesis 2  —  </a:t>
+            </a:r>
+            <a:pPr indent="0" marL="0">
+              <a:buNone/>
+            </a:pPr>
+            <a:r>
               <a:rPr lang="en-US" sz="2400" dirty="0">
                 <a:solidFill>
                   <a:srgbClr val="FFFFFF"/>
@@ -4244,221 +5727,70 @@
               <a:buNone/>
             </a:pPr>
             <a:r>
-              <a:rPr lang="en-US" sz="2400" dirty="0">
-                <a:solidFill>
-                  <a:srgbClr val="FFFFFF"/>
+              <a:rPr lang="en-US" sz="2400" b="1" dirty="0">
+                <a:solidFill>
+                  <a:srgbClr val="8FA3E0"/>
                 </a:solidFill>
                 <a:latin typeface="Calibri" pitchFamily="34" charset="0"/>
                 <a:ea typeface="Calibri" pitchFamily="34" charset="-122"/>
                 <a:cs typeface="Calibri" pitchFamily="34" charset="-120"/>
               </a:rPr>
-              <a:t>Is there a best time to buy?</a:t>
-            </a:r>
-            <a:endParaRPr lang="en-US" sz="2400" dirty="0"/>
-          </a:p>
-        </p:txBody>
-      </p:sp>
-    </p:spTree>
-  </p:cSld>
-  <p:clrMapOvr>
-    <a:masterClrMapping/>
-  </p:clrMapOvr>
-</p:sld>
-</file>
-
-<file path=ppt/slides/slide5.xml><?xml version="1.0" encoding="utf-8"?>
-<p:sld xmlns:a="http://schemas.openxmlformats.org/drawingml/2006/main" xmlns:r="http://schemas.openxmlformats.org/officeDocument/2006/relationships" xmlns:p="http://schemas.openxmlformats.org/presentationml/2006/main">
-  <p:cSld name="Slide 5">
-    <p:bg>
-      <p:bgPr>
-        <a:solidFill>
-          <a:srgbClr val="FFFFFF"/>
-        </a:solidFill>
-      </p:bgPr>
-    </p:bg>
-    <p:spTree>
-      <p:nvGrpSpPr>
-        <p:cNvPr id="1" name=""/>
-        <p:cNvGrpSpPr/>
-        <p:nvPr/>
-      </p:nvGrpSpPr>
-      <p:grpSpPr>
-        <a:xfrm>
-          <a:off x="0" y="0"/>
-          <a:ext cx="0" cy="0"/>
-          <a:chOff x="0" y="0"/>
-          <a:chExt cx="0" cy="0"/>
-        </a:xfrm>
-      </p:grpSpPr>
-      <p:sp>
-        <p:nvSpPr>
-          <p:cNvPr id="2" name="Text 0"/>
-          <p:cNvSpPr/>
-          <p:nvPr/>
-        </p:nvSpPr>
-        <p:spPr>
-          <a:xfrm>
-            <a:off x="640080" y="457200"/>
-            <a:ext cx="10881360" cy="777240"/>
-          </a:xfrm>
-          <a:prstGeom prst="rect">
-            <a:avLst/>
-          </a:prstGeom>
-          <a:noFill/>
-          <a:ln/>
-        </p:spPr>
-        <p:txBody>
-          <a:bodyPr wrap="square" lIns="0" tIns="0" rIns="0" bIns="0" rtlCol="0" anchor="ctr"/>
-          <a:lstStyle/>
-          <a:p>
+              <a:t>Hypothesis 3  —  </a:t>
+            </a:r>
             <a:pPr indent="0" marL="0">
               <a:buNone/>
             </a:pPr>
             <a:r>
-              <a:rPr lang="en-US" sz="3200" b="1" dirty="0">
-                <a:solidFill>
-                  <a:srgbClr val="1E2761"/>
-                </a:solidFill>
-                <a:latin typeface="Cambria" pitchFamily="34" charset="0"/>
-                <a:ea typeface="Cambria" pitchFamily="34" charset="-122"/>
-                <a:cs typeface="Cambria" pitchFamily="34" charset="-120"/>
-              </a:rPr>
-              <a:t>Location Commands a Premium</a:t>
-            </a:r>
-            <a:endParaRPr lang="en-US" sz="3200" dirty="0"/>
-          </a:p>
-        </p:txBody>
-      </p:sp>
-      <p:graphicFrame>
-        <p:nvGraphicFramePr>
-          <p:cNvPr id="3" name="Chart 0" descr=""/>
-          <p:cNvGraphicFramePr/>
-          <p:nvPr/>
-        </p:nvGraphicFramePr>
-        <p:xfrm>
-          <a:off x="640080" y="1417320"/>
-          <a:ext cx="6035040" cy="4480560"/>
-        </p:xfrm>
-        <a:graphic xmlns:a="http://schemas.openxmlformats.org/drawingml/2006/main">
-          <a:graphicData uri="http://schemas.openxmlformats.org/drawingml/2006/chart">
-            <c:chart xmlns:c="http://schemas.openxmlformats.org/drawingml/2006/chart" r:id="rId1"/>
-          </a:graphicData>
-        </a:graphic>
-      </p:graphicFrame>
-      <p:sp>
-        <p:nvSpPr>
-          <p:cNvPr id="4" name="Text 1"/>
-          <p:cNvSpPr/>
-          <p:nvPr/>
-        </p:nvSpPr>
-        <p:spPr>
-          <a:xfrm>
-            <a:off x="7040880" y="1828800"/>
-            <a:ext cx="4572000" cy="777240"/>
-          </a:xfrm>
-          <a:prstGeom prst="rect">
-            <a:avLst/>
-          </a:prstGeom>
-          <a:noFill/>
-          <a:ln/>
-        </p:spPr>
-        <p:txBody>
-          <a:bodyPr wrap="square" lIns="0" tIns="0" rIns="0" bIns="0" rtlCol="0" anchor="ctr"/>
-          <a:lstStyle/>
-          <a:p>
-            <a:pPr algn="ctr" indent="0" marL="0">
-              <a:buNone/>
-            </a:pPr>
-            <a:r>
-              <a:rPr lang="en-US" sz="4000" b="1" dirty="0">
-                <a:solidFill>
-                  <a:srgbClr val="1C7293"/>
-                </a:solidFill>
-                <a:latin typeface="Cambria" pitchFamily="34" charset="0"/>
-                <a:ea typeface="Cambria" pitchFamily="34" charset="-122"/>
-                <a:cs typeface="Cambria" pitchFamily="34" charset="-120"/>
-              </a:rPr>
-              <a:t>57%</a:t>
-            </a:r>
-            <a:endParaRPr lang="en-US" sz="4000" dirty="0"/>
-          </a:p>
-        </p:txBody>
-      </p:sp>
-      <p:sp>
-        <p:nvSpPr>
-          <p:cNvPr id="5" name="Text 2"/>
-          <p:cNvSpPr/>
-          <p:nvPr/>
-        </p:nvSpPr>
-        <p:spPr>
-          <a:xfrm>
-            <a:off x="7040880" y="2560320"/>
-            <a:ext cx="4572000" cy="502920"/>
-          </a:xfrm>
-          <a:prstGeom prst="rect">
-            <a:avLst/>
-          </a:prstGeom>
-          <a:noFill/>
-          <a:ln/>
-        </p:spPr>
-        <p:txBody>
-          <a:bodyPr wrap="square" lIns="0" tIns="0" rIns="0" bIns="0" rtlCol="0" anchor="ctr"/>
-          <a:lstStyle/>
-          <a:p>
-            <a:pPr algn="ctr" indent="0" marL="0">
-              <a:buNone/>
-            </a:pPr>
-            <a:r>
-              <a:rPr lang="en-US" sz="1300" dirty="0">
-                <a:solidFill>
-                  <a:srgbClr val="6B6B6B"/>
+              <a:rPr lang="en-US" sz="2400" dirty="0">
+                <a:solidFill>
+                  <a:srgbClr val="FFFFFF"/>
                 </a:solidFill>
                 <a:latin typeface="Calibri" pitchFamily="34" charset="0"/>
                 <a:ea typeface="Calibri" pitchFamily="34" charset="-122"/>
                 <a:cs typeface="Calibri" pitchFamily="34" charset="-120"/>
               </a:rPr>
-              <a:t>more per square foot within ~6 miles of downtown Seattle</a:t>
-            </a:r>
-            <a:endParaRPr lang="en-US" sz="1300" dirty="0"/>
-          </a:p>
-        </p:txBody>
-      </p:sp>
-      <p:sp>
-        <p:nvSpPr>
-          <p:cNvPr id="6" name="Text 3"/>
-          <p:cNvSpPr/>
-          <p:nvPr/>
-        </p:nvSpPr>
-        <p:spPr>
-          <a:xfrm>
-            <a:off x="7040880" y="3657600"/>
-            <a:ext cx="4572000" cy="2377440"/>
-          </a:xfrm>
-          <a:prstGeom prst="rect">
-            <a:avLst/>
-          </a:prstGeom>
-          <a:noFill/>
-          <a:ln/>
-        </p:spPr>
-        <p:txBody>
-          <a:bodyPr wrap="square" lIns="0" tIns="0" rIns="0" bIns="0" rtlCol="0" anchor="ctr"/>
-          <a:lstStyle/>
-          <a:p>
-            <a:pPr indent="0" marL="0">
-              <a:buNone/>
-            </a:pPr>
-            <a:r>
-              <a:rPr lang="en-US" sz="1400" dirty="0">
-                <a:solidFill>
-                  <a:srgbClr val="6B6B6B"/>
+              <a:t>Is there a best time to buy?</a:t>
+            </a:r>
+            <a:endParaRPr lang="en-US" sz="2400" dirty="0"/>
+          </a:p>
+        </p:txBody>
+      </p:sp>
+      <p:sp>
+        <p:nvSpPr>
+          <p:cNvPr id="13" name="Text 7"/>
+          <p:cNvSpPr/>
+          <p:nvPr/>
+        </p:nvSpPr>
+        <p:spPr>
+          <a:xfrm>
+            <a:off x="11292840" y="6510528"/>
+            <a:ext cx="777240" cy="274320"/>
+          </a:xfrm>
+          <a:prstGeom prst="rect">
+            <a:avLst/>
+          </a:prstGeom>
+          <a:noFill/>
+          <a:ln/>
+        </p:spPr>
+        <p:txBody>
+          <a:bodyPr wrap="square" lIns="0" tIns="0" rIns="0" bIns="0" rtlCol="0" anchor="ctr"/>
+          <a:lstStyle/>
+          <a:p>
+            <a:pPr algn="r" indent="0" marL="0">
+              <a:buNone/>
+            </a:pPr>
+            <a:r>
+              <a:rPr lang="en-US" sz="1000" dirty="0">
+                <a:solidFill>
+                  <a:srgbClr val="CADCFC"/>
                 </a:solidFill>
                 <a:latin typeface="Calibri" pitchFamily="34" charset="0"/>
                 <a:ea typeface="Calibri" pitchFamily="34" charset="-122"/>
                 <a:cs typeface="Calibri" pitchFamily="34" charset="-120"/>
               </a:rPr>
-              <a:t>Large-lot “country” homes don’t sell for less overall — but they do cost less per square foot of living space, since the buyer is paying for land, not finished floor area.</a:t>
-            </a:r>
-            <a:endParaRPr lang="en-US" sz="1400" dirty="0"/>
+              <a:t>5 / 12</a:t>
+            </a:r>
+            <a:endParaRPr lang="en-US" sz="1000" dirty="0"/>
           </a:p>
         </p:txBody>
       </p:sp>
@@ -4503,7 +5835,7 @@
         <p:spPr>
           <a:xfrm>
             <a:off x="640080" y="457200"/>
-            <a:ext cx="10881360" cy="777240"/>
+            <a:ext cx="10881360" cy="640080"/>
           </a:xfrm>
           <a:prstGeom prst="rect">
             <a:avLst/>
@@ -4527,21 +5859,80 @@
                 <a:ea typeface="Cambria" pitchFamily="34" charset="-122"/>
                 <a:cs typeface="Cambria" pitchFamily="34" charset="-120"/>
               </a:rPr>
-              <a:t>Non-Renovated Homes Cost Less — By Design</a:t>
+              <a:t>Location Commands a Premium</a:t>
             </a:r>
             <a:endParaRPr lang="en-US" sz="3000" dirty="0"/>
+          </a:p>
+        </p:txBody>
+      </p:sp>
+      <p:sp>
+        <p:nvSpPr>
+          <p:cNvPr id="3" name="Text 1"/>
+          <p:cNvSpPr/>
+          <p:nvPr/>
+        </p:nvSpPr>
+        <p:spPr>
+          <a:xfrm>
+            <a:off x="640080" y="1097280"/>
+            <a:ext cx="10881360" cy="548640"/>
+          </a:xfrm>
+          <a:prstGeom prst="rect">
+            <a:avLst/>
+          </a:prstGeom>
+          <a:noFill/>
+          <a:ln/>
+        </p:spPr>
+        <p:txBody>
+          <a:bodyPr wrap="square" lIns="0" tIns="0" rIns="0" bIns="0" rtlCol="0" anchor="ctr"/>
+          <a:lstStyle/>
+          <a:p>
+            <a:pPr indent="0" marL="0">
+              <a:lnSpc>
+                <a:spcPct val="105000"/>
+              </a:lnSpc>
+              <a:buNone/>
+            </a:pPr>
+            <a:r>
+              <a:rPr lang="en-US" sz="1600" b="1" dirty="0">
+                <a:solidFill>
+                  <a:srgbClr val="1C7293"/>
+                </a:solidFill>
+                <a:latin typeface="Calibri" pitchFamily="34" charset="0"/>
+                <a:ea typeface="Calibri" pitchFamily="34" charset="-122"/>
+                <a:cs typeface="Calibri" pitchFamily="34" charset="-120"/>
+              </a:rPr>
+              <a:t>BOTTOM LINE:  </a:t>
+            </a:r>
+            <a:pPr indent="0" marL="0">
+              <a:lnSpc>
+                <a:spcPct val="105000"/>
+              </a:lnSpc>
+              <a:buNone/>
+            </a:pPr>
+            <a:r>
+              <a:rPr lang="en-US" sz="1600" dirty="0">
+                <a:solidFill>
+                  <a:srgbClr val="1C7293"/>
+                </a:solidFill>
+                <a:latin typeface="Calibri" pitchFamily="34" charset="0"/>
+                <a:ea typeface="Calibri" pitchFamily="34" charset="-122"/>
+                <a:cs typeface="Calibri" pitchFamily="34" charset="-120"/>
+              </a:rPr>
+              <a:t>a home within ~6 miles of downtown Seattle costs about 57% more per square foot than one farther out.</a:t>
+            </a:r>
+            <a:endParaRPr lang="en-US" sz="1600" dirty="0"/>
           </a:p>
         </p:txBody>
       </p:sp>
       <p:graphicFrame>
         <p:nvGraphicFramePr>
-          <p:cNvPr id="3" name="Chart 0" descr=""/>
+          <p:cNvPr id="4" name="Chart 0" descr=""/>
           <p:cNvGraphicFramePr/>
           <p:nvPr/>
         </p:nvGraphicFramePr>
         <p:xfrm>
-          <a:off x="640080" y="1417320"/>
-          <a:ext cx="6035040" cy="4480560"/>
+          <a:off x="822960" y="1874520"/>
+          <a:ext cx="5760720" cy="4023360"/>
         </p:xfrm>
         <a:graphic xmlns:a="http://schemas.openxmlformats.org/drawingml/2006/main">
           <a:graphicData uri="http://schemas.openxmlformats.org/drawingml/2006/chart">
@@ -4551,69 +5942,33 @@
       </p:graphicFrame>
       <p:sp>
         <p:nvSpPr>
-          <p:cNvPr id="4" name="Text 1"/>
-          <p:cNvSpPr/>
-          <p:nvPr/>
-        </p:nvSpPr>
-        <p:spPr>
-          <a:xfrm>
-            <a:off x="7040880" y="1828800"/>
-            <a:ext cx="4572000" cy="777240"/>
-          </a:xfrm>
-          <a:prstGeom prst="rect">
-            <a:avLst/>
-          </a:prstGeom>
-          <a:noFill/>
-          <a:ln/>
-        </p:spPr>
-        <p:txBody>
-          <a:bodyPr wrap="square" lIns="0" tIns="0" rIns="0" bIns="0" rtlCol="0" anchor="ctr"/>
-          <a:lstStyle/>
-          <a:p>
-            <a:pPr algn="ctr" indent="0" marL="0">
-              <a:buNone/>
-            </a:pPr>
-            <a:r>
-              <a:rPr lang="en-US" sz="4000" b="1" dirty="0">
-                <a:solidFill>
-                  <a:srgbClr val="2C5F2D"/>
-                </a:solidFill>
-                <a:latin typeface="Cambria" pitchFamily="34" charset="0"/>
-                <a:ea typeface="Cambria" pitchFamily="34" charset="-122"/>
-                <a:cs typeface="Cambria" pitchFamily="34" charset="-120"/>
-              </a:rPr>
-              <a:t>97%</a:t>
-            </a:r>
-            <a:endParaRPr lang="en-US" sz="4000" dirty="0"/>
-          </a:p>
-        </p:txBody>
-      </p:sp>
-      <p:sp>
-        <p:nvSpPr>
           <p:cNvPr id="5" name="Text 2"/>
           <p:cNvSpPr/>
           <p:nvPr/>
         </p:nvSpPr>
         <p:spPr>
           <a:xfrm>
-            <a:off x="7040880" y="2560320"/>
-            <a:ext cx="4572000" cy="502920"/>
-          </a:xfrm>
-          <a:prstGeom prst="rect">
-            <a:avLst/>
-          </a:prstGeom>
-          <a:noFill/>
-          <a:ln/>
-        </p:spPr>
-        <p:txBody>
-          <a:bodyPr wrap="square" lIns="0" tIns="0" rIns="0" bIns="0" rtlCol="0" anchor="ctr"/>
-          <a:lstStyle/>
-          <a:p>
-            <a:pPr algn="ctr" indent="0" marL="0">
-              <a:buNone/>
-            </a:pPr>
-            <a:r>
-              <a:rPr lang="en-US" sz="1300" dirty="0">
+            <a:off x="6949440" y="2194560"/>
+            <a:ext cx="4663440" cy="2560320"/>
+          </a:xfrm>
+          <a:prstGeom prst="rect">
+            <a:avLst/>
+          </a:prstGeom>
+          <a:noFill/>
+          <a:ln/>
+        </p:spPr>
+        <p:txBody>
+          <a:bodyPr wrap="square" lIns="0" tIns="0" rIns="0" bIns="0" rtlCol="0" anchor="ctr"/>
+          <a:lstStyle/>
+          <a:p>
+            <a:pPr indent="0" marL="0">
+              <a:lnSpc>
+                <a:spcPct val="120000"/>
+              </a:lnSpc>
+              <a:buNone/>
+            </a:pPr>
+            <a:r>
+              <a:rPr lang="en-US" sz="1500" dirty="0">
                 <a:solidFill>
                   <a:srgbClr val="6B6B6B"/>
                 </a:solidFill>
@@ -4621,38 +5976,38 @@
                 <a:ea typeface="Calibri" pitchFamily="34" charset="-122"/>
                 <a:cs typeface="Calibri" pitchFamily="34" charset="-120"/>
               </a:rPr>
-              <a:t>of King County homes have no renovation on record</a:t>
-            </a:r>
-            <a:endParaRPr lang="en-US" sz="1300" dirty="0"/>
-          </a:p>
-        </p:txBody>
-      </p:sp>
-      <p:sp>
-        <p:nvSpPr>
-          <p:cNvPr id="6" name="Text 3"/>
-          <p:cNvSpPr/>
-          <p:nvPr/>
-        </p:nvSpPr>
-        <p:spPr>
-          <a:xfrm>
-            <a:off x="7040880" y="3657600"/>
-            <a:ext cx="4572000" cy="2377440"/>
-          </a:xfrm>
-          <a:prstGeom prst="rect">
-            <a:avLst/>
-          </a:prstGeom>
-          <a:noFill/>
-          <a:ln/>
-        </p:spPr>
-        <p:txBody>
-          <a:bodyPr wrap="square" lIns="0" tIns="0" rIns="0" bIns="0" rtlCol="0" anchor="ctr"/>
-          <a:lstStyle/>
-          <a:p>
-            <a:pPr indent="0" marL="0">
-              <a:buNone/>
-            </a:pPr>
-            <a:r>
-              <a:rPr lang="en-US" sz="1400" dirty="0">
+              <a:t>Large-lot “country” homes don’t sell for less overall — but they do cost less per square foot of living space, since the buyer is paying for land, not finished floor area.</a:t>
+            </a:r>
+            <a:endParaRPr lang="en-US" sz="1500" dirty="0"/>
+          </a:p>
+        </p:txBody>
+      </p:sp>
+      <p:sp>
+        <p:nvSpPr>
+          <p:cNvPr id="7" name="Text 3"/>
+          <p:cNvSpPr/>
+          <p:nvPr/>
+        </p:nvSpPr>
+        <p:spPr>
+          <a:xfrm>
+            <a:off x="11292840" y="6510528"/>
+            <a:ext cx="777240" cy="274320"/>
+          </a:xfrm>
+          <a:prstGeom prst="rect">
+            <a:avLst/>
+          </a:prstGeom>
+          <a:noFill/>
+          <a:ln/>
+        </p:spPr>
+        <p:txBody>
+          <a:bodyPr wrap="square" lIns="0" tIns="0" rIns="0" bIns="0" rtlCol="0" anchor="ctr"/>
+          <a:lstStyle/>
+          <a:p>
+            <a:pPr algn="r" indent="0" marL="0">
+              <a:buNone/>
+            </a:pPr>
+            <a:r>
+              <a:rPr lang="en-US" sz="1000" dirty="0">
                 <a:solidFill>
                   <a:srgbClr val="6B6B6B"/>
                 </a:solidFill>
@@ -4660,9 +6015,9 @@
                 <a:ea typeface="Calibri" pitchFamily="34" charset="-122"/>
                 <a:cs typeface="Calibri" pitchFamily="34" charset="-120"/>
               </a:rPr>
-              <a:t>Among large-lot properties, renovated homes carry a ~34% premium. Non-renovated homes aren’t a compromise — they’re the norm, and they’re the cheaper option.</a:t>
-            </a:r>
-            <a:endParaRPr lang="en-US" sz="1400" dirty="0"/>
+              <a:t>6 / 12</a:t>
+            </a:r>
+            <a:endParaRPr lang="en-US" sz="1000" dirty="0"/>
           </a:p>
         </p:txBody>
       </p:sp>
@@ -4707,7 +6062,7 @@
         <p:spPr>
           <a:xfrm>
             <a:off x="640080" y="457200"/>
-            <a:ext cx="10881360" cy="548640"/>
+            <a:ext cx="10881360" cy="640080"/>
           </a:xfrm>
           <a:prstGeom prst="rect">
             <a:avLst/>
@@ -4723,7 +6078,7 @@
               <a:buNone/>
             </a:pPr>
             <a:r>
-              <a:rPr lang="en-US" sz="3000" b="1" dirty="0">
+              <a:rPr lang="en-US" sz="2700" b="1" dirty="0">
                 <a:solidFill>
                   <a:srgbClr val="1E2761"/>
                 </a:solidFill>
@@ -4731,9 +6086,9 @@
                 <a:ea typeface="Cambria" pitchFamily="34" charset="-122"/>
                 <a:cs typeface="Cambria" pitchFamily="34" charset="-120"/>
               </a:rPr>
-              <a:t>When You Buy Determines What You Pay</a:t>
-            </a:r>
-            <a:endParaRPr lang="en-US" sz="3000" dirty="0"/>
+              <a:t>Non-Renovated Homes Cost Less — By Design</a:t>
+            </a:r>
+            <a:endParaRPr lang="en-US" sz="2700" dirty="0"/>
           </a:p>
         </p:txBody>
       </p:sp>
@@ -4745,8 +6100,8 @@
         </p:nvSpPr>
         <p:spPr>
           <a:xfrm>
-            <a:off x="640080" y="1024128"/>
-            <a:ext cx="10881360" cy="365760"/>
+            <a:off x="640080" y="1097280"/>
+            <a:ext cx="10881360" cy="548640"/>
           </a:xfrm>
           <a:prstGeom prst="rect">
             <a:avLst/>
@@ -4759,20 +6114,40 @@
           <a:lstStyle/>
           <a:p>
             <a:pPr indent="0" marL="0">
-              <a:buNone/>
-            </a:pPr>
-            <a:r>
-              <a:rPr lang="en-US" sz="1300" i="1" dirty="0">
-                <a:solidFill>
-                  <a:srgbClr val="6B6B6B"/>
+              <a:lnSpc>
+                <a:spcPct val="105000"/>
+              </a:lnSpc>
+              <a:buNone/>
+            </a:pPr>
+            <a:r>
+              <a:rPr lang="en-US" sz="1600" b="1" dirty="0">
+                <a:solidFill>
+                  <a:srgbClr val="2C5F2D"/>
                 </a:solidFill>
                 <a:latin typeface="Calibri" pitchFamily="34" charset="0"/>
                 <a:ea typeface="Calibri" pitchFamily="34" charset="-122"/>
                 <a:cs typeface="Calibri" pitchFamily="34" charset="-120"/>
               </a:rPr>
-              <a:t>Country homes specifically — city homes follow a different, later-year pattern.</a:t>
-            </a:r>
-            <a:endParaRPr lang="en-US" sz="1300" dirty="0"/>
+              <a:t>BOTTOM LINE:  </a:t>
+            </a:r>
+            <a:pPr indent="0" marL="0">
+              <a:lnSpc>
+                <a:spcPct val="105000"/>
+              </a:lnSpc>
+              <a:buNone/>
+            </a:pPr>
+            <a:r>
+              <a:rPr lang="en-US" sz="1600" dirty="0">
+                <a:solidFill>
+                  <a:srgbClr val="2C5F2D"/>
+                </a:solidFill>
+                <a:latin typeface="Calibri" pitchFamily="34" charset="0"/>
+                <a:ea typeface="Calibri" pitchFamily="34" charset="-122"/>
+                <a:cs typeface="Calibri" pitchFamily="34" charset="-120"/>
+              </a:rPr>
+              <a:t>non-renovated homes are both the norm (97% of listings) and the cheaper option — a ~34% savings among large-lot homes.</a:t>
+            </a:r>
+            <a:endParaRPr lang="en-US" sz="1600" dirty="0"/>
           </a:p>
         </p:txBody>
       </p:sp>
@@ -4783,8 +6158,8 @@
           <p:nvPr/>
         </p:nvGraphicFramePr>
         <p:xfrm>
-          <a:off x="548640" y="1508760"/>
-          <a:ext cx="11064240" cy="3886200"/>
+          <a:off x="822960" y="1874520"/>
+          <a:ext cx="5760720" cy="4023360"/>
         </p:xfrm>
         <a:graphic xmlns:a="http://schemas.openxmlformats.org/drawingml/2006/main">
           <a:graphicData uri="http://schemas.openxmlformats.org/drawingml/2006/chart">
@@ -4800,63 +6175,27 @@
         </p:nvSpPr>
         <p:spPr>
           <a:xfrm>
-            <a:off x="822960" y="5577840"/>
-            <a:ext cx="5212080" cy="777240"/>
-          </a:xfrm>
-          <a:prstGeom prst="rect">
-            <a:avLst/>
-          </a:prstGeom>
-          <a:noFill/>
-          <a:ln/>
-        </p:spPr>
-        <p:txBody>
-          <a:bodyPr wrap="square" lIns="0" tIns="0" rIns="0" bIns="0" rtlCol="0" anchor="ctr"/>
-          <a:lstStyle/>
-          <a:p>
-            <a:pPr algn="ctr" indent="0" marL="0">
-              <a:buNone/>
-            </a:pPr>
-            <a:r>
-              <a:rPr lang="en-US" sz="4000" b="1" dirty="0">
-                <a:solidFill>
-                  <a:srgbClr val="1C7293"/>
-                </a:solidFill>
-                <a:latin typeface="Cambria" pitchFamily="34" charset="0"/>
-                <a:ea typeface="Cambria" pitchFamily="34" charset="-122"/>
-                <a:cs typeface="Cambria" pitchFamily="34" charset="-120"/>
-              </a:rPr>
-              <a:t>Aug – $493,725</a:t>
-            </a:r>
-            <a:endParaRPr lang="en-US" sz="4000" dirty="0"/>
-          </a:p>
-        </p:txBody>
-      </p:sp>
-      <p:sp>
-        <p:nvSpPr>
-          <p:cNvPr id="6" name="Text 3"/>
-          <p:cNvSpPr/>
-          <p:nvPr/>
-        </p:nvSpPr>
-        <p:spPr>
-          <a:xfrm>
-            <a:off x="822960" y="6309360"/>
-            <a:ext cx="5212080" cy="502920"/>
-          </a:xfrm>
-          <a:prstGeom prst="rect">
-            <a:avLst/>
-          </a:prstGeom>
-          <a:noFill/>
-          <a:ln/>
-        </p:spPr>
-        <p:txBody>
-          <a:bodyPr wrap="square" lIns="0" tIns="0" rIns="0" bIns="0" rtlCol="0" anchor="ctr"/>
-          <a:lstStyle/>
-          <a:p>
-            <a:pPr algn="ctr" indent="0" marL="0">
-              <a:buNone/>
-            </a:pPr>
-            <a:r>
-              <a:rPr lang="en-US" sz="1300" dirty="0">
+            <a:off x="6949440" y="2194560"/>
+            <a:ext cx="4663440" cy="2560320"/>
+          </a:xfrm>
+          <a:prstGeom prst="rect">
+            <a:avLst/>
+          </a:prstGeom>
+          <a:noFill/>
+          <a:ln/>
+        </p:spPr>
+        <p:txBody>
+          <a:bodyPr wrap="square" lIns="0" tIns="0" rIns="0" bIns="0" rtlCol="0" anchor="ctr"/>
+          <a:lstStyle/>
+          <a:p>
+            <a:pPr indent="0" marL="0">
+              <a:lnSpc>
+                <a:spcPct val="120000"/>
+              </a:lnSpc>
+              <a:buNone/>
+            </a:pPr>
+            <a:r>
+              <a:rPr lang="en-US" sz="1500" dirty="0">
                 <a:solidFill>
                   <a:srgbClr val="6B6B6B"/>
                 </a:solidFill>
@@ -4864,77 +6203,38 @@
                 <a:ea typeface="Calibri" pitchFamily="34" charset="-122"/>
                 <a:cs typeface="Calibri" pitchFamily="34" charset="-120"/>
               </a:rPr>
-              <a:t>cheapest median price for country homes</a:t>
-            </a:r>
-            <a:endParaRPr lang="en-US" sz="1300" dirty="0"/>
-          </a:p>
-        </p:txBody>
-      </p:sp>
-      <p:sp>
-        <p:nvSpPr>
-          <p:cNvPr id="7" name="Text 4"/>
-          <p:cNvSpPr/>
-          <p:nvPr/>
-        </p:nvSpPr>
-        <p:spPr>
-          <a:xfrm>
-            <a:off x="6172200" y="5577840"/>
-            <a:ext cx="5212080" cy="777240"/>
-          </a:xfrm>
-          <a:prstGeom prst="rect">
-            <a:avLst/>
-          </a:prstGeom>
-          <a:noFill/>
-          <a:ln/>
-        </p:spPr>
-        <p:txBody>
-          <a:bodyPr wrap="square" lIns="0" tIns="0" rIns="0" bIns="0" rtlCol="0" anchor="ctr"/>
-          <a:lstStyle/>
-          <a:p>
-            <a:pPr algn="ctr" indent="0" marL="0">
-              <a:buNone/>
-            </a:pPr>
-            <a:r>
-              <a:rPr lang="en-US" sz="4000" b="1" dirty="0">
-                <a:solidFill>
-                  <a:srgbClr val="2C5F2D"/>
-                </a:solidFill>
-                <a:latin typeface="Cambria" pitchFamily="34" charset="0"/>
-                <a:ea typeface="Cambria" pitchFamily="34" charset="-122"/>
-                <a:cs typeface="Cambria" pitchFamily="34" charset="-120"/>
-              </a:rPr>
-              <a:t>May – 604 sales</a:t>
-            </a:r>
-            <a:endParaRPr lang="en-US" sz="4000" dirty="0"/>
-          </a:p>
-        </p:txBody>
-      </p:sp>
-      <p:sp>
-        <p:nvSpPr>
-          <p:cNvPr id="8" name="Text 5"/>
-          <p:cNvSpPr/>
-          <p:nvPr/>
-        </p:nvSpPr>
-        <p:spPr>
-          <a:xfrm>
-            <a:off x="6172200" y="6309360"/>
-            <a:ext cx="5212080" cy="502920"/>
-          </a:xfrm>
-          <a:prstGeom prst="rect">
-            <a:avLst/>
-          </a:prstGeom>
-          <a:noFill/>
-          <a:ln/>
-        </p:spPr>
-        <p:txBody>
-          <a:bodyPr wrap="square" lIns="0" tIns="0" rIns="0" bIns="0" rtlCol="0" anchor="ctr"/>
-          <a:lstStyle/>
-          <a:p>
-            <a:pPr algn="ctr" indent="0" marL="0">
-              <a:buNone/>
-            </a:pPr>
-            <a:r>
-              <a:rPr lang="en-US" sz="1300" dirty="0">
+              <a:t>97% of King County homes have no renovation on record. Non-renovated isn’t a compromise here — it’s the typical listing, which lines up well with William’s stated preference.</a:t>
+            </a:r>
+            <a:endParaRPr lang="en-US" sz="1500" dirty="0"/>
+          </a:p>
+        </p:txBody>
+      </p:sp>
+      <p:sp>
+        <p:nvSpPr>
+          <p:cNvPr id="7" name="Text 3"/>
+          <p:cNvSpPr/>
+          <p:nvPr/>
+        </p:nvSpPr>
+        <p:spPr>
+          <a:xfrm>
+            <a:off x="11292840" y="6510528"/>
+            <a:ext cx="777240" cy="274320"/>
+          </a:xfrm>
+          <a:prstGeom prst="rect">
+            <a:avLst/>
+          </a:prstGeom>
+          <a:noFill/>
+          <a:ln/>
+        </p:spPr>
+        <p:txBody>
+          <a:bodyPr wrap="square" lIns="0" tIns="0" rIns="0" bIns="0" rtlCol="0" anchor="ctr"/>
+          <a:lstStyle/>
+          <a:p>
+            <a:pPr algn="r" indent="0" marL="0">
+              <a:buNone/>
+            </a:pPr>
+            <a:r>
+              <a:rPr lang="en-US" sz="1000" dirty="0">
                 <a:solidFill>
                   <a:srgbClr val="6B6B6B"/>
                 </a:solidFill>
@@ -4942,9 +6242,9 @@
                 <a:ea typeface="Calibri" pitchFamily="34" charset="-122"/>
                 <a:cs typeface="Calibri" pitchFamily="34" charset="-120"/>
               </a:rPr>
-              <a:t>most country-home listings to choose from</a:t>
-            </a:r>
-            <a:endParaRPr lang="en-US" sz="1300" dirty="0"/>
+              <a:t>7 / 12</a:t>
+            </a:r>
+            <a:endParaRPr lang="en-US" sz="1000" dirty="0"/>
           </a:p>
         </p:txBody>
       </p:sp>
@@ -4959,6 +6259,386 @@
 <file path=ppt/slides/slide8.xml><?xml version="1.0" encoding="utf-8"?>
 <p:sld xmlns:a="http://schemas.openxmlformats.org/drawingml/2006/main" xmlns:r="http://schemas.openxmlformats.org/officeDocument/2006/relationships" xmlns:p="http://schemas.openxmlformats.org/presentationml/2006/main">
   <p:cSld name="Slide 8">
+    <p:bg>
+      <p:bgPr>
+        <a:solidFill>
+          <a:srgbClr val="FFFFFF"/>
+        </a:solidFill>
+      </p:bgPr>
+    </p:bg>
+    <p:spTree>
+      <p:nvGrpSpPr>
+        <p:cNvPr id="1" name=""/>
+        <p:cNvGrpSpPr/>
+        <p:nvPr/>
+      </p:nvGrpSpPr>
+      <p:grpSpPr>
+        <a:xfrm>
+          <a:off x="0" y="0"/>
+          <a:ext cx="0" cy="0"/>
+          <a:chOff x="0" y="0"/>
+          <a:chExt cx="0" cy="0"/>
+        </a:xfrm>
+      </p:grpSpPr>
+      <p:sp>
+        <p:nvSpPr>
+          <p:cNvPr id="2" name="Text 0"/>
+          <p:cNvSpPr/>
+          <p:nvPr/>
+        </p:nvSpPr>
+        <p:spPr>
+          <a:xfrm>
+            <a:off x="640080" y="411480"/>
+            <a:ext cx="10881360" cy="548640"/>
+          </a:xfrm>
+          <a:prstGeom prst="rect">
+            <a:avLst/>
+          </a:prstGeom>
+          <a:noFill/>
+          <a:ln/>
+        </p:spPr>
+        <p:txBody>
+          <a:bodyPr wrap="square" lIns="0" tIns="0" rIns="0" bIns="0" rtlCol="0" anchor="ctr"/>
+          <a:lstStyle/>
+          <a:p>
+            <a:pPr indent="0" marL="0">
+              <a:buNone/>
+            </a:pPr>
+            <a:r>
+              <a:rPr lang="en-US" sz="2700" b="1" dirty="0">
+                <a:solidFill>
+                  <a:srgbClr val="1E2761"/>
+                </a:solidFill>
+                <a:latin typeface="Cambria" pitchFamily="34" charset="0"/>
+                <a:ea typeface="Cambria" pitchFamily="34" charset="-122"/>
+                <a:cs typeface="Cambria" pitchFamily="34" charset="-120"/>
+              </a:rPr>
+              <a:t>When You Buy Determines What You Pay</a:t>
+            </a:r>
+            <a:endParaRPr lang="en-US" sz="2700" dirty="0"/>
+          </a:p>
+        </p:txBody>
+      </p:sp>
+      <p:sp>
+        <p:nvSpPr>
+          <p:cNvPr id="3" name="Text 1"/>
+          <p:cNvSpPr/>
+          <p:nvPr/>
+        </p:nvSpPr>
+        <p:spPr>
+          <a:xfrm>
+            <a:off x="640080" y="960120"/>
+            <a:ext cx="10881360" cy="548640"/>
+          </a:xfrm>
+          <a:prstGeom prst="rect">
+            <a:avLst/>
+          </a:prstGeom>
+          <a:noFill/>
+          <a:ln/>
+        </p:spPr>
+        <p:txBody>
+          <a:bodyPr wrap="square" lIns="0" tIns="0" rIns="0" bIns="0" rtlCol="0" anchor="ctr"/>
+          <a:lstStyle/>
+          <a:p>
+            <a:pPr indent="0" marL="0">
+              <a:lnSpc>
+                <a:spcPct val="105000"/>
+              </a:lnSpc>
+              <a:buNone/>
+            </a:pPr>
+            <a:r>
+              <a:rPr lang="en-US" sz="1600" b="1" dirty="0">
+                <a:solidFill>
+                  <a:srgbClr val="1E2761"/>
+                </a:solidFill>
+                <a:latin typeface="Calibri" pitchFamily="34" charset="0"/>
+                <a:ea typeface="Calibri" pitchFamily="34" charset="-122"/>
+                <a:cs typeface="Calibri" pitchFamily="34" charset="-120"/>
+              </a:rPr>
+              <a:t>BOTTOM LINE:  </a:t>
+            </a:r>
+            <a:pPr indent="0" marL="0">
+              <a:lnSpc>
+                <a:spcPct val="105000"/>
+              </a:lnSpc>
+              <a:buNone/>
+            </a:pPr>
+            <a:r>
+              <a:rPr lang="en-US" sz="1600" dirty="0">
+                <a:solidFill>
+                  <a:srgbClr val="1E2761"/>
+                </a:solidFill>
+                <a:latin typeface="Calibri" pitchFamily="34" charset="0"/>
+                <a:ea typeface="Calibri" pitchFamily="34" charset="-122"/>
+                <a:cs typeface="Calibri" pitchFamily="34" charset="-120"/>
+              </a:rPr>
+              <a:t>for country homes, August is the cheapest month to close (median $493,725) — worth timing around if savings matter most.</a:t>
+            </a:r>
+            <a:endParaRPr lang="en-US" sz="1600" dirty="0"/>
+          </a:p>
+        </p:txBody>
+      </p:sp>
+      <p:sp>
+        <p:nvSpPr>
+          <p:cNvPr id="4" name="Text 2"/>
+          <p:cNvSpPr/>
+          <p:nvPr/>
+        </p:nvSpPr>
+        <p:spPr>
+          <a:xfrm>
+            <a:off x="640080" y="1481328"/>
+            <a:ext cx="10881360" cy="320040"/>
+          </a:xfrm>
+          <a:prstGeom prst="rect">
+            <a:avLst/>
+          </a:prstGeom>
+          <a:noFill/>
+          <a:ln/>
+        </p:spPr>
+        <p:txBody>
+          <a:bodyPr wrap="square" lIns="0" tIns="0" rIns="0" bIns="0" rtlCol="0" anchor="ctr"/>
+          <a:lstStyle/>
+          <a:p>
+            <a:pPr indent="0" marL="0">
+              <a:buNone/>
+            </a:pPr>
+            <a:r>
+              <a:rPr lang="en-US" sz="1200" i="1" dirty="0">
+                <a:solidFill>
+                  <a:srgbClr val="6B6B6B"/>
+                </a:solidFill>
+                <a:latin typeface="Calibri" pitchFamily="34" charset="0"/>
+                <a:ea typeface="Calibri" pitchFamily="34" charset="-122"/>
+                <a:cs typeface="Calibri" pitchFamily="34" charset="-120"/>
+              </a:rPr>
+              <a:t>Country homes specifically — city homes follow a different, later-year pattern.</a:t>
+            </a:r>
+            <a:endParaRPr lang="en-US" sz="1200" dirty="0"/>
+          </a:p>
+        </p:txBody>
+      </p:sp>
+      <p:graphicFrame>
+        <p:nvGraphicFramePr>
+          <p:cNvPr id="5" name="Chart 0" descr=""/>
+          <p:cNvGraphicFramePr/>
+          <p:nvPr/>
+        </p:nvGraphicFramePr>
+        <p:xfrm>
+          <a:off x="548640" y="1920240"/>
+          <a:ext cx="11064240" cy="3520440"/>
+        </p:xfrm>
+        <a:graphic xmlns:a="http://schemas.openxmlformats.org/drawingml/2006/main">
+          <a:graphicData uri="http://schemas.openxmlformats.org/drawingml/2006/chart">
+            <c:chart xmlns:c="http://schemas.openxmlformats.org/drawingml/2006/chart" r:id="rId1"/>
+          </a:graphicData>
+        </a:graphic>
+      </p:graphicFrame>
+      <p:sp>
+        <p:nvSpPr>
+          <p:cNvPr id="6" name="Text 3"/>
+          <p:cNvSpPr/>
+          <p:nvPr/>
+        </p:nvSpPr>
+        <p:spPr>
+          <a:xfrm>
+            <a:off x="822960" y="5623560"/>
+            <a:ext cx="5212080" cy="777240"/>
+          </a:xfrm>
+          <a:prstGeom prst="rect">
+            <a:avLst/>
+          </a:prstGeom>
+          <a:noFill/>
+          <a:ln/>
+        </p:spPr>
+        <p:txBody>
+          <a:bodyPr wrap="square" lIns="0" tIns="0" rIns="0" bIns="0" rtlCol="0" anchor="ctr"/>
+          <a:lstStyle/>
+          <a:p>
+            <a:pPr algn="ctr" indent="0" marL="0">
+              <a:buNone/>
+            </a:pPr>
+            <a:r>
+              <a:rPr lang="en-US" sz="4000" b="1" dirty="0">
+                <a:solidFill>
+                  <a:srgbClr val="1C7293"/>
+                </a:solidFill>
+                <a:latin typeface="Cambria" pitchFamily="34" charset="0"/>
+                <a:ea typeface="Cambria" pitchFamily="34" charset="-122"/>
+                <a:cs typeface="Cambria" pitchFamily="34" charset="-120"/>
+              </a:rPr>
+              <a:t>Aug – $493,725</a:t>
+            </a:r>
+            <a:endParaRPr lang="en-US" sz="4000" dirty="0"/>
+          </a:p>
+        </p:txBody>
+      </p:sp>
+      <p:sp>
+        <p:nvSpPr>
+          <p:cNvPr id="7" name="Text 4"/>
+          <p:cNvSpPr/>
+          <p:nvPr/>
+        </p:nvSpPr>
+        <p:spPr>
+          <a:xfrm>
+            <a:off x="822960" y="6355080"/>
+            <a:ext cx="5212080" cy="502920"/>
+          </a:xfrm>
+          <a:prstGeom prst="rect">
+            <a:avLst/>
+          </a:prstGeom>
+          <a:noFill/>
+          <a:ln/>
+        </p:spPr>
+        <p:txBody>
+          <a:bodyPr wrap="square" lIns="0" tIns="0" rIns="0" bIns="0" rtlCol="0" anchor="ctr"/>
+          <a:lstStyle/>
+          <a:p>
+            <a:pPr algn="ctr" indent="0" marL="0">
+              <a:buNone/>
+            </a:pPr>
+            <a:r>
+              <a:rPr lang="en-US" sz="1300" dirty="0">
+                <a:solidFill>
+                  <a:srgbClr val="6B6B6B"/>
+                </a:solidFill>
+                <a:latin typeface="Calibri" pitchFamily="34" charset="0"/>
+                <a:ea typeface="Calibri" pitchFamily="34" charset="-122"/>
+                <a:cs typeface="Calibri" pitchFamily="34" charset="-120"/>
+              </a:rPr>
+              <a:t>cheapest median price for country homes</a:t>
+            </a:r>
+            <a:endParaRPr lang="en-US" sz="1300" dirty="0"/>
+          </a:p>
+        </p:txBody>
+      </p:sp>
+      <p:sp>
+        <p:nvSpPr>
+          <p:cNvPr id="8" name="Text 5"/>
+          <p:cNvSpPr/>
+          <p:nvPr/>
+        </p:nvSpPr>
+        <p:spPr>
+          <a:xfrm>
+            <a:off x="6172200" y="5623560"/>
+            <a:ext cx="5212080" cy="777240"/>
+          </a:xfrm>
+          <a:prstGeom prst="rect">
+            <a:avLst/>
+          </a:prstGeom>
+          <a:noFill/>
+          <a:ln/>
+        </p:spPr>
+        <p:txBody>
+          <a:bodyPr wrap="square" lIns="0" tIns="0" rIns="0" bIns="0" rtlCol="0" anchor="ctr"/>
+          <a:lstStyle/>
+          <a:p>
+            <a:pPr algn="ctr" indent="0" marL="0">
+              <a:buNone/>
+            </a:pPr>
+            <a:r>
+              <a:rPr lang="en-US" sz="4000" b="1" dirty="0">
+                <a:solidFill>
+                  <a:srgbClr val="2C5F2D"/>
+                </a:solidFill>
+                <a:latin typeface="Cambria" pitchFamily="34" charset="0"/>
+                <a:ea typeface="Cambria" pitchFamily="34" charset="-122"/>
+                <a:cs typeface="Cambria" pitchFamily="34" charset="-120"/>
+              </a:rPr>
+              <a:t>May – 604 sales</a:t>
+            </a:r>
+            <a:endParaRPr lang="en-US" sz="4000" dirty="0"/>
+          </a:p>
+        </p:txBody>
+      </p:sp>
+      <p:sp>
+        <p:nvSpPr>
+          <p:cNvPr id="9" name="Text 6"/>
+          <p:cNvSpPr/>
+          <p:nvPr/>
+        </p:nvSpPr>
+        <p:spPr>
+          <a:xfrm>
+            <a:off x="6172200" y="6355080"/>
+            <a:ext cx="5212080" cy="502920"/>
+          </a:xfrm>
+          <a:prstGeom prst="rect">
+            <a:avLst/>
+          </a:prstGeom>
+          <a:noFill/>
+          <a:ln/>
+        </p:spPr>
+        <p:txBody>
+          <a:bodyPr wrap="square" lIns="0" tIns="0" rIns="0" bIns="0" rtlCol="0" anchor="ctr"/>
+          <a:lstStyle/>
+          <a:p>
+            <a:pPr algn="ctr" indent="0" marL="0">
+              <a:buNone/>
+            </a:pPr>
+            <a:r>
+              <a:rPr lang="en-US" sz="1300" dirty="0">
+                <a:solidFill>
+                  <a:srgbClr val="6B6B6B"/>
+                </a:solidFill>
+                <a:latin typeface="Calibri" pitchFamily="34" charset="0"/>
+                <a:ea typeface="Calibri" pitchFamily="34" charset="-122"/>
+                <a:cs typeface="Calibri" pitchFamily="34" charset="-120"/>
+              </a:rPr>
+              <a:t>most country-home listings to choose from</a:t>
+            </a:r>
+            <a:endParaRPr lang="en-US" sz="1300" dirty="0"/>
+          </a:p>
+        </p:txBody>
+      </p:sp>
+      <p:sp>
+        <p:nvSpPr>
+          <p:cNvPr id="11" name="Text 7"/>
+          <p:cNvSpPr/>
+          <p:nvPr/>
+        </p:nvSpPr>
+        <p:spPr>
+          <a:xfrm>
+            <a:off x="11292840" y="6510528"/>
+            <a:ext cx="777240" cy="274320"/>
+          </a:xfrm>
+          <a:prstGeom prst="rect">
+            <a:avLst/>
+          </a:prstGeom>
+          <a:noFill/>
+          <a:ln/>
+        </p:spPr>
+        <p:txBody>
+          <a:bodyPr wrap="square" lIns="0" tIns="0" rIns="0" bIns="0" rtlCol="0" anchor="ctr"/>
+          <a:lstStyle/>
+          <a:p>
+            <a:pPr algn="r" indent="0" marL="0">
+              <a:buNone/>
+            </a:pPr>
+            <a:r>
+              <a:rPr lang="en-US" sz="1000" dirty="0">
+                <a:solidFill>
+                  <a:srgbClr val="6B6B6B"/>
+                </a:solidFill>
+                <a:latin typeface="Calibri" pitchFamily="34" charset="0"/>
+                <a:ea typeface="Calibri" pitchFamily="34" charset="-122"/>
+                <a:cs typeface="Calibri" pitchFamily="34" charset="-120"/>
+              </a:rPr>
+              <a:t>8 / 12</a:t>
+            </a:r>
+            <a:endParaRPr lang="en-US" sz="1000" dirty="0"/>
+          </a:p>
+        </p:txBody>
+      </p:sp>
+    </p:spTree>
+  </p:cSld>
+  <p:clrMapOvr>
+    <a:masterClrMapping/>
+  </p:clrMapOvr>
+</p:sld>
+</file>
+
+<file path=ppt/slides/slide9.xml><?xml version="1.0" encoding="utf-8"?>
+<p:sld xmlns:a="http://schemas.openxmlformats.org/drawingml/2006/main" xmlns:r="http://schemas.openxmlformats.org/officeDocument/2006/relationships" xmlns:p="http://schemas.openxmlformats.org/presentationml/2006/main">
+  <p:cSld name="Slide 9">
     <p:bg>
       <p:bgPr>
         <a:solidFill>
@@ -4988,8 +6668,8 @@
         </p:nvSpPr>
         <p:spPr>
           <a:xfrm>
-            <a:off x="731520" y="594360"/>
-            <a:ext cx="1005840" cy="1005840"/>
+            <a:off x="731520" y="457200"/>
+            <a:ext cx="914400" cy="914400"/>
           </a:xfrm>
           <a:prstGeom prst="ellipse">
             <a:avLst/>
@@ -5016,8 +6696,8 @@
         </p:blipFill>
         <p:spPr>
           <a:xfrm>
-            <a:off x="993038" y="855878"/>
-            <a:ext cx="482803" cy="482803"/>
+            <a:off x="969264" y="694944"/>
+            <a:ext cx="438912" cy="438912"/>
           </a:xfrm>
           <a:prstGeom prst="rect">
             <a:avLst/>
@@ -5032,8 +6712,8 @@
         </p:nvSpPr>
         <p:spPr>
           <a:xfrm>
-            <a:off x="1920240" y="548640"/>
-            <a:ext cx="9601200" cy="914400"/>
+            <a:off x="1828800" y="438912"/>
+            <a:ext cx="9509760" cy="777240"/>
           </a:xfrm>
           <a:prstGeom prst="rect">
             <a:avLst/>
@@ -5049,7 +6729,7 @@
               <a:buNone/>
             </a:pPr>
             <a:r>
-              <a:rPr lang="en-US" sz="3200" b="1" dirty="0">
+              <a:rPr lang="en-US" sz="2800" b="1" dirty="0">
                 <a:solidFill>
                   <a:srgbClr val="FFFFFF"/>
                 </a:solidFill>
@@ -5059,442 +6739,109 @@
               </a:rPr>
               <a:t>For the City Home  →  Zip 98118</a:t>
             </a:r>
-            <a:endParaRPr lang="en-US" sz="3200" dirty="0"/>
-          </a:p>
-        </p:txBody>
-      </p:sp>
-      <p:sp>
-        <p:nvSpPr>
-          <p:cNvPr id="5" name="Shape 2"/>
-          <p:cNvSpPr/>
-          <p:nvPr/>
-        </p:nvSpPr>
-        <p:spPr>
-          <a:xfrm>
-            <a:off x="731520" y="2377440"/>
-            <a:ext cx="3383280" cy="3017520"/>
-          </a:xfrm>
-          <a:prstGeom prst="roundRect">
-            <a:avLst>
-              <a:gd name="adj" fmla="val 3636"/>
-            </a:avLst>
-          </a:prstGeom>
-          <a:solidFill>
-            <a:srgbClr val="1A6D85"/>
-          </a:solidFill>
-          <a:ln/>
-        </p:spPr>
-      </p:sp>
-      <p:sp>
-        <p:nvSpPr>
-          <p:cNvPr id="6" name="Text 3"/>
-          <p:cNvSpPr/>
-          <p:nvPr/>
-        </p:nvSpPr>
-        <p:spPr>
-          <a:xfrm>
-            <a:off x="731520" y="2743200"/>
-            <a:ext cx="3383280" cy="822960"/>
-          </a:xfrm>
-          <a:prstGeom prst="rect">
-            <a:avLst/>
-          </a:prstGeom>
-          <a:noFill/>
-          <a:ln/>
-        </p:spPr>
-        <p:txBody>
-          <a:bodyPr wrap="square" lIns="0" tIns="0" rIns="0" bIns="0" rtlCol="0" anchor="ctr"/>
-          <a:lstStyle/>
-          <a:p>
-            <a:pPr algn="ctr" indent="0" marL="0">
-              <a:buNone/>
-            </a:pPr>
-            <a:r>
-              <a:rPr lang="en-US" sz="3400" b="1" dirty="0">
+            <a:endParaRPr lang="en-US" sz="2800" dirty="0"/>
+          </a:p>
+        </p:txBody>
+      </p:sp>
+      <p:sp>
+        <p:nvSpPr>
+          <p:cNvPr id="5" name="Text 2"/>
+          <p:cNvSpPr/>
+          <p:nvPr/>
+        </p:nvSpPr>
+        <p:spPr>
+          <a:xfrm>
+            <a:off x="640080" y="1280160"/>
+            <a:ext cx="10881360" cy="548640"/>
+          </a:xfrm>
+          <a:prstGeom prst="rect">
+            <a:avLst/>
+          </a:prstGeom>
+          <a:noFill/>
+          <a:ln/>
+        </p:spPr>
+        <p:txBody>
+          <a:bodyPr wrap="square" lIns="0" tIns="0" rIns="0" bIns="0" rtlCol="0" anchor="ctr"/>
+          <a:lstStyle/>
+          <a:p>
+            <a:pPr indent="0" marL="0">
+              <a:lnSpc>
+                <a:spcPct val="105000"/>
+              </a:lnSpc>
+              <a:buNone/>
+            </a:pPr>
+            <a:r>
+              <a:rPr lang="en-US" sz="1600" b="1" dirty="0">
                 <a:solidFill>
                   <a:srgbClr val="FFFFFF"/>
-                </a:solidFill>
-                <a:latin typeface="Cambria" pitchFamily="34" charset="0"/>
-                <a:ea typeface="Cambria" pitchFamily="34" charset="-122"/>
-                <a:cs typeface="Cambria" pitchFamily="34" charset="-120"/>
-              </a:rPr>
-              <a:t>7.9 km</a:t>
-            </a:r>
-            <a:endParaRPr lang="en-US" sz="3400" dirty="0"/>
-          </a:p>
-        </p:txBody>
-      </p:sp>
-      <p:sp>
-        <p:nvSpPr>
-          <p:cNvPr id="7" name="Text 4"/>
-          <p:cNvSpPr/>
-          <p:nvPr/>
-        </p:nvSpPr>
-        <p:spPr>
-          <a:xfrm>
-            <a:off x="1005840" y="3611880"/>
-            <a:ext cx="2834640" cy="1554480"/>
-          </a:xfrm>
-          <a:prstGeom prst="rect">
-            <a:avLst/>
-          </a:prstGeom>
-          <a:noFill/>
-          <a:ln/>
-        </p:spPr>
-        <p:txBody>
-          <a:bodyPr wrap="square" lIns="0" tIns="0" rIns="0" bIns="0" rtlCol="0" anchor="ctr"/>
-          <a:lstStyle/>
-          <a:p>
-            <a:pPr algn="ctr" indent="0" marL="0">
-              <a:buNone/>
-            </a:pPr>
-            <a:r>
-              <a:rPr lang="en-US" sz="1400" dirty="0">
-                <a:solidFill>
-                  <a:srgbClr val="CADCFC"/>
                 </a:solidFill>
                 <a:latin typeface="Calibri" pitchFamily="34" charset="0"/>
                 <a:ea typeface="Calibri" pitchFamily="34" charset="-122"/>
                 <a:cs typeface="Calibri" pitchFamily="34" charset="-120"/>
               </a:rPr>
-              <a:t>from downtown Seattle — the closest of the high-turnover zips</a:t>
-            </a:r>
-            <a:endParaRPr lang="en-US" sz="1400" dirty="0"/>
-          </a:p>
-        </p:txBody>
-      </p:sp>
-      <p:sp>
-        <p:nvSpPr>
-          <p:cNvPr id="8" name="Shape 5"/>
-          <p:cNvSpPr/>
-          <p:nvPr/>
-        </p:nvSpPr>
-        <p:spPr>
-          <a:xfrm>
-            <a:off x="4434840" y="2377440"/>
-            <a:ext cx="3383280" cy="3017520"/>
-          </a:xfrm>
-          <a:prstGeom prst="roundRect">
-            <a:avLst>
-              <a:gd name="adj" fmla="val 3636"/>
-            </a:avLst>
-          </a:prstGeom>
-          <a:solidFill>
-            <a:srgbClr val="1A6D85"/>
-          </a:solidFill>
-          <a:ln/>
-        </p:spPr>
-      </p:sp>
-      <p:sp>
-        <p:nvSpPr>
-          <p:cNvPr id="9" name="Text 6"/>
-          <p:cNvSpPr/>
-          <p:nvPr/>
-        </p:nvSpPr>
-        <p:spPr>
-          <a:xfrm>
-            <a:off x="4434840" y="2743200"/>
-            <a:ext cx="3383280" cy="822960"/>
-          </a:xfrm>
-          <a:prstGeom prst="rect">
-            <a:avLst/>
-          </a:prstGeom>
-          <a:noFill/>
-          <a:ln/>
-        </p:spPr>
-        <p:txBody>
-          <a:bodyPr wrap="square" lIns="0" tIns="0" rIns="0" bIns="0" rtlCol="0" anchor="ctr"/>
-          <a:lstStyle/>
-          <a:p>
-            <a:pPr algn="ctr" indent="0" marL="0">
-              <a:buNone/>
-            </a:pPr>
-            <a:r>
-              <a:rPr lang="en-US" sz="3400" b="1" dirty="0">
+              <a:t>BOTTOM LINE:  </a:t>
+            </a:r>
+            <a:pPr indent="0" marL="0">
+              <a:lnSpc>
+                <a:spcPct val="105000"/>
+              </a:lnSpc>
+              <a:buNone/>
+            </a:pPr>
+            <a:r>
+              <a:rPr lang="en-US" sz="1600" dirty="0">
                 <a:solidFill>
                   <a:srgbClr val="FFFFFF"/>
-                </a:solidFill>
-                <a:latin typeface="Cambria" pitchFamily="34" charset="0"/>
-                <a:ea typeface="Cambria" pitchFamily="34" charset="-122"/>
-                <a:cs typeface="Cambria" pitchFamily="34" charset="-120"/>
-              </a:rPr>
-              <a:t>507 sales</a:t>
-            </a:r>
-            <a:endParaRPr lang="en-US" sz="3400" dirty="0"/>
-          </a:p>
-        </p:txBody>
-      </p:sp>
-      <p:sp>
-        <p:nvSpPr>
-          <p:cNvPr id="10" name="Text 7"/>
-          <p:cNvSpPr/>
-          <p:nvPr/>
-        </p:nvSpPr>
-        <p:spPr>
-          <a:xfrm>
-            <a:off x="4709160" y="3611880"/>
-            <a:ext cx="2834640" cy="1554480"/>
-          </a:xfrm>
-          <a:prstGeom prst="rect">
-            <a:avLst/>
-          </a:prstGeom>
-          <a:noFill/>
-          <a:ln/>
-        </p:spPr>
-        <p:txBody>
-          <a:bodyPr wrap="square" lIns="0" tIns="0" rIns="0" bIns="0" rtlCol="0" anchor="ctr"/>
-          <a:lstStyle/>
-          <a:p>
-            <a:pPr algn="ctr" indent="0" marL="0">
-              <a:buNone/>
-            </a:pPr>
-            <a:r>
-              <a:rPr lang="en-US" sz="1400" dirty="0">
-                <a:solidFill>
-                  <a:srgbClr val="CADCFC"/>
                 </a:solidFill>
                 <a:latin typeface="Calibri" pitchFamily="34" charset="0"/>
                 <a:ea typeface="Calibri" pitchFamily="34" charset="-122"/>
                 <a:cs typeface="Calibri" pitchFamily="34" charset="-120"/>
               </a:rPr>
-              <a:t>in the 12-month window — highest turnover among affordable central zips</a:t>
-            </a:r>
-            <a:endParaRPr lang="en-US" sz="1400" dirty="0"/>
-          </a:p>
-        </p:txBody>
-      </p:sp>
-      <p:sp>
-        <p:nvSpPr>
-          <p:cNvPr id="11" name="Shape 8"/>
-          <p:cNvSpPr/>
-          <p:nvPr/>
-        </p:nvSpPr>
-        <p:spPr>
-          <a:xfrm>
-            <a:off x="8138160" y="2377440"/>
-            <a:ext cx="3383280" cy="3017520"/>
+              <a:t>98118 is the closest high-turnover, affordable zip to downtown — the strongest match for “fast and central.”</a:t>
+            </a:r>
+            <a:endParaRPr lang="en-US" sz="1600" dirty="0"/>
+          </a:p>
+        </p:txBody>
+      </p:sp>
+      <p:sp>
+        <p:nvSpPr>
+          <p:cNvPr id="6" name="Shape 3"/>
+          <p:cNvSpPr/>
+          <p:nvPr/>
+        </p:nvSpPr>
+        <p:spPr>
+          <a:xfrm>
+            <a:off x="640080" y="1965960"/>
+            <a:ext cx="5806440" cy="4160520"/>
           </a:xfrm>
           <a:prstGeom prst="roundRect">
             <a:avLst>
-              <a:gd name="adj" fmla="val 3636"/>
+              <a:gd name="adj" fmla="val 2198"/>
             </a:avLst>
           </a:prstGeom>
           <a:solidFill>
-            <a:srgbClr val="1A6D85"/>
-          </a:solidFill>
-          <a:ln/>
-        </p:spPr>
-      </p:sp>
-      <p:sp>
-        <p:nvSpPr>
-          <p:cNvPr id="12" name="Text 9"/>
-          <p:cNvSpPr/>
-          <p:nvPr/>
-        </p:nvSpPr>
-        <p:spPr>
-          <a:xfrm>
-            <a:off x="8138160" y="2743200"/>
-            <a:ext cx="3383280" cy="822960"/>
-          </a:xfrm>
-          <a:prstGeom prst="rect">
-            <a:avLst/>
-          </a:prstGeom>
-          <a:noFill/>
-          <a:ln/>
-        </p:spPr>
-        <p:txBody>
-          <a:bodyPr wrap="square" lIns="0" tIns="0" rIns="0" bIns="0" rtlCol="0" anchor="ctr"/>
-          <a:lstStyle/>
-          <a:p>
-            <a:pPr algn="ctr" indent="0" marL="0">
-              <a:buNone/>
-            </a:pPr>
-            <a:r>
-              <a:rPr lang="en-US" sz="3400" b="1" dirty="0">
-                <a:solidFill>
-                  <a:srgbClr val="FFFFFF"/>
-                </a:solidFill>
-                <a:latin typeface="Cambria" pitchFamily="34" charset="0"/>
-                <a:ea typeface="Cambria" pitchFamily="34" charset="-122"/>
-                <a:cs typeface="Cambria" pitchFamily="34" charset="-120"/>
-              </a:rPr>
-              <a:t>$367,500</a:t>
-            </a:r>
-            <a:endParaRPr lang="en-US" sz="3400" dirty="0"/>
-          </a:p>
-        </p:txBody>
-      </p:sp>
-      <p:sp>
-        <p:nvSpPr>
-          <p:cNvPr id="13" name="Text 10"/>
-          <p:cNvSpPr/>
-          <p:nvPr/>
-        </p:nvSpPr>
-        <p:spPr>
-          <a:xfrm>
-            <a:off x="8412480" y="3611880"/>
-            <a:ext cx="2834640" cy="1554480"/>
-          </a:xfrm>
-          <a:prstGeom prst="rect">
-            <a:avLst/>
-          </a:prstGeom>
-          <a:noFill/>
-          <a:ln/>
-        </p:spPr>
-        <p:txBody>
-          <a:bodyPr wrap="square" lIns="0" tIns="0" rIns="0" bIns="0" rtlCol="0" anchor="ctr"/>
-          <a:lstStyle/>
-          <a:p>
-            <a:pPr algn="ctr" indent="0" marL="0">
-              <a:buNone/>
-            </a:pPr>
-            <a:r>
-              <a:rPr lang="en-US" sz="1400" dirty="0">
-                <a:solidFill>
-                  <a:srgbClr val="CADCFC"/>
-                </a:solidFill>
-                <a:latin typeface="Calibri" pitchFamily="34" charset="0"/>
-                <a:ea typeface="Calibri" pitchFamily="34" charset="-122"/>
-                <a:cs typeface="Calibri" pitchFamily="34" charset="-120"/>
-              </a:rPr>
-              <a:t>median price — the most affordable of that group</a:t>
-            </a:r>
-            <a:endParaRPr lang="en-US" sz="1400" dirty="0"/>
-          </a:p>
-        </p:txBody>
-      </p:sp>
-      <p:sp>
-        <p:nvSpPr>
-          <p:cNvPr id="14" name="Text 11"/>
-          <p:cNvSpPr/>
-          <p:nvPr/>
-        </p:nvSpPr>
-        <p:spPr>
-          <a:xfrm>
-            <a:off x="731520" y="5760720"/>
-            <a:ext cx="10698480" cy="822960"/>
-          </a:xfrm>
-          <a:prstGeom prst="rect">
-            <a:avLst/>
-          </a:prstGeom>
-          <a:noFill/>
-          <a:ln/>
-        </p:spPr>
-        <p:txBody>
-          <a:bodyPr wrap="square" lIns="0" tIns="0" rIns="0" bIns="0" rtlCol="0" anchor="ctr"/>
-          <a:lstStyle/>
-          <a:p>
-            <a:pPr algn="ctr" indent="0" marL="0">
-              <a:lnSpc>
-                <a:spcPct val="115000"/>
-              </a:lnSpc>
-              <a:buNone/>
-            </a:pPr>
-            <a:r>
-              <a:rPr lang="en-US" sz="1300" i="1" dirty="0">
-                <a:solidFill>
-                  <a:srgbClr val="CADCFC"/>
-                </a:solidFill>
-                <a:latin typeface="Calibri" pitchFamily="34" charset="0"/>
-                <a:ea typeface="Calibri" pitchFamily="34" charset="-122"/>
-                <a:cs typeface="Calibri" pitchFamily="34" charset="-120"/>
-              </a:rPr>
-              <a:t>98103, 98115, and 98117 are strong second choices if 98118 doesn’t work out.</a:t>
-            </a:r>
-            <a:endParaRPr lang="en-US" sz="1300" dirty="0"/>
-          </a:p>
-          <a:p>
-            <a:pPr algn="ctr" indent="0" marL="0">
-              <a:lnSpc>
-                <a:spcPct val="115000"/>
-              </a:lnSpc>
-              <a:buNone/>
-            </a:pPr>
-            <a:r>
-              <a:rPr lang="en-US" sz="1300" i="1" dirty="0">
-                <a:solidFill>
-                  <a:srgbClr val="CADCFC"/>
-                </a:solidFill>
-                <a:latin typeface="Calibri" pitchFamily="34" charset="0"/>
-                <a:ea typeface="Calibri" pitchFamily="34" charset="-122"/>
-                <a:cs typeface="Calibri" pitchFamily="34" charset="-120"/>
-              </a:rPr>
-              <a:t>Filter to 1–3 bedrooms — plenty for a household of 2, and it avoids a ~41% size premium.</a:t>
-            </a:r>
-            <a:endParaRPr lang="en-US" sz="1300" dirty="0"/>
-          </a:p>
-        </p:txBody>
-      </p:sp>
-    </p:spTree>
-  </p:cSld>
-  <p:clrMapOvr>
-    <a:masterClrMapping/>
-  </p:clrMapOvr>
-</p:sld>
-</file>
-
-<file path=ppt/slides/slide9.xml><?xml version="1.0" encoding="utf-8"?>
-<p:sld xmlns:a="http://schemas.openxmlformats.org/drawingml/2006/main" xmlns:r="http://schemas.openxmlformats.org/officeDocument/2006/relationships" xmlns:p="http://schemas.openxmlformats.org/presentationml/2006/main">
-  <p:cSld name="Slide 9">
-    <p:bg>
-      <p:bgPr>
-        <a:solidFill>
-          <a:srgbClr val="2C5F2D"/>
-        </a:solidFill>
-      </p:bgPr>
-    </p:bg>
-    <p:spTree>
-      <p:nvGrpSpPr>
-        <p:cNvPr id="1" name=""/>
-        <p:cNvGrpSpPr/>
-        <p:nvPr/>
-      </p:nvGrpSpPr>
-      <p:grpSpPr>
-        <a:xfrm>
-          <a:off x="0" y="0"/>
-          <a:ext cx="0" cy="0"/>
-          <a:chOff x="0" y="0"/>
-          <a:chExt cx="0" cy="0"/>
-        </a:xfrm>
-      </p:grpSpPr>
-      <p:sp>
-        <p:nvSpPr>
-          <p:cNvPr id="2" name="Shape 0"/>
-          <p:cNvSpPr/>
-          <p:nvPr/>
-        </p:nvSpPr>
-        <p:spPr>
-          <a:xfrm>
-            <a:off x="731520" y="594360"/>
-            <a:ext cx="1005840" cy="1005840"/>
-          </a:xfrm>
-          <a:prstGeom prst="ellipse">
-            <a:avLst/>
-          </a:prstGeom>
-          <a:solidFill>
-            <a:srgbClr val="1E4620"/>
+            <a:srgbClr val="FFFFFF"/>
           </a:solidFill>
           <a:ln/>
         </p:spPr>
       </p:sp>
       <p:pic>
         <p:nvPicPr>
-          <p:cNvPr id="3" name="Image 0" descr="preencoded.png">    </p:cNvPr>
+          <p:cNvPr id="7" name="Image 1" descr="chart_slide9_zip_bubble.png">    </p:cNvPr>
           <p:cNvPicPr>
             <a:picLocks noChangeAspect="1"/>
           </p:cNvPicPr>
           <p:nvPr/>
         </p:nvPicPr>
         <p:blipFill>
-          <a:blip r:embed="rId1"/>
+          <a:blip r:embed="rId2"/>
           <a:stretch>
             <a:fillRect/>
           </a:stretch>
         </p:blipFill>
         <p:spPr>
           <a:xfrm>
-            <a:off x="993038" y="855878"/>
-            <a:ext cx="482803" cy="482803"/>
+            <a:off x="777240" y="2103120"/>
+            <a:ext cx="5532120" cy="3685032"/>
           </a:xfrm>
           <a:prstGeom prst="rect">
             <a:avLst/>
@@ -5503,14 +6850,14 @@
       </p:pic>
       <p:sp>
         <p:nvSpPr>
-          <p:cNvPr id="4" name="Text 1"/>
-          <p:cNvSpPr/>
-          <p:nvPr/>
-        </p:nvSpPr>
-        <p:spPr>
-          <a:xfrm>
-            <a:off x="1920240" y="548640"/>
-            <a:ext cx="9601200" cy="914400"/>
+          <p:cNvPr id="8" name="Text 4"/>
+          <p:cNvSpPr/>
+          <p:nvPr/>
+        </p:nvSpPr>
+        <p:spPr>
+          <a:xfrm>
+            <a:off x="777240" y="5760720"/>
+            <a:ext cx="5532120" cy="320040"/>
           </a:xfrm>
           <a:prstGeom prst="rect">
             <a:avLst/>
@@ -5526,7 +6873,68 @@
               <a:buNone/>
             </a:pPr>
             <a:r>
-              <a:rPr lang="en-US" sz="3000" b="1" dirty="0">
+              <a:rPr lang="en-US" sz="1100" i="1" dirty="0">
+                <a:solidFill>
+                  <a:srgbClr val="1A6D85"/>
+                </a:solidFill>
+                <a:latin typeface="Calibri" pitchFamily="34" charset="0"/>
+                <a:ea typeface="Calibri" pitchFamily="34" charset="-122"/>
+                <a:cs typeface="Calibri" pitchFamily="34" charset="-120"/>
+              </a:rPr>
+              <a:t>Distance vs. large-lot share, sized by sales, colored by price — 98118 circled.</a:t>
+            </a:r>
+            <a:endParaRPr lang="en-US" sz="1100" dirty="0"/>
+          </a:p>
+        </p:txBody>
+      </p:sp>
+      <p:sp>
+        <p:nvSpPr>
+          <p:cNvPr id="9" name="Shape 5"/>
+          <p:cNvSpPr/>
+          <p:nvPr/>
+        </p:nvSpPr>
+        <p:spPr>
+          <a:xfrm>
+            <a:off x="6656832" y="2011680"/>
+            <a:ext cx="4892040" cy="1261872"/>
+          </a:xfrm>
+          <a:prstGeom prst="roundRect">
+            <a:avLst>
+              <a:gd name="adj" fmla="val 7246"/>
+            </a:avLst>
+          </a:prstGeom>
+          <a:solidFill>
+            <a:srgbClr val="1A6D85"/>
+          </a:solidFill>
+          <a:ln/>
+        </p:spPr>
+      </p:sp>
+      <p:sp>
+        <p:nvSpPr>
+          <p:cNvPr id="10" name="Text 6"/>
+          <p:cNvSpPr/>
+          <p:nvPr/>
+        </p:nvSpPr>
+        <p:spPr>
+          <a:xfrm>
+            <a:off x="6858000" y="2121408"/>
+            <a:ext cx="4480560" cy="457200"/>
+          </a:xfrm>
+          <a:prstGeom prst="rect">
+            <a:avLst/>
+          </a:prstGeom>
+          <a:noFill/>
+          <a:ln/>
+        </p:spPr>
+        <p:txBody>
+          <a:bodyPr wrap="square" lIns="0" tIns="0" rIns="0" bIns="0" rtlCol="0" anchor="ctr"/>
+          <a:lstStyle/>
+          <a:p>
+            <a:pPr indent="0" marL="0">
+              <a:buNone/>
+            </a:pPr>
+            <a:r>
+              <a:rPr lang="en-US" sz="2200" b="1" dirty="0">
                 <a:solidFill>
                   <a:srgbClr val="FFFFFF"/>
                 </a:solidFill>
@@ -5534,60 +6942,99 @@
                 <a:ea typeface="Cambria" pitchFamily="34" charset="-122"/>
                 <a:cs typeface="Cambria" pitchFamily="34" charset="-120"/>
               </a:rPr>
-              <a:t>For the Country Home  →  Zip 98010 or 98014</a:t>
-            </a:r>
-            <a:endParaRPr lang="en-US" sz="3000" dirty="0"/>
-          </a:p>
-        </p:txBody>
-      </p:sp>
-      <p:sp>
-        <p:nvSpPr>
-          <p:cNvPr id="5" name="Shape 2"/>
-          <p:cNvSpPr/>
-          <p:nvPr/>
-        </p:nvSpPr>
-        <p:spPr>
-          <a:xfrm>
-            <a:off x="731520" y="2377440"/>
-            <a:ext cx="3383280" cy="3017520"/>
+              <a:t>7.9 km</a:t>
+            </a:r>
+            <a:endParaRPr lang="en-US" sz="2200" dirty="0"/>
+          </a:p>
+        </p:txBody>
+      </p:sp>
+      <p:sp>
+        <p:nvSpPr>
+          <p:cNvPr id="11" name="Text 7"/>
+          <p:cNvSpPr/>
+          <p:nvPr/>
+        </p:nvSpPr>
+        <p:spPr>
+          <a:xfrm>
+            <a:off x="6858000" y="2578608"/>
+            <a:ext cx="4480560" cy="640080"/>
+          </a:xfrm>
+          <a:prstGeom prst="rect">
+            <a:avLst/>
+          </a:prstGeom>
+          <a:noFill/>
+          <a:ln/>
+        </p:spPr>
+        <p:txBody>
+          <a:bodyPr wrap="square" lIns="0" tIns="0" rIns="0" bIns="0" rtlCol="0" anchor="ctr"/>
+          <a:lstStyle/>
+          <a:p>
+            <a:pPr indent="0" marL="0">
+              <a:buNone/>
+            </a:pPr>
+            <a:r>
+              <a:rPr lang="en-US" sz="1200" dirty="0">
+                <a:solidFill>
+                  <a:srgbClr val="FFFFFF"/>
+                </a:solidFill>
+                <a:latin typeface="Calibri" pitchFamily="34" charset="0"/>
+                <a:ea typeface="Calibri" pitchFamily="34" charset="-122"/>
+                <a:cs typeface="Calibri" pitchFamily="34" charset="-120"/>
+              </a:rPr>
+              <a:t>from downtown Seattle — the closest of the high-turnover zips</a:t>
+            </a:r>
+            <a:endParaRPr lang="en-US" sz="1200" dirty="0"/>
+          </a:p>
+        </p:txBody>
+      </p:sp>
+      <p:sp>
+        <p:nvSpPr>
+          <p:cNvPr id="12" name="Shape 8"/>
+          <p:cNvSpPr/>
+          <p:nvPr/>
+        </p:nvSpPr>
+        <p:spPr>
+          <a:xfrm>
+            <a:off x="6656832" y="3419856"/>
+            <a:ext cx="4892040" cy="1261872"/>
           </a:xfrm>
           <a:prstGeom prst="roundRect">
             <a:avLst>
-              <a:gd name="adj" fmla="val 3636"/>
+              <a:gd name="adj" fmla="val 7246"/>
             </a:avLst>
           </a:prstGeom>
           <a:solidFill>
-            <a:srgbClr val="244F26"/>
+            <a:srgbClr val="1A6D85"/>
           </a:solidFill>
           <a:ln/>
         </p:spPr>
       </p:sp>
       <p:sp>
         <p:nvSpPr>
-          <p:cNvPr id="6" name="Text 3"/>
-          <p:cNvSpPr/>
-          <p:nvPr/>
-        </p:nvSpPr>
-        <p:spPr>
-          <a:xfrm>
-            <a:off x="731520" y="2743200"/>
-            <a:ext cx="3383280" cy="822960"/>
-          </a:xfrm>
-          <a:prstGeom prst="rect">
-            <a:avLst/>
-          </a:prstGeom>
-          <a:noFill/>
-          <a:ln/>
-        </p:spPr>
-        <p:txBody>
-          <a:bodyPr wrap="square" lIns="0" tIns="0" rIns="0" bIns="0" rtlCol="0" anchor="ctr"/>
-          <a:lstStyle/>
-          <a:p>
-            <a:pPr algn="ctr" indent="0" marL="0">
-              <a:buNone/>
-            </a:pPr>
-            <a:r>
-              <a:rPr lang="en-US" sz="3000" b="1" dirty="0">
+          <p:cNvPr id="13" name="Text 9"/>
+          <p:cNvSpPr/>
+          <p:nvPr/>
+        </p:nvSpPr>
+        <p:spPr>
+          <a:xfrm>
+            <a:off x="6858000" y="3529584"/>
+            <a:ext cx="4480560" cy="457200"/>
+          </a:xfrm>
+          <a:prstGeom prst="rect">
+            <a:avLst/>
+          </a:prstGeom>
+          <a:noFill/>
+          <a:ln/>
+        </p:spPr>
+        <p:txBody>
+          <a:bodyPr wrap="square" lIns="0" tIns="0" rIns="0" bIns="0" rtlCol="0" anchor="ctr"/>
+          <a:lstStyle/>
+          <a:p>
+            <a:pPr indent="0" marL="0">
+              <a:buNone/>
+            </a:pPr>
+            <a:r>
+              <a:rPr lang="en-US" sz="2200" b="1" dirty="0">
                 <a:solidFill>
                   <a:srgbClr val="FFFFFF"/>
                 </a:solidFill>
@@ -5595,99 +7042,99 @@
                 <a:ea typeface="Cambria" pitchFamily="34" charset="-122"/>
                 <a:cs typeface="Cambria" pitchFamily="34" charset="-120"/>
               </a:rPr>
-              <a:t>30+ km</a:t>
-            </a:r>
-            <a:endParaRPr lang="en-US" sz="3000" dirty="0"/>
-          </a:p>
-        </p:txBody>
-      </p:sp>
-      <p:sp>
-        <p:nvSpPr>
-          <p:cNvPr id="7" name="Text 4"/>
-          <p:cNvSpPr/>
-          <p:nvPr/>
-        </p:nvSpPr>
-        <p:spPr>
-          <a:xfrm>
-            <a:off x="1005840" y="3611880"/>
-            <a:ext cx="2834640" cy="1554480"/>
-          </a:xfrm>
-          <a:prstGeom prst="rect">
-            <a:avLst/>
-          </a:prstGeom>
-          <a:noFill/>
-          <a:ln/>
-        </p:spPr>
-        <p:txBody>
-          <a:bodyPr wrap="square" lIns="0" tIns="0" rIns="0" bIns="0" rtlCol="0" anchor="ctr"/>
-          <a:lstStyle/>
-          <a:p>
-            <a:pPr algn="ctr" indent="0" marL="0">
-              <a:buNone/>
-            </a:pPr>
-            <a:r>
-              <a:rPr lang="en-US" sz="1400" dirty="0">
-                <a:solidFill>
-                  <a:srgbClr val="DCEAD2"/>
+              <a:t>507 sales</a:t>
+            </a:r>
+            <a:endParaRPr lang="en-US" sz="2200" dirty="0"/>
+          </a:p>
+        </p:txBody>
+      </p:sp>
+      <p:sp>
+        <p:nvSpPr>
+          <p:cNvPr id="14" name="Text 10"/>
+          <p:cNvSpPr/>
+          <p:nvPr/>
+        </p:nvSpPr>
+        <p:spPr>
+          <a:xfrm>
+            <a:off x="6858000" y="3986784"/>
+            <a:ext cx="4480560" cy="640080"/>
+          </a:xfrm>
+          <a:prstGeom prst="rect">
+            <a:avLst/>
+          </a:prstGeom>
+          <a:noFill/>
+          <a:ln/>
+        </p:spPr>
+        <p:txBody>
+          <a:bodyPr wrap="square" lIns="0" tIns="0" rIns="0" bIns="0" rtlCol="0" anchor="ctr"/>
+          <a:lstStyle/>
+          <a:p>
+            <a:pPr indent="0" marL="0">
+              <a:buNone/>
+            </a:pPr>
+            <a:r>
+              <a:rPr lang="en-US" sz="1200" dirty="0">
+                <a:solidFill>
+                  <a:srgbClr val="FFFFFF"/>
                 </a:solidFill>
                 <a:latin typeface="Calibri" pitchFamily="34" charset="0"/>
                 <a:ea typeface="Calibri" pitchFamily="34" charset="-122"/>
                 <a:cs typeface="Calibri" pitchFamily="34" charset="-120"/>
               </a:rPr>
-              <a:t>from downtown — genuinely rural, not just “outside city limits”</a:t>
-            </a:r>
-            <a:endParaRPr lang="en-US" sz="1400" dirty="0"/>
-          </a:p>
-        </p:txBody>
-      </p:sp>
-      <p:sp>
-        <p:nvSpPr>
-          <p:cNvPr id="8" name="Shape 5"/>
-          <p:cNvSpPr/>
-          <p:nvPr/>
-        </p:nvSpPr>
-        <p:spPr>
-          <a:xfrm>
-            <a:off x="4434840" y="2377440"/>
-            <a:ext cx="3383280" cy="3017520"/>
+              <a:t>in the 12-month window — highest turnover among affordable central zips</a:t>
+            </a:r>
+            <a:endParaRPr lang="en-US" sz="1200" dirty="0"/>
+          </a:p>
+        </p:txBody>
+      </p:sp>
+      <p:sp>
+        <p:nvSpPr>
+          <p:cNvPr id="15" name="Shape 11"/>
+          <p:cNvSpPr/>
+          <p:nvPr/>
+        </p:nvSpPr>
+        <p:spPr>
+          <a:xfrm>
+            <a:off x="6656832" y="4828032"/>
+            <a:ext cx="4892040" cy="1261872"/>
           </a:xfrm>
           <a:prstGeom prst="roundRect">
             <a:avLst>
-              <a:gd name="adj" fmla="val 3636"/>
+              <a:gd name="adj" fmla="val 7246"/>
             </a:avLst>
           </a:prstGeom>
           <a:solidFill>
-            <a:srgbClr val="244F26"/>
+            <a:srgbClr val="1A6D85"/>
           </a:solidFill>
           <a:ln/>
         </p:spPr>
       </p:sp>
       <p:sp>
         <p:nvSpPr>
-          <p:cNvPr id="9" name="Text 6"/>
-          <p:cNvSpPr/>
-          <p:nvPr/>
-        </p:nvSpPr>
-        <p:spPr>
-          <a:xfrm>
-            <a:off x="4434840" y="2743200"/>
-            <a:ext cx="3383280" cy="822960"/>
-          </a:xfrm>
-          <a:prstGeom prst="rect">
-            <a:avLst/>
-          </a:prstGeom>
-          <a:noFill/>
-          <a:ln/>
-        </p:spPr>
-        <p:txBody>
-          <a:bodyPr wrap="square" lIns="0" tIns="0" rIns="0" bIns="0" rtlCol="0" anchor="ctr"/>
-          <a:lstStyle/>
-          <a:p>
-            <a:pPr algn="ctr" indent="0" marL="0">
-              <a:buNone/>
-            </a:pPr>
-            <a:r>
-              <a:rPr lang="en-US" sz="3000" b="1" dirty="0">
+          <p:cNvPr id="16" name="Text 12"/>
+          <p:cNvSpPr/>
+          <p:nvPr/>
+        </p:nvSpPr>
+        <p:spPr>
+          <a:xfrm>
+            <a:off x="6858000" y="4937760"/>
+            <a:ext cx="4480560" cy="457200"/>
+          </a:xfrm>
+          <a:prstGeom prst="rect">
+            <a:avLst/>
+          </a:prstGeom>
+          <a:noFill/>
+          <a:ln/>
+        </p:spPr>
+        <p:txBody>
+          <a:bodyPr wrap="square" lIns="0" tIns="0" rIns="0" bIns="0" rtlCol="0" anchor="ctr"/>
+          <a:lstStyle/>
+          <a:p>
+            <a:pPr indent="0" marL="0">
+              <a:buNone/>
+            </a:pPr>
+            <a:r>
+              <a:rPr lang="en-US" sz="2200" b="1" dirty="0">
                 <a:solidFill>
                   <a:srgbClr val="FFFFFF"/>
                 </a:solidFill>
@@ -5695,187 +7142,129 @@
                 <a:ea typeface="Cambria" pitchFamily="34" charset="-122"/>
                 <a:cs typeface="Cambria" pitchFamily="34" charset="-120"/>
               </a:rPr>
-              <a:t>68–85%</a:t>
-            </a:r>
-            <a:endParaRPr lang="en-US" sz="3000" dirty="0"/>
-          </a:p>
-        </p:txBody>
-      </p:sp>
-      <p:sp>
-        <p:nvSpPr>
-          <p:cNvPr id="10" name="Text 7"/>
-          <p:cNvSpPr/>
-          <p:nvPr/>
-        </p:nvSpPr>
-        <p:spPr>
-          <a:xfrm>
-            <a:off x="4709160" y="3611880"/>
-            <a:ext cx="2834640" cy="1554480"/>
-          </a:xfrm>
-          <a:prstGeom prst="rect">
-            <a:avLst/>
-          </a:prstGeom>
-          <a:noFill/>
-          <a:ln/>
-        </p:spPr>
-        <p:txBody>
-          <a:bodyPr wrap="square" lIns="0" tIns="0" rIns="0" bIns="0" rtlCol="0" anchor="ctr"/>
-          <a:lstStyle/>
-          <a:p>
-            <a:pPr algn="ctr" indent="0" marL="0">
-              <a:buNone/>
-            </a:pPr>
-            <a:r>
-              <a:rPr lang="en-US" sz="1400" dirty="0">
-                <a:solidFill>
-                  <a:srgbClr val="DCEAD2"/>
+              <a:t>$367,500</a:t>
+            </a:r>
+            <a:endParaRPr lang="en-US" sz="2200" dirty="0"/>
+          </a:p>
+        </p:txBody>
+      </p:sp>
+      <p:sp>
+        <p:nvSpPr>
+          <p:cNvPr id="17" name="Text 13"/>
+          <p:cNvSpPr/>
+          <p:nvPr/>
+        </p:nvSpPr>
+        <p:spPr>
+          <a:xfrm>
+            <a:off x="6858000" y="5394960"/>
+            <a:ext cx="4480560" cy="640080"/>
+          </a:xfrm>
+          <a:prstGeom prst="rect">
+            <a:avLst/>
+          </a:prstGeom>
+          <a:noFill/>
+          <a:ln/>
+        </p:spPr>
+        <p:txBody>
+          <a:bodyPr wrap="square" lIns="0" tIns="0" rIns="0" bIns="0" rtlCol="0" anchor="ctr"/>
+          <a:lstStyle/>
+          <a:p>
+            <a:pPr indent="0" marL="0">
+              <a:buNone/>
+            </a:pPr>
+            <a:r>
+              <a:rPr lang="en-US" sz="1200" dirty="0">
+                <a:solidFill>
+                  <a:srgbClr val="FFFFFF"/>
                 </a:solidFill>
                 <a:latin typeface="Calibri" pitchFamily="34" charset="0"/>
                 <a:ea typeface="Calibri" pitchFamily="34" charset="-122"/>
                 <a:cs typeface="Calibri" pitchFamily="34" charset="-120"/>
               </a:rPr>
-              <a:t>of homes in these zips are large-lot — real country character</a:t>
-            </a:r>
-            <a:endParaRPr lang="en-US" sz="1400" dirty="0"/>
-          </a:p>
-        </p:txBody>
-      </p:sp>
-      <p:sp>
-        <p:nvSpPr>
-          <p:cNvPr id="11" name="Shape 8"/>
-          <p:cNvSpPr/>
-          <p:nvPr/>
-        </p:nvSpPr>
-        <p:spPr>
-          <a:xfrm>
-            <a:off x="8138160" y="2377440"/>
-            <a:ext cx="3383280" cy="3017520"/>
-          </a:xfrm>
-          <a:prstGeom prst="roundRect">
-            <a:avLst>
-              <a:gd name="adj" fmla="val 3636"/>
-            </a:avLst>
-          </a:prstGeom>
-          <a:solidFill>
-            <a:srgbClr val="244F26"/>
-          </a:solidFill>
-          <a:ln/>
-        </p:spPr>
-      </p:sp>
-      <p:sp>
-        <p:nvSpPr>
-          <p:cNvPr id="12" name="Text 9"/>
-          <p:cNvSpPr/>
-          <p:nvPr/>
-        </p:nvSpPr>
-        <p:spPr>
-          <a:xfrm>
-            <a:off x="8138160" y="2743200"/>
-            <a:ext cx="3383280" cy="822960"/>
-          </a:xfrm>
-          <a:prstGeom prst="rect">
-            <a:avLst/>
-          </a:prstGeom>
-          <a:noFill/>
-          <a:ln/>
-        </p:spPr>
-        <p:txBody>
-          <a:bodyPr wrap="square" lIns="0" tIns="0" rIns="0" bIns="0" rtlCol="0" anchor="ctr"/>
-          <a:lstStyle/>
-          <a:p>
-            <a:pPr algn="ctr" indent="0" marL="0">
-              <a:buNone/>
-            </a:pPr>
-            <a:r>
-              <a:rPr lang="en-US" sz="3000" b="1" dirty="0">
-                <a:solidFill>
-                  <a:srgbClr val="FFFFFF"/>
-                </a:solidFill>
-                <a:latin typeface="Cambria" pitchFamily="34" charset="0"/>
-                <a:ea typeface="Cambria" pitchFamily="34" charset="-122"/>
-                <a:cs typeface="Cambria" pitchFamily="34" charset="-120"/>
-              </a:rPr>
-              <a:t>$360K–$415K</a:t>
-            </a:r>
-            <a:endParaRPr lang="en-US" sz="3000" dirty="0"/>
-          </a:p>
-        </p:txBody>
-      </p:sp>
-      <p:sp>
-        <p:nvSpPr>
-          <p:cNvPr id="13" name="Text 10"/>
-          <p:cNvSpPr/>
-          <p:nvPr/>
-        </p:nvSpPr>
-        <p:spPr>
-          <a:xfrm>
-            <a:off x="8412480" y="3611880"/>
-            <a:ext cx="2834640" cy="1554480"/>
-          </a:xfrm>
-          <a:prstGeom prst="rect">
-            <a:avLst/>
-          </a:prstGeom>
-          <a:noFill/>
-          <a:ln/>
-        </p:spPr>
-        <p:txBody>
-          <a:bodyPr wrap="square" lIns="0" tIns="0" rIns="0" bIns="0" rtlCol="0" anchor="ctr"/>
-          <a:lstStyle/>
-          <a:p>
-            <a:pPr algn="ctr" indent="0" marL="0">
-              <a:buNone/>
-            </a:pPr>
-            <a:r>
-              <a:rPr lang="en-US" sz="1400" dirty="0">
-                <a:solidFill>
-                  <a:srgbClr val="DCEAD2"/>
+              <a:t>median price — the most affordable of that group</a:t>
+            </a:r>
+            <a:endParaRPr lang="en-US" sz="1200" dirty="0"/>
+          </a:p>
+        </p:txBody>
+      </p:sp>
+      <p:sp>
+        <p:nvSpPr>
+          <p:cNvPr id="18" name="Text 14"/>
+          <p:cNvSpPr/>
+          <p:nvPr/>
+        </p:nvSpPr>
+        <p:spPr>
+          <a:xfrm>
+            <a:off x="6656832" y="6281928"/>
+            <a:ext cx="4892040" cy="685800"/>
+          </a:xfrm>
+          <a:prstGeom prst="rect">
+            <a:avLst/>
+          </a:prstGeom>
+          <a:noFill/>
+          <a:ln/>
+        </p:spPr>
+        <p:txBody>
+          <a:bodyPr wrap="square" lIns="0" tIns="0" rIns="0" bIns="0" rtlCol="0" anchor="ctr"/>
+          <a:lstStyle/>
+          <a:p>
+            <a:pPr indent="0" marL="0">
+              <a:lnSpc>
+                <a:spcPct val="110000"/>
+              </a:lnSpc>
+              <a:buNone/>
+            </a:pPr>
+            <a:r>
+              <a:rPr lang="en-US" sz="1150" i="1" dirty="0">
+                <a:solidFill>
+                  <a:srgbClr val="CADCFC"/>
                 </a:solidFill>
                 <a:latin typeface="Calibri" pitchFamily="34" charset="0"/>
                 <a:ea typeface="Calibri" pitchFamily="34" charset="-122"/>
                 <a:cs typeface="Calibri" pitchFamily="34" charset="-120"/>
               </a:rPr>
-              <a:t>median price — well below the county median</a:t>
-            </a:r>
-            <a:endParaRPr lang="en-US" sz="1400" dirty="0"/>
-          </a:p>
-        </p:txBody>
-      </p:sp>
-      <p:sp>
-        <p:nvSpPr>
-          <p:cNvPr id="14" name="Text 11"/>
-          <p:cNvSpPr/>
-          <p:nvPr/>
-        </p:nvSpPr>
-        <p:spPr>
-          <a:xfrm>
-            <a:off x="731520" y="5806440"/>
-            <a:ext cx="10698480" cy="548640"/>
-          </a:xfrm>
-          <a:prstGeom prst="rect">
-            <a:avLst/>
-          </a:prstGeom>
-          <a:noFill/>
-          <a:ln/>
-        </p:spPr>
-        <p:txBody>
-          <a:bodyPr wrap="square" lIns="0" tIns="0" rIns="0" bIns="0" rtlCol="0" anchor="ctr"/>
-          <a:lstStyle/>
-          <a:p>
-            <a:pPr algn="ctr" indent="0" marL="0">
-              <a:buNone/>
-            </a:pPr>
-            <a:r>
-              <a:rPr lang="en-US" sz="1300" i="1" dirty="0">
-                <a:solidFill>
-                  <a:srgbClr val="DCEAD2"/>
+              <a:t>98103, 98115, and 98117 are strong second choices. Filter to 1–3 bedrooms — plenty for a household of 2, avoiding a ~41% size premium.</a:t>
+            </a:r>
+            <a:endParaRPr lang="en-US" sz="1150" dirty="0"/>
+          </a:p>
+        </p:txBody>
+      </p:sp>
+      <p:sp>
+        <p:nvSpPr>
+          <p:cNvPr id="20" name="Text 15"/>
+          <p:cNvSpPr/>
+          <p:nvPr/>
+        </p:nvSpPr>
+        <p:spPr>
+          <a:xfrm>
+            <a:off x="11292840" y="6510528"/>
+            <a:ext cx="777240" cy="274320"/>
+          </a:xfrm>
+          <a:prstGeom prst="rect">
+            <a:avLst/>
+          </a:prstGeom>
+          <a:noFill/>
+          <a:ln/>
+        </p:spPr>
+        <p:txBody>
+          <a:bodyPr wrap="square" lIns="0" tIns="0" rIns="0" bIns="0" rtlCol="0" anchor="ctr"/>
+          <a:lstStyle/>
+          <a:p>
+            <a:pPr algn="r" indent="0" marL="0">
+              <a:buNone/>
+            </a:pPr>
+            <a:r>
+              <a:rPr lang="en-US" sz="1000" dirty="0">
+                <a:solidFill>
+                  <a:srgbClr val="CADCFC"/>
                 </a:solidFill>
                 <a:latin typeface="Calibri" pitchFamily="34" charset="0"/>
                 <a:ea typeface="Calibri" pitchFamily="34" charset="-122"/>
                 <a:cs typeface="Calibri" pitchFamily="34" charset="-120"/>
               </a:rPr>
-              <a:t>Lean into non-renovated listings here — they’re the majority of homes and meaningfully cheaper.</a:t>
-            </a:r>
-            <a:endParaRPr lang="en-US" sz="1300" dirty="0"/>
+              <a:t>9 / 12</a:t>
+            </a:r>
+            <a:endParaRPr lang="en-US" sz="1000" dirty="0"/>
           </a:p>
         </p:txBody>
       </p:sp>

</xml_diff>

<commit_message>
Deck round 2: charts sourced from data/eda.csv (matching 04_eda.ipynb analysis) replacing native charts, fix new contrast failure on slide 9, bump remaining small fonts to 13pt
</commit_message>
<xml_diff>
--- a/presentation.pptx
+++ b/presentation.pptx
@@ -116,841 +116,6 @@
     </a:lvl9pPr>
   </p:defaultTextStyle>
 </p:presentation>
-</file>
-
-<file path=ppt/charts/chart1.xml><?xml version="1.0" encoding="utf-8"?>
-<c:chartSpace xmlns:c="http://schemas.openxmlformats.org/drawingml/2006/chart" xmlns:a="http://schemas.openxmlformats.org/drawingml/2006/main" xmlns:r="http://schemas.openxmlformats.org/officeDocument/2006/relationships">
-  <c:date1904 val="0"/>
-  <c:roundedCorners val="1"/>
-  <c:chart>
-    <c:title>
-      <c:tx>
-        <c:rich>
-          <a:bodyPr/>
-          <a:lstStyle/>
-          <a:p>
-            <a:pPr>
-              <a:defRPr sz="1400" b="0" i="0" u="none" strike="noStrike">
-                <a:solidFill>
-                  <a:srgbClr val="262626"/>
-                </a:solidFill>
-                <a:latin typeface="Calibri"/>
-              </a:defRPr>
-            </a:pPr>
-            <a:r>
-              <a:rPr sz="1400" b="0" i="0" u="none" strike="noStrike">
-                <a:solidFill>
-                  <a:srgbClr val="262626"/>
-                </a:solidFill>
-                <a:latin typeface="Calibri"/>
-              </a:rPr>
-              <a:t>Median Price per Square Foot</a:t>
-            </a:r>
-          </a:p>
-        </c:rich>
-      </c:tx>
-      <c:layout/>
-      <c:overlay val="0"/>
-    </c:title>
-    <c:autoTitleDeleted val="0"/>
-    <c:plotArea>
-      <c:layout/>
-      <c:barChart>
-        <c:barDir val="col"/>
-        <c:grouping val="clustered"/>
-        <c:varyColors val="0"/>
-        <c:ser>
-          <c:idx val="0"/>
-          <c:order val="0"/>
-          <c:tx>
-            <c:strRef>
-              <c:f>Sheet1!$B$1</c:f>
-              <c:strCache>
-                <c:ptCount val="1"/>
-                <c:pt idx="0">
-                  <c:v>Price per Sqft</c:v>
-                </c:pt>
-              </c:strCache>
-            </c:strRef>
-          </c:tx>
-          <c:spPr>
-            <a:solidFill>
-              <a:srgbClr val="1C7293"/>
-            </a:solidFill>
-            <a:effectLst/>
-          </c:spPr>
-          <c:invertIfNegative val="0"/>
-          <c:dLbls>
-            <c:numFmt formatCode="&quot;$&quot;#,##0" sourceLinked="0"/>
-            <c:txPr>
-              <a:bodyPr/>
-              <a:lstStyle/>
-              <a:p>
-                <a:pPr>
-                  <a:defRPr b="0" i="0" strike="noStrike" sz="1300" u="none">
-                    <a:solidFill>
-                      <a:srgbClr val="262626"/>
-                    </a:solidFill>
-                    <a:latin typeface="Calibri"/>
-                  </a:defRPr>
-                </a:pPr>
-              </a:p>
-            </c:txPr>
-            <c:showLegendKey val="0"/>
-            <c:showVal val="1"/>
-            <c:showCatName val="0"/>
-            <c:showSerName val="0"/>
-            <c:showPercent val="0"/>
-            <c:showBubbleSize val="0"/>
-            <c:showLeaderLines val="0"/>
-          </c:dLbls>
-          <c:cat>
-            <c:multiLvlStrRef>
-              <c:f>Sheet1!$A$2:$A$3</c:f>
-              <c:multiLvlStrCache>
-                <c:ptCount val="2"/>
-                <c:lvl>
-                  <c:pt idx="0">
-                    <c:v>Central Seattle
-(closest 25%)</c:v>
-                  </c:pt>
-                  <c:pt idx="1">
-                    <c:v>Rest of
-King County</c:v>
-                  </c:pt>
-                </c:lvl>
-              </c:multiLvlStrCache>
-            </c:multiLvlStrRef>
-          </c:cat>
-          <c:val>
-            <c:numRef>
-              <c:f>Sheet1!$B$2:$B$3</c:f>
-              <c:numCache>
-                <c:formatCode>General</c:formatCode>
-                <c:ptCount val="2"/>
-                <c:pt idx="0">
-                  <c:v>345</c:v>
-                </c:pt>
-                <c:pt idx="1">
-                  <c:v>220</c:v>
-                </c:pt>
-              </c:numCache>
-            </c:numRef>
-          </c:val>
-        </c:ser>
-        <c:dLbls>
-          <c:numFmt formatCode="&quot;$&quot;#,##0" sourceLinked="0"/>
-          <c:txPr>
-            <a:bodyPr/>
-            <a:lstStyle/>
-            <a:p>
-              <a:pPr>
-                <a:defRPr b="0" i="0" strike="noStrike" sz="1300" u="none">
-                  <a:solidFill>
-                    <a:srgbClr val="262626"/>
-                  </a:solidFill>
-                  <a:latin typeface="Calibri"/>
-                </a:defRPr>
-              </a:pPr>
-            </a:p>
-          </c:txPr>
-          <c:showLegendKey val="0"/>
-          <c:showVal val="1"/>
-          <c:showCatName val="0"/>
-          <c:showSerName val="0"/>
-          <c:showPercent val="0"/>
-          <c:showBubbleSize val="0"/>
-          <c:showLeaderLines val="0"/>
-        </c:dLbls>
-        <c:gapWidth val="150"/>
-        <c:overlap val="0"/>
-        <c:axId val="2094734554"/>
-        <c:axId val="2094734552"/>
-        <c:axId val="2094734556"/>
-      </c:barChart>
-      <c:catAx>
-        <c:axId val="2094734554"/>
-        <c:scaling>
-          <c:orientation val="minMax"/>
-        </c:scaling>
-        <c:delete val="0"/>
-        <c:axPos val="b"/>
-        <c:numFmt formatCode="General" sourceLinked="1"/>
-        <c:majorTickMark val="out"/>
-        <c:minorTickMark val="none"/>
-        <c:tickLblPos val="low"/>
-        <c:spPr>
-          <a:ln w="12700" cap="flat">
-            <a:solidFill>
-              <a:srgbClr val="888888"/>
-            </a:solidFill>
-            <a:prstDash val="solid"/>
-            <a:round/>
-          </a:ln>
-        </c:spPr>
-        <c:txPr>
-          <a:bodyPr/>
-          <a:lstStyle/>
-          <a:p>
-            <a:pPr>
-              <a:defRPr sz="1200" b="0" i="0" u="none" strike="noStrike">
-                <a:solidFill>
-                  <a:srgbClr val="262626"/>
-                </a:solidFill>
-                <a:latin typeface="Calibri"/>
-              </a:defRPr>
-            </a:pPr>
-            <a:endParaRPr lang="en-US"/>
-          </a:p>
-        </c:txPr>
-        <c:crossAx val="2094734552"/>
-        <c:crosses val="autoZero"/>
-        <c:auto val="1"/>
-        <c:lblAlgn val="ctr"/>
-        <c:noMultiLvlLbl val="1"/>
-      </c:catAx>
-      <c:valAx>
-        <c:axId val="2094734552"/>
-        <c:scaling>
-          <c:orientation val="minMax"/>
-        </c:scaling>
-        <c:delete val="1"/>
-        <c:axPos val="l"/>
-        <c:numFmt formatCode="General" sourceLinked="0"/>
-        <c:majorTickMark val="out"/>
-        <c:minorTickMark val="none"/>
-        <c:tickLblPos val="nextTo"/>
-        <c:spPr>
-          <a:ln w="12700" cap="flat">
-            <a:solidFill>
-              <a:srgbClr val="888888"/>
-            </a:solidFill>
-            <a:prstDash val="solid"/>
-            <a:round/>
-          </a:ln>
-        </c:spPr>
-        <c:txPr>
-          <a:bodyPr/>
-          <a:lstStyle/>
-          <a:p>
-            <a:pPr>
-              <a:defRPr sz="1200" b="0" i="0" u="none" strike="noStrike">
-                <a:solidFill>
-                  <a:srgbClr val="000000"/>
-                </a:solidFill>
-                <a:latin typeface="Arial"/>
-              </a:defRPr>
-            </a:pPr>
-            <a:endParaRPr lang="en-US"/>
-          </a:p>
-        </c:txPr>
-        <c:crossAx val="2094734554"/>
-        <c:crosses val="autoZero"/>
-        <c:crossBetween val="between"/>
-      </c:valAx>
-      <c:spPr>
-        <a:noFill/>
-        <a:ln>
-          <a:noFill/>
-        </a:ln>
-        <a:effectLst/>
-      </c:spPr>
-    </c:plotArea>
-    <c:plotVisOnly val="1"/>
-    <c:dispBlanksAs val="span"/>
-  </c:chart>
-  <c:spPr>
-    <a:solidFill>
-      <a:srgbClr val="FFFFFF"/>
-    </a:solidFill>
-    <a:ln>
-      <a:noFill/>
-    </a:ln>
-    <a:effectLst/>
-  </c:spPr>
-  <c:externalData r:id="rId1">
-    <c:autoUpdate val="0"/>
-  </c:externalData>
-</c:chartSpace>
-</file>
-
-<file path=ppt/charts/chart2.xml><?xml version="1.0" encoding="utf-8"?>
-<c:chartSpace xmlns:c="http://schemas.openxmlformats.org/drawingml/2006/chart" xmlns:a="http://schemas.openxmlformats.org/drawingml/2006/main" xmlns:r="http://schemas.openxmlformats.org/officeDocument/2006/relationships">
-  <c:date1904 val="0"/>
-  <c:roundedCorners val="1"/>
-  <c:chart>
-    <c:title>
-      <c:tx>
-        <c:rich>
-          <a:bodyPr/>
-          <a:lstStyle/>
-          <a:p>
-            <a:pPr>
-              <a:defRPr sz="1400" b="0" i="0" u="none" strike="noStrike">
-                <a:solidFill>
-                  <a:srgbClr val="262626"/>
-                </a:solidFill>
-                <a:latin typeface="Calibri"/>
-              </a:defRPr>
-            </a:pPr>
-            <a:r>
-              <a:rPr sz="1400" b="0" i="0" u="none" strike="noStrike">
-                <a:solidFill>
-                  <a:srgbClr val="262626"/>
-                </a:solidFill>
-                <a:latin typeface="Calibri"/>
-              </a:rPr>
-              <a:t>Median Price — Large-Lot Homes</a:t>
-            </a:r>
-          </a:p>
-        </c:rich>
-      </c:tx>
-      <c:layout/>
-      <c:overlay val="0"/>
-    </c:title>
-    <c:autoTitleDeleted val="0"/>
-    <c:plotArea>
-      <c:layout/>
-      <c:barChart>
-        <c:barDir val="col"/>
-        <c:grouping val="clustered"/>
-        <c:varyColors val="0"/>
-        <c:ser>
-          <c:idx val="0"/>
-          <c:order val="0"/>
-          <c:tx>
-            <c:strRef>
-              <c:f>Sheet1!$B$1</c:f>
-              <c:strCache>
-                <c:ptCount val="1"/>
-                <c:pt idx="0">
-                  <c:v>Median Price</c:v>
-                </c:pt>
-              </c:strCache>
-            </c:strRef>
-          </c:tx>
-          <c:spPr>
-            <a:solidFill>
-              <a:srgbClr val="2C5F2D"/>
-            </a:solidFill>
-            <a:effectLst/>
-          </c:spPr>
-          <c:invertIfNegative val="0"/>
-          <c:dLbls>
-            <c:numFmt formatCode="&quot;$&quot;#,##0" sourceLinked="0"/>
-            <c:txPr>
-              <a:bodyPr/>
-              <a:lstStyle/>
-              <a:p>
-                <a:pPr>
-                  <a:defRPr b="0" i="0" strike="noStrike" sz="1300" u="none">
-                    <a:solidFill>
-                      <a:srgbClr val="262626"/>
-                    </a:solidFill>
-                    <a:latin typeface="Calibri"/>
-                  </a:defRPr>
-                </a:pPr>
-              </a:p>
-            </c:txPr>
-            <c:showLegendKey val="0"/>
-            <c:showVal val="1"/>
-            <c:showCatName val="0"/>
-            <c:showSerName val="0"/>
-            <c:showPercent val="0"/>
-            <c:showBubbleSize val="0"/>
-            <c:showLeaderLines val="0"/>
-          </c:dLbls>
-          <c:cat>
-            <c:multiLvlStrRef>
-              <c:f>Sheet1!$A$2:$A$3</c:f>
-              <c:multiLvlStrCache>
-                <c:ptCount val="2"/>
-                <c:lvl>
-                  <c:pt idx="0">
-                    <c:v>Non-Renovated</c:v>
-                  </c:pt>
-                  <c:pt idx="1">
-                    <c:v>Renovated</c:v>
-                  </c:pt>
-                </c:lvl>
-              </c:multiLvlStrCache>
-            </c:multiLvlStrRef>
-          </c:cat>
-          <c:val>
-            <c:numRef>
-              <c:f>Sheet1!$B$2:$B$3</c:f>
-              <c:numCache>
-                <c:formatCode>General</c:formatCode>
-                <c:ptCount val="2"/>
-                <c:pt idx="0">
-                  <c:v>530000</c:v>
-                </c:pt>
-                <c:pt idx="1">
-                  <c:v>712500</c:v>
-                </c:pt>
-              </c:numCache>
-            </c:numRef>
-          </c:val>
-        </c:ser>
-        <c:dLbls>
-          <c:numFmt formatCode="&quot;$&quot;#,##0" sourceLinked="0"/>
-          <c:txPr>
-            <a:bodyPr/>
-            <a:lstStyle/>
-            <a:p>
-              <a:pPr>
-                <a:defRPr b="0" i="0" strike="noStrike" sz="1300" u="none">
-                  <a:solidFill>
-                    <a:srgbClr val="262626"/>
-                  </a:solidFill>
-                  <a:latin typeface="Calibri"/>
-                </a:defRPr>
-              </a:pPr>
-            </a:p>
-          </c:txPr>
-          <c:showLegendKey val="0"/>
-          <c:showVal val="1"/>
-          <c:showCatName val="0"/>
-          <c:showSerName val="0"/>
-          <c:showPercent val="0"/>
-          <c:showBubbleSize val="0"/>
-          <c:showLeaderLines val="0"/>
-        </c:dLbls>
-        <c:gapWidth val="150"/>
-        <c:overlap val="0"/>
-        <c:axId val="2094734554"/>
-        <c:axId val="2094734552"/>
-        <c:axId val="2094734556"/>
-      </c:barChart>
-      <c:catAx>
-        <c:axId val="2094734554"/>
-        <c:scaling>
-          <c:orientation val="minMax"/>
-        </c:scaling>
-        <c:delete val="0"/>
-        <c:axPos val="b"/>
-        <c:numFmt formatCode="General" sourceLinked="1"/>
-        <c:majorTickMark val="out"/>
-        <c:minorTickMark val="none"/>
-        <c:tickLblPos val="low"/>
-        <c:spPr>
-          <a:ln w="12700" cap="flat">
-            <a:solidFill>
-              <a:srgbClr val="888888"/>
-            </a:solidFill>
-            <a:prstDash val="solid"/>
-            <a:round/>
-          </a:ln>
-        </c:spPr>
-        <c:txPr>
-          <a:bodyPr/>
-          <a:lstStyle/>
-          <a:p>
-            <a:pPr>
-              <a:defRPr sz="1200" b="0" i="0" u="none" strike="noStrike">
-                <a:solidFill>
-                  <a:srgbClr val="262626"/>
-                </a:solidFill>
-                <a:latin typeface="Calibri"/>
-              </a:defRPr>
-            </a:pPr>
-            <a:endParaRPr lang="en-US"/>
-          </a:p>
-        </c:txPr>
-        <c:crossAx val="2094734552"/>
-        <c:crosses val="autoZero"/>
-        <c:auto val="1"/>
-        <c:lblAlgn val="ctr"/>
-        <c:noMultiLvlLbl val="1"/>
-      </c:catAx>
-      <c:valAx>
-        <c:axId val="2094734552"/>
-        <c:scaling>
-          <c:orientation val="minMax"/>
-        </c:scaling>
-        <c:delete val="1"/>
-        <c:axPos val="l"/>
-        <c:numFmt formatCode="General" sourceLinked="0"/>
-        <c:majorTickMark val="out"/>
-        <c:minorTickMark val="none"/>
-        <c:tickLblPos val="nextTo"/>
-        <c:spPr>
-          <a:ln w="12700" cap="flat">
-            <a:solidFill>
-              <a:srgbClr val="888888"/>
-            </a:solidFill>
-            <a:prstDash val="solid"/>
-            <a:round/>
-          </a:ln>
-        </c:spPr>
-        <c:txPr>
-          <a:bodyPr/>
-          <a:lstStyle/>
-          <a:p>
-            <a:pPr>
-              <a:defRPr sz="1200" b="0" i="0" u="none" strike="noStrike">
-                <a:solidFill>
-                  <a:srgbClr val="000000"/>
-                </a:solidFill>
-                <a:latin typeface="Arial"/>
-              </a:defRPr>
-            </a:pPr>
-            <a:endParaRPr lang="en-US"/>
-          </a:p>
-        </c:txPr>
-        <c:crossAx val="2094734554"/>
-        <c:crosses val="autoZero"/>
-        <c:crossBetween val="between"/>
-      </c:valAx>
-      <c:spPr>
-        <a:noFill/>
-        <a:ln>
-          <a:noFill/>
-        </a:ln>
-        <a:effectLst/>
-      </c:spPr>
-    </c:plotArea>
-    <c:plotVisOnly val="1"/>
-    <c:dispBlanksAs val="span"/>
-  </c:chart>
-  <c:spPr>
-    <a:solidFill>
-      <a:srgbClr val="FFFFFF"/>
-    </a:solidFill>
-    <a:ln>
-      <a:noFill/>
-    </a:ln>
-    <a:effectLst/>
-  </c:spPr>
-  <c:externalData r:id="rId1">
-    <c:autoUpdate val="0"/>
-  </c:externalData>
-</c:chartSpace>
-</file>
-
-<file path=ppt/charts/chart3.xml><?xml version="1.0" encoding="utf-8"?>
-<c:chartSpace xmlns:c="http://schemas.openxmlformats.org/drawingml/2006/chart" xmlns:a="http://schemas.openxmlformats.org/drawingml/2006/main" xmlns:r="http://schemas.openxmlformats.org/officeDocument/2006/relationships">
-  <c:date1904 val="0"/>
-  <c:roundedCorners val="1"/>
-  <c:chart>
-    <c:title>
-      <c:tx>
-        <c:rich>
-          <a:bodyPr/>
-          <a:lstStyle/>
-          <a:p>
-            <a:pPr>
-              <a:defRPr sz="1400" b="0" i="0" u="none" strike="noStrike">
-                <a:solidFill>
-                  <a:srgbClr val="262626"/>
-                </a:solidFill>
-                <a:latin typeface="Calibri"/>
-              </a:defRPr>
-            </a:pPr>
-            <a:r>
-              <a:rPr sz="1400" b="0" i="0" u="none" strike="noStrike">
-                <a:solidFill>
-                  <a:srgbClr val="262626"/>
-                </a:solidFill>
-                <a:latin typeface="Calibri"/>
-              </a:rPr>
-              <a:t>Median Sale Price by Month — Country Homes</a:t>
-            </a:r>
-          </a:p>
-        </c:rich>
-      </c:tx>
-      <c:layout/>
-      <c:overlay val="0"/>
-    </c:title>
-    <c:autoTitleDeleted val="0"/>
-    <c:plotArea>
-      <c:layout/>
-      <c:barChart>
-        <c:barDir val="col"/>
-        <c:grouping val="clustered"/>
-        <c:varyColors val="0"/>
-        <c:ser>
-          <c:idx val="0"/>
-          <c:order val="0"/>
-          <c:tx>
-            <c:strRef>
-              <c:f>Sheet1!$B$1</c:f>
-              <c:strCache>
-                <c:ptCount val="1"/>
-                <c:pt idx="0">
-                  <c:v>Median Price</c:v>
-                </c:pt>
-              </c:strCache>
-            </c:strRef>
-          </c:tx>
-          <c:spPr>
-            <a:solidFill>
-              <a:srgbClr val="2C5F2D"/>
-            </a:solidFill>
-            <a:effectLst/>
-          </c:spPr>
-          <c:invertIfNegative val="0"/>
-          <c:dLbls>
-            <c:numFmt formatCode="#,##0" sourceLinked="0"/>
-            <c:txPr>
-              <a:bodyPr/>
-              <a:lstStyle/>
-              <a:p>
-                <a:pPr>
-                  <a:defRPr b="0" i="0" strike="noStrike" sz="1200" u="none">
-                    <a:solidFill>
-                      <a:srgbClr val="000000"/>
-                    </a:solidFill>
-                    <a:latin typeface="Arial"/>
-                  </a:defRPr>
-                </a:pPr>
-              </a:p>
-            </c:txPr>
-            <c:showLegendKey val="0"/>
-            <c:showVal val="0"/>
-            <c:showCatName val="0"/>
-            <c:showSerName val="0"/>
-            <c:showPercent val="0"/>
-            <c:showBubbleSize val="0"/>
-            <c:showLeaderLines val="0"/>
-          </c:dLbls>
-          <c:cat>
-            <c:multiLvlStrRef>
-              <c:f>Sheet1!$A$2:$A$13</c:f>
-              <c:multiLvlStrCache>
-                <c:ptCount val="12"/>
-                <c:lvl>
-                  <c:pt idx="0">
-                    <c:v>Jan</c:v>
-                  </c:pt>
-                  <c:pt idx="1">
-                    <c:v>Feb</c:v>
-                  </c:pt>
-                  <c:pt idx="2">
-                    <c:v>Mar</c:v>
-                  </c:pt>
-                  <c:pt idx="3">
-                    <c:v>Apr</c:v>
-                  </c:pt>
-                  <c:pt idx="4">
-                    <c:v>May</c:v>
-                  </c:pt>
-                  <c:pt idx="5">
-                    <c:v>Jun</c:v>
-                  </c:pt>
-                  <c:pt idx="6">
-                    <c:v>Jul</c:v>
-                  </c:pt>
-                  <c:pt idx="7">
-                    <c:v>Aug</c:v>
-                  </c:pt>
-                  <c:pt idx="8">
-                    <c:v>Sep</c:v>
-                  </c:pt>
-                  <c:pt idx="9">
-                    <c:v>Oct</c:v>
-                  </c:pt>
-                  <c:pt idx="10">
-                    <c:v>Nov</c:v>
-                  </c:pt>
-                  <c:pt idx="11">
-                    <c:v>Dec</c:v>
-                  </c:pt>
-                </c:lvl>
-              </c:multiLvlStrCache>
-            </c:multiLvlStrRef>
-          </c:cat>
-          <c:val>
-            <c:numRef>
-              <c:f>Sheet1!$B$2:$B$13</c:f>
-              <c:numCache>
-                <c:formatCode>General</c:formatCode>
-                <c:ptCount val="12"/>
-                <c:pt idx="0">
-                  <c:v>524112</c:v>
-                </c:pt>
-                <c:pt idx="1">
-                  <c:v>519500</c:v>
-                </c:pt>
-                <c:pt idx="2">
-                  <c:v>530000</c:v>
-                </c:pt>
-                <c:pt idx="3">
-                  <c:v>575000</c:v>
-                </c:pt>
-                <c:pt idx="4">
-                  <c:v>540000</c:v>
-                </c:pt>
-                <c:pt idx="5">
-                  <c:v>552000</c:v>
-                </c:pt>
-                <c:pt idx="6">
-                  <c:v>550000</c:v>
-                </c:pt>
-                <c:pt idx="7">
-                  <c:v>493725</c:v>
-                </c:pt>
-                <c:pt idx="8">
-                  <c:v>540000</c:v>
-                </c:pt>
-                <c:pt idx="9">
-                  <c:v>535000</c:v>
-                </c:pt>
-                <c:pt idx="10">
-                  <c:v>525000</c:v>
-                </c:pt>
-                <c:pt idx="11">
-                  <c:v>515000</c:v>
-                </c:pt>
-              </c:numCache>
-            </c:numRef>
-          </c:val>
-        </c:ser>
-        <c:dLbls>
-          <c:numFmt formatCode="#,##0" sourceLinked="0"/>
-          <c:txPr>
-            <a:bodyPr/>
-            <a:lstStyle/>
-            <a:p>
-              <a:pPr>
-                <a:defRPr b="0" i="0" strike="noStrike" sz="1200" u="none">
-                  <a:solidFill>
-                    <a:srgbClr val="000000"/>
-                  </a:solidFill>
-                  <a:latin typeface="Arial"/>
-                </a:defRPr>
-              </a:pPr>
-            </a:p>
-          </c:txPr>
-          <c:showLegendKey val="0"/>
-          <c:showVal val="0"/>
-          <c:showCatName val="0"/>
-          <c:showSerName val="0"/>
-          <c:showPercent val="0"/>
-          <c:showBubbleSize val="0"/>
-          <c:showLeaderLines val="0"/>
-        </c:dLbls>
-        <c:gapWidth val="150"/>
-        <c:overlap val="0"/>
-        <c:axId val="2094734554"/>
-        <c:axId val="2094734552"/>
-        <c:axId val="2094734556"/>
-      </c:barChart>
-      <c:catAx>
-        <c:axId val="2094734554"/>
-        <c:scaling>
-          <c:orientation val="minMax"/>
-        </c:scaling>
-        <c:delete val="0"/>
-        <c:axPos val="b"/>
-        <c:numFmt formatCode="General" sourceLinked="1"/>
-        <c:majorTickMark val="out"/>
-        <c:minorTickMark val="none"/>
-        <c:tickLblPos val="low"/>
-        <c:spPr>
-          <a:ln w="12700" cap="flat">
-            <a:solidFill>
-              <a:srgbClr val="888888"/>
-            </a:solidFill>
-            <a:prstDash val="solid"/>
-            <a:round/>
-          </a:ln>
-        </c:spPr>
-        <c:txPr>
-          <a:bodyPr/>
-          <a:lstStyle/>
-          <a:p>
-            <a:pPr>
-              <a:defRPr sz="1300" b="0" i="0" u="none" strike="noStrike">
-                <a:solidFill>
-                  <a:srgbClr val="262626"/>
-                </a:solidFill>
-                <a:latin typeface="Calibri"/>
-              </a:defRPr>
-            </a:pPr>
-            <a:endParaRPr lang="en-US"/>
-          </a:p>
-        </c:txPr>
-        <c:crossAx val="2094734552"/>
-        <c:crosses val="autoZero"/>
-        <c:auto val="1"/>
-        <c:lblAlgn val="ctr"/>
-        <c:noMultiLvlLbl val="1"/>
-      </c:catAx>
-      <c:valAx>
-        <c:axId val="2094734552"/>
-        <c:scaling>
-          <c:orientation val="minMax"/>
-        </c:scaling>
-        <c:delete val="0"/>
-        <c:axPos val="l"/>
-        <c:majorGridlines>
-          <c:spPr>
-            <a:ln w="6350" cap="flat">
-              <a:solidFill>
-                <a:srgbClr val="E5E5E5"/>
-              </a:solidFill>
-              <a:prstDash val="solid"/>
-              <a:round/>
-            </a:ln>
-          </c:spPr>
-        </c:majorGridlines>
-        <c:numFmt formatCode="&quot;$&quot;#,##0,&quot;K&quot;" sourceLinked="0"/>
-        <c:majorTickMark val="out"/>
-        <c:minorTickMark val="none"/>
-        <c:tickLblPos val="nextTo"/>
-        <c:spPr>
-          <a:ln w="12700" cap="flat">
-            <a:solidFill>
-              <a:srgbClr val="888888"/>
-            </a:solidFill>
-            <a:prstDash val="solid"/>
-            <a:round/>
-          </a:ln>
-        </c:spPr>
-        <c:txPr>
-          <a:bodyPr/>
-          <a:lstStyle/>
-          <a:p>
-            <a:pPr>
-              <a:defRPr sz="1200" b="0" i="0" u="none" strike="noStrike">
-                <a:solidFill>
-                  <a:srgbClr val="6B6B6B"/>
-                </a:solidFill>
-                <a:latin typeface="Calibri"/>
-              </a:defRPr>
-            </a:pPr>
-            <a:endParaRPr lang="en-US"/>
-          </a:p>
-        </c:txPr>
-        <c:crossAx val="2094734554"/>
-        <c:crosses val="autoZero"/>
-        <c:crossBetween val="between"/>
-      </c:valAx>
-      <c:spPr>
-        <a:noFill/>
-        <a:ln>
-          <a:noFill/>
-        </a:ln>
-        <a:effectLst/>
-      </c:spPr>
-    </c:plotArea>
-    <c:plotVisOnly val="1"/>
-    <c:dispBlanksAs val="span"/>
-  </c:chart>
-  <c:spPr>
-    <a:solidFill>
-      <a:srgbClr val="FFFFFF"/>
-    </a:solidFill>
-    <a:ln>
-      <a:noFill/>
-    </a:ln>
-    <a:effectLst/>
-  </c:spPr>
-  <c:externalData r:id="rId1">
-    <c:autoUpdate val="0"/>
-  </c:externalData>
-</c:chartSpace>
 </file>
 
 <file path=ppt/notesMasters/notesMaster1.xml><?xml version="1.0" encoding="utf-8"?>
@@ -3157,7 +2322,7 @@
               <a:buNone/>
             </a:pPr>
             <a:r>
-              <a:rPr lang="en-US" sz="1100" i="1" dirty="0">
+              <a:rPr lang="en-US" sz="1300" i="1" dirty="0">
                 <a:solidFill>
                   <a:srgbClr val="244F26"/>
                 </a:solidFill>
@@ -3167,7 +2332,7 @@
               </a:rPr>
               <a:t>Distance vs. large-lot share, sized by sales, colored by price — 98010 &amp; 98014 circled.</a:t>
             </a:r>
-            <a:endParaRPr lang="en-US" sz="1100" dirty="0"/>
+            <a:endParaRPr lang="en-US" sz="1300" dirty="0"/>
           </a:p>
         </p:txBody>
       </p:sp>
@@ -3257,7 +2422,7 @@
               <a:buNone/>
             </a:pPr>
             <a:r>
-              <a:rPr lang="en-US" sz="1200" dirty="0">
+              <a:rPr lang="en-US" sz="1300" dirty="0">
                 <a:solidFill>
                   <a:srgbClr val="FFFFFF"/>
                 </a:solidFill>
@@ -3267,7 +2432,7 @@
               </a:rPr>
               <a:t>from downtown — genuinely rural, not just “outside city limits”</a:t>
             </a:r>
-            <a:endParaRPr lang="en-US" sz="1200" dirty="0"/>
+            <a:endParaRPr lang="en-US" sz="1300" dirty="0"/>
           </a:p>
         </p:txBody>
       </p:sp>
@@ -3357,7 +2522,7 @@
               <a:buNone/>
             </a:pPr>
             <a:r>
-              <a:rPr lang="en-US" sz="1200" dirty="0">
+              <a:rPr lang="en-US" sz="1300" dirty="0">
                 <a:solidFill>
                   <a:srgbClr val="FFFFFF"/>
                 </a:solidFill>
@@ -3367,7 +2532,7 @@
               </a:rPr>
               <a:t>of homes in these zips are large-lot — real country character</a:t>
             </a:r>
-            <a:endParaRPr lang="en-US" sz="1200" dirty="0"/>
+            <a:endParaRPr lang="en-US" sz="1300" dirty="0"/>
           </a:p>
         </p:txBody>
       </p:sp>
@@ -3457,7 +2622,7 @@
               <a:buNone/>
             </a:pPr>
             <a:r>
-              <a:rPr lang="en-US" sz="1200" dirty="0">
+              <a:rPr lang="en-US" sz="1300" dirty="0">
                 <a:solidFill>
                   <a:srgbClr val="FFFFFF"/>
                 </a:solidFill>
@@ -3467,7 +2632,7 @@
               </a:rPr>
               <a:t>median price — well below the county median</a:t>
             </a:r>
-            <a:endParaRPr lang="en-US" sz="1200" dirty="0"/>
+            <a:endParaRPr lang="en-US" sz="1300" dirty="0"/>
           </a:p>
         </p:txBody>
       </p:sp>
@@ -3499,7 +2664,7 @@
               <a:buNone/>
             </a:pPr>
             <a:r>
-              <a:rPr lang="en-US" sz="1150" i="1" dirty="0">
+              <a:rPr lang="en-US" sz="1300" i="1" dirty="0">
                 <a:solidFill>
                   <a:srgbClr val="DCEAD2"/>
                 </a:solidFill>
@@ -3509,7 +2674,7 @@
               </a:rPr>
               <a:t>Lean into non-renovated listings here — they’re the majority of homes and meaningfully cheaper.</a:t>
             </a:r>
-            <a:endParaRPr lang="en-US" sz="1150" dirty="0"/>
+            <a:endParaRPr lang="en-US" sz="1300" dirty="0"/>
           </a:p>
         </p:txBody>
       </p:sp>
@@ -5924,22 +5089,30 @@
           </a:p>
         </p:txBody>
       </p:sp>
-      <p:graphicFrame>
-        <p:nvGraphicFramePr>
-          <p:cNvPr id="4" name="Chart 0" descr=""/>
-          <p:cNvGraphicFramePr/>
-          <p:nvPr/>
-        </p:nvGraphicFramePr>
-        <p:xfrm>
-          <a:off x="822960" y="1874520"/>
-          <a:ext cx="5760720" cy="4023360"/>
-        </p:xfrm>
-        <a:graphic xmlns:a="http://schemas.openxmlformats.org/drawingml/2006/main">
-          <a:graphicData uri="http://schemas.openxmlformats.org/drawingml/2006/chart">
-            <c:chart xmlns:c="http://schemas.openxmlformats.org/drawingml/2006/chart" r:id="rId1"/>
-          </a:graphicData>
-        </a:graphic>
-      </p:graphicFrame>
+      <p:pic>
+        <p:nvPicPr>
+          <p:cNvPr id="4" name="Image 0" descr="chart_location.png">    </p:cNvPr>
+          <p:cNvPicPr>
+            <a:picLocks noChangeAspect="1"/>
+          </p:cNvPicPr>
+          <p:nvPr/>
+        </p:nvPicPr>
+        <p:blipFill>
+          <a:blip r:embed="rId1"/>
+          <a:stretch>
+            <a:fillRect/>
+          </a:stretch>
+        </p:blipFill>
+        <p:spPr>
+          <a:xfrm>
+            <a:off x="822960" y="1874520"/>
+            <a:ext cx="5394960" cy="4023360"/>
+          </a:xfrm>
+          <a:prstGeom prst="rect">
+            <a:avLst/>
+          </a:prstGeom>
+        </p:spPr>
+      </p:pic>
       <p:sp>
         <p:nvSpPr>
           <p:cNvPr id="5" name="Text 2"/>
@@ -6151,22 +5324,30 @@
           </a:p>
         </p:txBody>
       </p:sp>
-      <p:graphicFrame>
-        <p:nvGraphicFramePr>
-          <p:cNvPr id="4" name="Chart 0" descr=""/>
-          <p:cNvGraphicFramePr/>
-          <p:nvPr/>
-        </p:nvGraphicFramePr>
-        <p:xfrm>
-          <a:off x="822960" y="1874520"/>
-          <a:ext cx="5760720" cy="4023360"/>
-        </p:xfrm>
-        <a:graphic xmlns:a="http://schemas.openxmlformats.org/drawingml/2006/main">
-          <a:graphicData uri="http://schemas.openxmlformats.org/drawingml/2006/chart">
-            <c:chart xmlns:c="http://schemas.openxmlformats.org/drawingml/2006/chart" r:id="rId1"/>
-          </a:graphicData>
-        </a:graphic>
-      </p:graphicFrame>
+      <p:pic>
+        <p:nvPicPr>
+          <p:cNvPr id="4" name="Image 0" descr="chart_renovation.png">    </p:cNvPr>
+          <p:cNvPicPr>
+            <a:picLocks noChangeAspect="1"/>
+          </p:cNvPicPr>
+          <p:nvPr/>
+        </p:nvPicPr>
+        <p:blipFill>
+          <a:blip r:embed="rId1"/>
+          <a:stretch>
+            <a:fillRect/>
+          </a:stretch>
+        </p:blipFill>
+        <p:spPr>
+          <a:xfrm>
+            <a:off x="822960" y="1874520"/>
+            <a:ext cx="5394960" cy="4023360"/>
+          </a:xfrm>
+          <a:prstGeom prst="rect">
+            <a:avLst/>
+          </a:prstGeom>
+        </p:spPr>
+      </p:pic>
       <p:sp>
         <p:nvSpPr>
           <p:cNvPr id="5" name="Text 2"/>
@@ -6403,7 +5584,7 @@
               <a:buNone/>
             </a:pPr>
             <a:r>
-              <a:rPr lang="en-US" sz="1200" i="1" dirty="0">
+              <a:rPr lang="en-US" sz="1300" i="1" dirty="0">
                 <a:solidFill>
                   <a:srgbClr val="6B6B6B"/>
                 </a:solidFill>
@@ -6413,26 +5594,34 @@
               </a:rPr>
               <a:t>Country homes specifically — city homes follow a different, later-year pattern.</a:t>
             </a:r>
-            <a:endParaRPr lang="en-US" sz="1200" dirty="0"/>
-          </a:p>
-        </p:txBody>
-      </p:sp>
-      <p:graphicFrame>
-        <p:nvGraphicFramePr>
-          <p:cNvPr id="5" name="Chart 0" descr=""/>
-          <p:cNvGraphicFramePr/>
-          <p:nvPr/>
-        </p:nvGraphicFramePr>
-        <p:xfrm>
-          <a:off x="548640" y="1920240"/>
-          <a:ext cx="11064240" cy="3520440"/>
-        </p:xfrm>
-        <a:graphic xmlns:a="http://schemas.openxmlformats.org/drawingml/2006/main">
-          <a:graphicData uri="http://schemas.openxmlformats.org/drawingml/2006/chart">
-            <c:chart xmlns:c="http://schemas.openxmlformats.org/drawingml/2006/chart" r:id="rId1"/>
-          </a:graphicData>
-        </a:graphic>
-      </p:graphicFrame>
+            <a:endParaRPr lang="en-US" sz="1300" dirty="0"/>
+          </a:p>
+        </p:txBody>
+      </p:sp>
+      <p:pic>
+        <p:nvPicPr>
+          <p:cNvPr id="5" name="Image 0" descr="chart_timing.png">    </p:cNvPr>
+          <p:cNvPicPr>
+            <a:picLocks noChangeAspect="1"/>
+          </p:cNvPicPr>
+          <p:nvPr/>
+        </p:nvPicPr>
+        <p:blipFill>
+          <a:blip r:embed="rId1"/>
+          <a:stretch>
+            <a:fillRect/>
+          </a:stretch>
+        </p:blipFill>
+        <p:spPr>
+          <a:xfrm>
+            <a:off x="1069848" y="1783080"/>
+            <a:ext cx="10058400" cy="3675888"/>
+          </a:xfrm>
+          <a:prstGeom prst="rect">
+            <a:avLst/>
+          </a:prstGeom>
+        </p:spPr>
+      </p:pic>
       <p:sp>
         <p:nvSpPr>
           <p:cNvPr id="6" name="Text 3"/>
@@ -6873,7 +6062,7 @@
               <a:buNone/>
             </a:pPr>
             <a:r>
-              <a:rPr lang="en-US" sz="1100" i="1" dirty="0">
+              <a:rPr lang="en-US" sz="1300" i="1" dirty="0">
                 <a:solidFill>
                   <a:srgbClr val="1A6D85"/>
                 </a:solidFill>
@@ -6883,7 +6072,7 @@
               </a:rPr>
               <a:t>Distance vs. large-lot share, sized by sales, colored by price — 98118 circled.</a:t>
             </a:r>
-            <a:endParaRPr lang="en-US" sz="1100" dirty="0"/>
+            <a:endParaRPr lang="en-US" sz="1300" dirty="0"/>
           </a:p>
         </p:txBody>
       </p:sp>
@@ -6973,7 +6162,7 @@
               <a:buNone/>
             </a:pPr>
             <a:r>
-              <a:rPr lang="en-US" sz="1200" dirty="0">
+              <a:rPr lang="en-US" sz="1300" dirty="0">
                 <a:solidFill>
                   <a:srgbClr val="FFFFFF"/>
                 </a:solidFill>
@@ -6983,7 +6172,7 @@
               </a:rPr>
               <a:t>from downtown Seattle — the closest of the high-turnover zips</a:t>
             </a:r>
-            <a:endParaRPr lang="en-US" sz="1200" dirty="0"/>
+            <a:endParaRPr lang="en-US" sz="1300" dirty="0"/>
           </a:p>
         </p:txBody>
       </p:sp>
@@ -7073,7 +6262,7 @@
               <a:buNone/>
             </a:pPr>
             <a:r>
-              <a:rPr lang="en-US" sz="1200" dirty="0">
+              <a:rPr lang="en-US" sz="1300" dirty="0">
                 <a:solidFill>
                   <a:srgbClr val="FFFFFF"/>
                 </a:solidFill>
@@ -7083,7 +6272,7 @@
               </a:rPr>
               <a:t>in the 12-month window — highest turnover among affordable central zips</a:t>
             </a:r>
-            <a:endParaRPr lang="en-US" sz="1200" dirty="0"/>
+            <a:endParaRPr lang="en-US" sz="1300" dirty="0"/>
           </a:p>
         </p:txBody>
       </p:sp>
@@ -7173,7 +6362,7 @@
               <a:buNone/>
             </a:pPr>
             <a:r>
-              <a:rPr lang="en-US" sz="1200" dirty="0">
+              <a:rPr lang="en-US" sz="1300" dirty="0">
                 <a:solidFill>
                   <a:srgbClr val="FFFFFF"/>
                 </a:solidFill>
@@ -7183,7 +6372,7 @@
               </a:rPr>
               <a:t>median price — the most affordable of that group</a:t>
             </a:r>
-            <a:endParaRPr lang="en-US" sz="1200" dirty="0"/>
+            <a:endParaRPr lang="en-US" sz="1300" dirty="0"/>
           </a:p>
         </p:txBody>
       </p:sp>
@@ -7215,9 +6404,9 @@
               <a:buNone/>
             </a:pPr>
             <a:r>
-              <a:rPr lang="en-US" sz="1150" i="1" dirty="0">
-                <a:solidFill>
-                  <a:srgbClr val="CADCFC"/>
+              <a:rPr lang="en-US" sz="1300" i="1" dirty="0">
+                <a:solidFill>
+                  <a:srgbClr val="FFFFFF"/>
                 </a:solidFill>
                 <a:latin typeface="Calibri" pitchFamily="34" charset="0"/>
                 <a:ea typeface="Calibri" pitchFamily="34" charset="-122"/>
@@ -7225,7 +6414,7 @@
               </a:rPr>
               <a:t>98103, 98115, and 98117 are strong second choices. Filter to 1–3 bedrooms — plenty for a household of 2, avoiding a ~41% size premium.</a:t>
             </a:r>
-            <a:endParaRPr lang="en-US" sz="1150" dirty="0"/>
+            <a:endParaRPr lang="en-US" sz="1300" dirty="0"/>
           </a:p>
         </p:txBody>
       </p:sp>

</xml_diff>

<commit_message>
Deck round 3: fix slide 8 takeaway color to match its green chart, Final Recommendations now answers Hypothesis 3 for both city and country timing
</commit_message>
<xml_diff>
--- a/presentation.pptx
+++ b/presentation.pptx
@@ -2796,7 +2796,7 @@
         </p:nvSpPr>
         <p:spPr>
           <a:xfrm>
-            <a:off x="822960" y="1828800"/>
+            <a:off x="822960" y="1783080"/>
             <a:ext cx="914400" cy="914400"/>
           </a:xfrm>
           <a:prstGeom prst="ellipse">
@@ -2824,7 +2824,7 @@
         </p:blipFill>
         <p:spPr>
           <a:xfrm>
-            <a:off x="1060704" y="2066544"/>
+            <a:off x="1060704" y="2020824"/>
             <a:ext cx="438912" cy="438912"/>
           </a:xfrm>
           <a:prstGeom prst="rect">
@@ -2840,7 +2840,7 @@
         </p:nvSpPr>
         <p:spPr>
           <a:xfrm>
-            <a:off x="2011680" y="1783080"/>
+            <a:off x="2011680" y="1737360"/>
             <a:ext cx="2926080" cy="914400"/>
           </a:xfrm>
           <a:prstGeom prst="rect">
@@ -2879,8 +2879,8 @@
         </p:nvSpPr>
         <p:spPr>
           <a:xfrm>
-            <a:off x="4846320" y="1783080"/>
-            <a:ext cx="6675120" cy="1005840"/>
+            <a:off x="4846320" y="1709928"/>
+            <a:ext cx="6675120" cy="1508760"/>
           </a:xfrm>
           <a:prstGeom prst="rect">
             <a:avLst/>
@@ -2899,7 +2899,7 @@
               <a:buNone/>
             </a:pPr>
             <a:r>
-              <a:rPr lang="en-US" sz="1500" dirty="0">
+              <a:rPr lang="en-US" sz="1400" dirty="0">
                 <a:solidFill>
                   <a:srgbClr val="CADCFC"/>
                 </a:solidFill>
@@ -2909,7 +2909,7 @@
               </a:rPr>
               <a:t>Target zip 98118 — closest high-turnover, affordable zip to downtown. Filter to 1–3 bedrooms.</a:t>
             </a:r>
-            <a:endParaRPr lang="en-US" sz="1500" dirty="0"/>
+            <a:endParaRPr lang="en-US" sz="1400" dirty="0"/>
           </a:p>
         </p:txBody>
       </p:sp>
@@ -2921,7 +2921,7 @@
         </p:nvSpPr>
         <p:spPr>
           <a:xfrm>
-            <a:off x="822960" y="3246120"/>
+            <a:off x="822960" y="3355848"/>
             <a:ext cx="914400" cy="914400"/>
           </a:xfrm>
           <a:prstGeom prst="ellipse">
@@ -2949,7 +2949,7 @@
         </p:blipFill>
         <p:spPr>
           <a:xfrm>
-            <a:off x="1060704" y="3483864"/>
+            <a:off x="1060704" y="3593592"/>
             <a:ext cx="438912" cy="438912"/>
           </a:xfrm>
           <a:prstGeom prst="rect">
@@ -2965,7 +2965,7 @@
         </p:nvSpPr>
         <p:spPr>
           <a:xfrm>
-            <a:off x="2011680" y="3200400"/>
+            <a:off x="2011680" y="3310128"/>
             <a:ext cx="2926080" cy="914400"/>
           </a:xfrm>
           <a:prstGeom prst="rect">
@@ -3004,8 +3004,8 @@
         </p:nvSpPr>
         <p:spPr>
           <a:xfrm>
-            <a:off x="4846320" y="3200400"/>
-            <a:ext cx="6675120" cy="1005840"/>
+            <a:off x="4846320" y="3282696"/>
+            <a:ext cx="6675120" cy="1508760"/>
           </a:xfrm>
           <a:prstGeom prst="rect">
             <a:avLst/>
@@ -3024,7 +3024,7 @@
               <a:buNone/>
             </a:pPr>
             <a:r>
-              <a:rPr lang="en-US" sz="1500" dirty="0">
+              <a:rPr lang="en-US" sz="1400" dirty="0">
                 <a:solidFill>
                   <a:srgbClr val="CADCFC"/>
                 </a:solidFill>
@@ -3034,7 +3034,7 @@
               </a:rPr>
               <a:t>Target zip 98010 or 98014 — genuinely rural and affordable. Lean into non-renovated listings.</a:t>
             </a:r>
-            <a:endParaRPr lang="en-US" sz="1500" dirty="0"/>
+            <a:endParaRPr lang="en-US" sz="1400" dirty="0"/>
           </a:p>
         </p:txBody>
       </p:sp>
@@ -3046,7 +3046,7 @@
         </p:nvSpPr>
         <p:spPr>
           <a:xfrm>
-            <a:off x="822960" y="4663440"/>
+            <a:off x="822960" y="4928616"/>
             <a:ext cx="914400" cy="914400"/>
           </a:xfrm>
           <a:prstGeom prst="ellipse">
@@ -3074,7 +3074,7 @@
         </p:blipFill>
         <p:spPr>
           <a:xfrm>
-            <a:off x="1060704" y="4901184"/>
+            <a:off x="1060704" y="5166360"/>
             <a:ext cx="438912" cy="438912"/>
           </a:xfrm>
           <a:prstGeom prst="rect">
@@ -3090,7 +3090,7 @@
         </p:nvSpPr>
         <p:spPr>
           <a:xfrm>
-            <a:off x="2011680" y="4617720"/>
+            <a:off x="2011680" y="4882896"/>
             <a:ext cx="2926080" cy="914400"/>
           </a:xfrm>
           <a:prstGeom prst="rect">
@@ -3129,8 +3129,8 @@
         </p:nvSpPr>
         <p:spPr>
           <a:xfrm>
-            <a:off x="4846320" y="4617720"/>
-            <a:ext cx="6675120" cy="1005840"/>
+            <a:off x="4846320" y="4855464"/>
+            <a:ext cx="6675120" cy="1508760"/>
           </a:xfrm>
           <a:prstGeom prst="rect">
             <a:avLst/>
@@ -3149,7 +3149,7 @@
               <a:buNone/>
             </a:pPr>
             <a:r>
-              <a:rPr lang="en-US" sz="1500" dirty="0">
+              <a:rPr lang="en-US" sz="1400" dirty="0">
                 <a:solidFill>
                   <a:srgbClr val="CADCFC"/>
                 </a:solidFill>
@@ -3157,9 +3157,9 @@
                 <a:ea typeface="Calibri" pitchFamily="34" charset="-122"/>
                 <a:cs typeface="Calibri" pitchFamily="34" charset="-120"/>
               </a:rPr>
-              <a:t>Close in August for the lowest country-home price ($493,725), or May for ~18% more inventory at only a ~9% premium.</a:t>
-            </a:r>
-            <a:endParaRPr lang="en-US" sz="1500" dirty="0"/>
+              <a:t>Country home: close in August for the lowest price ($493,725), or May for ~18% more inventory at only a ~9% premium. City home: timing matters less since speed comes first, but November is the cheapest month ($537,500) if there's flexibility — the two searches don't share one seasonal pattern.</a:t>
+            </a:r>
+            <a:endParaRPr lang="en-US" sz="1400" dirty="0"/>
           </a:p>
         </p:txBody>
       </p:sp>
@@ -5530,7 +5530,7 @@
             <a:r>
               <a:rPr lang="en-US" sz="1600" b="1" dirty="0">
                 <a:solidFill>
-                  <a:srgbClr val="1E2761"/>
+                  <a:srgbClr val="2C5F2D"/>
                 </a:solidFill>
                 <a:latin typeface="Calibri" pitchFamily="34" charset="0"/>
                 <a:ea typeface="Calibri" pitchFamily="34" charset="-122"/>
@@ -5547,7 +5547,7 @@
             <a:r>
               <a:rPr lang="en-US" sz="1600" dirty="0">
                 <a:solidFill>
-                  <a:srgbClr val="1E2761"/>
+                  <a:srgbClr val="2C5F2D"/>
                 </a:solidFill>
                 <a:latin typeface="Calibri" pitchFamily="34" charset="0"/>
                 <a:ea typeface="Calibri" pitchFamily="34" charset="-122"/>

</xml_diff>

<commit_message>
Apply user's manual color/text edits back to source: unify takeaway text to charcoal (no bold BOTTOM LINE prefix), King County stat navy not green, slide 8 May stat teal not green, shorten slide 7 title
</commit_message>
<xml_diff>
--- a/presentation.pptx
+++ b/presentation.pptx
@@ -2220,23 +2220,6 @@
               <a:buNone/>
             </a:pPr>
             <a:r>
-              <a:rPr lang="en-US" sz="1600" b="1" dirty="0">
-                <a:solidFill>
-                  <a:srgbClr val="FFFFFF"/>
-                </a:solidFill>
-                <a:latin typeface="Calibri" pitchFamily="34" charset="0"/>
-                <a:ea typeface="Calibri" pitchFamily="34" charset="-122"/>
-                <a:cs typeface="Calibri" pitchFamily="34" charset="-120"/>
-              </a:rPr>
-              <a:t>BOTTOM LINE:  </a:t>
-            </a:r>
-            <a:pPr indent="0" marL="0">
-              <a:lnSpc>
-                <a:spcPct val="105000"/>
-              </a:lnSpc>
-              <a:buNone/>
-            </a:pPr>
-            <a:r>
               <a:rPr lang="en-US" sz="1600" dirty="0">
                 <a:solidFill>
                   <a:srgbClr val="FFFFFF"/>
@@ -4429,7 +4412,7 @@
             <a:r>
               <a:rPr lang="en-US" sz="4000" b="1" dirty="0">
                 <a:solidFill>
-                  <a:srgbClr val="2C5F2D"/>
+                  <a:srgbClr val="1E2761"/>
                 </a:solidFill>
                 <a:latin typeface="Cambria" pitchFamily="34" charset="0"/>
                 <a:ea typeface="Cambria" pitchFamily="34" charset="-122"/>
@@ -5058,32 +5041,15 @@
               <a:buNone/>
             </a:pPr>
             <a:r>
-              <a:rPr lang="en-US" sz="1600" b="1" dirty="0">
-                <a:solidFill>
-                  <a:srgbClr val="1C7293"/>
+              <a:rPr lang="en-US" sz="1600" dirty="0">
+                <a:solidFill>
+                  <a:srgbClr val="262626"/>
                 </a:solidFill>
                 <a:latin typeface="Calibri" pitchFamily="34" charset="0"/>
                 <a:ea typeface="Calibri" pitchFamily="34" charset="-122"/>
                 <a:cs typeface="Calibri" pitchFamily="34" charset="-120"/>
               </a:rPr>
-              <a:t>BOTTOM LINE:  </a:t>
-            </a:r>
-            <a:pPr indent="0" marL="0">
-              <a:lnSpc>
-                <a:spcPct val="105000"/>
-              </a:lnSpc>
-              <a:buNone/>
-            </a:pPr>
-            <a:r>
-              <a:rPr lang="en-US" sz="1600" dirty="0">
-                <a:solidFill>
-                  <a:srgbClr val="1C7293"/>
-                </a:solidFill>
-                <a:latin typeface="Calibri" pitchFamily="34" charset="0"/>
-                <a:ea typeface="Calibri" pitchFamily="34" charset="-122"/>
-                <a:cs typeface="Calibri" pitchFamily="34" charset="-120"/>
-              </a:rPr>
-              <a:t>a home within ~6 miles of downtown Seattle costs about 57% more per square foot than one farther out.</a:t>
+              <a:t>A home within ~6 miles of downtown Seattle costs about 57% more per square foot than one farther out.</a:t>
             </a:r>
             <a:endParaRPr lang="en-US" sz="1600" dirty="0"/>
           </a:p>
@@ -5259,7 +5225,7 @@
                 <a:ea typeface="Cambria" pitchFamily="34" charset="-122"/>
                 <a:cs typeface="Cambria" pitchFamily="34" charset="-120"/>
               </a:rPr>
-              <a:t>Non-Renovated Homes Cost Less — By Design</a:t>
+              <a:t>Non-Renovated Homes Cost Less</a:t>
             </a:r>
             <a:endParaRPr lang="en-US" sz="2700" dirty="0"/>
           </a:p>
@@ -5293,32 +5259,15 @@
               <a:buNone/>
             </a:pPr>
             <a:r>
-              <a:rPr lang="en-US" sz="1600" b="1" dirty="0">
-                <a:solidFill>
-                  <a:srgbClr val="2C5F2D"/>
+              <a:rPr lang="en-US" sz="1600" dirty="0">
+                <a:solidFill>
+                  <a:srgbClr val="262626"/>
                 </a:solidFill>
                 <a:latin typeface="Calibri" pitchFamily="34" charset="0"/>
                 <a:ea typeface="Calibri" pitchFamily="34" charset="-122"/>
                 <a:cs typeface="Calibri" pitchFamily="34" charset="-120"/>
               </a:rPr>
-              <a:t>BOTTOM LINE:  </a:t>
-            </a:r>
-            <a:pPr indent="0" marL="0">
-              <a:lnSpc>
-                <a:spcPct val="105000"/>
-              </a:lnSpc>
-              <a:buNone/>
-            </a:pPr>
-            <a:r>
-              <a:rPr lang="en-US" sz="1600" dirty="0">
-                <a:solidFill>
-                  <a:srgbClr val="2C5F2D"/>
-                </a:solidFill>
-                <a:latin typeface="Calibri" pitchFamily="34" charset="0"/>
-                <a:ea typeface="Calibri" pitchFamily="34" charset="-122"/>
-                <a:cs typeface="Calibri" pitchFamily="34" charset="-120"/>
-              </a:rPr>
-              <a:t>non-renovated homes are both the norm (97% of listings) and the cheaper option — a ~34% savings among large-lot homes.</a:t>
+              <a:t>Non-renovated homes are both the norm (97% of listings) and the cheaper option — a ~34% savings among large-lot homes.</a:t>
             </a:r>
             <a:endParaRPr lang="en-US" sz="1600" dirty="0"/>
           </a:p>
@@ -5528,32 +5477,15 @@
               <a:buNone/>
             </a:pPr>
             <a:r>
-              <a:rPr lang="en-US" sz="1600" b="1" dirty="0">
-                <a:solidFill>
-                  <a:srgbClr val="2C5F2D"/>
+              <a:rPr lang="en-US" sz="1600" dirty="0">
+                <a:solidFill>
+                  <a:srgbClr val="262626"/>
                 </a:solidFill>
                 <a:latin typeface="Calibri" pitchFamily="34" charset="0"/>
                 <a:ea typeface="Calibri" pitchFamily="34" charset="-122"/>
                 <a:cs typeface="Calibri" pitchFamily="34" charset="-120"/>
               </a:rPr>
-              <a:t>BOTTOM LINE:  </a:t>
-            </a:r>
-            <a:pPr indent="0" marL="0">
-              <a:lnSpc>
-                <a:spcPct val="105000"/>
-              </a:lnSpc>
-              <a:buNone/>
-            </a:pPr>
-            <a:r>
-              <a:rPr lang="en-US" sz="1600" dirty="0">
-                <a:solidFill>
-                  <a:srgbClr val="2C5F2D"/>
-                </a:solidFill>
-                <a:latin typeface="Calibri" pitchFamily="34" charset="0"/>
-                <a:ea typeface="Calibri" pitchFamily="34" charset="-122"/>
-                <a:cs typeface="Calibri" pitchFamily="34" charset="-120"/>
-              </a:rPr>
-              <a:t>for country homes, August is the cheapest month to close (median $493,725) — worth timing around if savings matter most.</a:t>
+              <a:t>For country homes, August is the cheapest month to close (median $493,725) — worth timing around if savings matter most.</a:t>
             </a:r>
             <a:endParaRPr lang="en-US" sz="1600" dirty="0"/>
           </a:p>
@@ -5727,7 +5659,7 @@
             <a:r>
               <a:rPr lang="en-US" sz="4000" b="1" dirty="0">
                 <a:solidFill>
-                  <a:srgbClr val="2C5F2D"/>
+                  <a:srgbClr val="1C7293"/>
                 </a:solidFill>
                 <a:latin typeface="Cambria" pitchFamily="34" charset="0"/>
                 <a:ea typeface="Cambria" pitchFamily="34" charset="-122"/>
@@ -5953,23 +5885,6 @@
           <a:bodyPr wrap="square" lIns="0" tIns="0" rIns="0" bIns="0" rtlCol="0" anchor="ctr"/>
           <a:lstStyle/>
           <a:p>
-            <a:pPr indent="0" marL="0">
-              <a:lnSpc>
-                <a:spcPct val="105000"/>
-              </a:lnSpc>
-              <a:buNone/>
-            </a:pPr>
-            <a:r>
-              <a:rPr lang="en-US" sz="1600" b="1" dirty="0">
-                <a:solidFill>
-                  <a:srgbClr val="FFFFFF"/>
-                </a:solidFill>
-                <a:latin typeface="Calibri" pitchFamily="34" charset="0"/>
-                <a:ea typeface="Calibri" pitchFamily="34" charset="-122"/>
-                <a:cs typeface="Calibri" pitchFamily="34" charset="-120"/>
-              </a:rPr>
-              <a:t>BOTTOM LINE:  </a:t>
-            </a:r>
             <a:pPr indent="0" marL="0">
               <a:lnSpc>
                 <a:spcPct val="105000"/>

</xml_diff>

<commit_message>
Sync presentation.pptx/.pdf to the reviewed Google Slides version: fix slide 2 grammar, slide 6 speaker-note typo (also caught a real $345->$346 data error), slide 10 unsupported "move-in-ready" claim, and sync remaining wording to match
</commit_message>
<xml_diff>
--- a/presentation.pptx
+++ b/presentation.pptx
@@ -601,7 +601,7 @@
           <a:p>
             <a:r>
               <a:rPr lang="en-US" dirty="0"/>
-              <a:t>For the country home, zip codes 98010 and 98014 stand out: genuinely large-lot areas more than 30 kilometers from downtown, where 68 to 85 percent of homes qualify as large-lot versus a 25 percent cutoff countywide, with affordable medians of $360,000 and $415,000. Non-renovated listings are both the norm and the better deal here.</a:t>
+              <a:t>For the country home, zip codes 98010 and 98014 stand out as large-lot areas at 30+ kilometers from downtown, where 68 to 85 percent of homes qualify as large-lot versus a 25 percent countywide, and affordable medians of $360,000 and $415,000. Non-renovated listings are both the norm and the better deal here.</a:t>
             </a:r>
             <a:endParaRPr lang="en-US" dirty="0"/>
           </a:p>
@@ -689,7 +689,7 @@
           <a:p>
             <a:r>
               <a:rPr lang="en-US" dirty="0"/>
-              <a:t>To recap: city home in zip 98118 filtered to 1-3 bedrooms, country home in zip 98010 or 98014 leaning non-renovated, and if timing matters for the country search, August for the lowest price or May for more inventory at a small premium.</a:t>
+              <a:t>Final recommendations: a 1-3 bedroom city home in zip 98118, and a non-renovated country home in zip 98010 or 98014. If timing matters for the country search, August for the lowest price or May for more inventory at a small premium.</a:t>
             </a:r>
             <a:endParaRPr lang="en-US" dirty="0"/>
           </a:p>
@@ -865,7 +865,7 @@
           <a:p>
             <a:r>
               <a:rPr lang="en-US" dirty="0"/>
-              <a:t>William Rodriguez is buying two properties at once: a country home where timing and a willingness to skip renovated listings are priorities, and a city home where speed and centrality matter most. Everything in this deck is built to serve those two, sometimes opposite, goals.</a:t>
+              <a:t>William Rodriguez is buying two properties: For the country home, timing is the priority — he wants to buy at the best possible time, and prefers non-renovated properties. For the city home, the priority is a centrally located zip code where homes turn over often, giving him a faster, more realistic search.</a:t>
             </a:r>
             <a:endParaRPr lang="en-US" dirty="0"/>
           </a:p>
@@ -953,7 +953,7 @@
           <a:p>
             <a:r>
               <a:rPr lang="en-US" dirty="0"/>
-              <a:t>This is the business question behind the whole analysis: what actually drives home prices in King County. We break it into three specific, testable hypotheses next, then answer each one for William's two searches specifically.</a:t>
+              <a:t>The business question behind the analysis: what factors influence the price of homes in King County? We break it into three hypotheses. Then answer each one for William's two searches specifically.</a:t>
             </a:r>
             <a:endParaRPr lang="en-US" dirty="0"/>
           </a:p>
@@ -1041,7 +1041,7 @@
           <a:p>
             <a:r>
               <a:rPr lang="en-US" dirty="0"/>
-              <a:t>We're working with a full year of King County home sales, just over 21,500 transactions, joined to the county's property detail records so we know size, condition, location, and renovation history for every sale.</a:t>
+              <a:t>We're working with a full year of King County home sales, just over 21,500 transactions, joined to the county's property detail records so we know the size, condition, location, and renovation history for every sale.</a:t>
             </a:r>
             <a:endParaRPr lang="en-US" dirty="0"/>
           </a:p>
@@ -1129,7 +1129,7 @@
           <a:p>
             <a:r>
               <a:rPr lang="en-US" dirty="0"/>
-              <a:t>Three research questions guided the analysis: does where a home sits drive its price, does renovation status change what buyers pay, and is there a seasonal pattern that points to a better or worse time to buy.</a:t>
+              <a:t>Three research questions guided the analysis: does a home's location drive its price, does renovation status change what buyers pay, and is there a seasonal pattern that points to a better or worse time to buy?</a:t>
             </a:r>
             <a:endParaRPr lang="en-US" dirty="0"/>
           </a:p>
@@ -1217,7 +1217,7 @@
           <a:p>
             <a:r>
               <a:rPr lang="en-US" dirty="0"/>
-              <a:t>Homes in the closest quarter of the market to downtown Seattle sell for a median $345 per square foot, versus $220 for the rest of the county — a 57 percent premium. Large-lot homes don't sell for less in total, but they are cheaper per square foot, since more of the price is land rather than house.</a:t>
+              <a:t>Homes in the closest quarter of the market to downtown Seattle sell for a median of $346 per square foot, versus $220 for the rest of the county — with a 57 percent premium. Large-lot homes don't sell for less in total, but they are cheaper per square foot, since more of the price is for land rather than house.</a:t>
             </a:r>
             <a:endParaRPr lang="en-US" dirty="0"/>
           </a:p>
@@ -1305,7 +1305,7 @@
           <a:p>
             <a:r>
               <a:rPr lang="en-US" dirty="0"/>
-              <a:t>Among large-lot properties, renovated homes have a median price of $712,500 versus $530,000 for non-renovated ones, a 34 percent premium. Ninety-seven percent of homes countywide have no renovation on record, so non-renovated is both the typical listing and the cheaper one — good news given the client's preference.</a:t>
+              <a:t>Among large-lot properties, renovated homes have a median price of $712,500 versus $530,000 for non-renovated ones, with a 34 percent premium. Ninety-seven percent of homes countywide have no renovation on record, so non-renovated is the typical listing and the cheaper one.</a:t>
             </a:r>
             <a:endParaRPr lang="en-US" dirty="0"/>
           </a:p>
@@ -1393,7 +1393,7 @@
           <a:p>
             <a:r>
               <a:rPr lang="en-US" dirty="0"/>
-              <a:t>For country homes specifically, median price is lowest in August and highest in April, while sales volume is lowest in January and peaks in May. City homes actually follow a different pattern — their median price is lowest in November and highest in March — so the two searches shouldn't be timed the same way. Since timing matters most for the country home, August is the window we recommend targeting.</a:t>
+              <a:t>For country homes, median price is lowest in August and highest in April, while sales volume is lowest in January and peaks in May. City homes follow a different pattern — their median price is lowest in November and highest in March. Since timing matters most for the country home, August is the window we recommend targeting.</a:t>
             </a:r>
             <a:endParaRPr lang="en-US" dirty="0"/>
           </a:p>
@@ -1481,7 +1481,7 @@
           <a:p>
             <a:r>
               <a:rPr lang="en-US" dirty="0"/>
-              <a:t>For the city home, zip code 98118 is the closest high-turnover zip to downtown at 7.9 kilometers, with the most sales activity among affordable central zips — 507 sales in the window — and the lowest median price of that group at $367,500. 98103, 98115, and 98117 are close backups. Worth noting too: since this is a household of 2, sticking to 1 to 3 bedroom listings covers 59 percent of the market and avoids paying a roughly 41 percent premium for bedrooms that won't get used.</a:t>
+              <a:t>For the city home, 98118 stands out as the strongest option near downtown - with the closest high-turnover ZIP code at 7.9 km away. It has the most sales among affordable central ZIP codes (507 during the period), and has the group's lowest median price at $367,500. ZIP codes 98103, 98115, and 98117 are also solid alternatives. For a two-person household, focusing on one- to three-bedroom homes captures 59% of available listings while avoiding an estimated 41% premium for extra bedrooms that are unlikely to be used.</a:t>
             </a:r>
             <a:endParaRPr lang="en-US" dirty="0"/>
           </a:p>
@@ -2228,7 +2228,7 @@
                 <a:ea typeface="Calibri" pitchFamily="34" charset="-122"/>
                 <a:cs typeface="Calibri" pitchFamily="34" charset="-120"/>
               </a:rPr>
-              <a:t>98010 and 98014 are genuinely rural, affordable, and still liquid enough to search — the strongest match for William's timing and non-renovated preference.</a:t>
+              <a:t>98010 and 98014 are genuinely rural, affordable, with enough active listings and sales to suit William's timeline and preference for non-renovated homes.</a:t>
             </a:r>
             <a:endParaRPr lang="en-US" sz="1600" dirty="0"/>
           </a:p>
@@ -3834,7 +3834,7 @@
                 <a:ea typeface="Calibri" pitchFamily="34" charset="-122"/>
                 <a:cs typeface="Calibri" pitchFamily="34" charset="-120"/>
               </a:rPr>
-              <a:t>Open to (actually prefers) non-renovated homes</a:t>
+              <a:t>Prefers non-renovated homes</a:t>
             </a:r>
             <a:endParaRPr lang="en-US" sz="1700" dirty="0"/>
           </a:p>
@@ -4025,7 +4025,7 @@
                 <a:ea typeface="Calibri" pitchFamily="34" charset="-122"/>
                 <a:cs typeface="Calibri" pitchFamily="34" charset="-120"/>
               </a:rPr>
-              <a:t>Every finding and recommendation in this deck traces back to this one question — answered specifically for William's two searches, not the market in general.</a:t>
+              <a:t>Every finding and recommendation in this deck traces back to this one question — answered specifically for William's two searches.</a:t>
             </a:r>
             <a:endParaRPr lang="en-US" sz="1600" dirty="0"/>
           </a:p>
@@ -4606,7 +4606,7 @@
                 <a:ea typeface="Cambria" pitchFamily="34" charset="-122"/>
                 <a:cs typeface="Cambria" pitchFamily="34" charset="-120"/>
               </a:rPr>
-              <a:t>Three Hypotheses We Tested</a:t>
+              <a:t>Three Hypotheses Tested</a:t>
             </a:r>
             <a:endParaRPr lang="en-US" sz="3200" dirty="0"/>
           </a:p>
@@ -5049,7 +5049,7 @@
                 <a:ea typeface="Calibri" pitchFamily="34" charset="-122"/>
                 <a:cs typeface="Calibri" pitchFamily="34" charset="-120"/>
               </a:rPr>
-              <a:t>A home within ~6 miles of downtown Seattle costs about 57% more per square foot than one farther out.</a:t>
+              <a:t>A home within ~6 miles of downtown Seattle costs about 57% more per square foot than homes farther out.</a:t>
             </a:r>
             <a:endParaRPr lang="en-US" sz="1600" dirty="0"/>
           </a:p>

</xml_diff>